<commit_message>
Make ICE Japanese examples and corpus-use explanations natural
</commit_message>
<xml_diff>
--- a/slides/datasets-in-10-minutes-ice.pptx
+++ b/slides/datasets-in-10-minutes-ice.pptx
@@ -50,7 +50,6 @@
     <p:sldId id="298" r:id="rId48"/>
     <p:sldId id="299" r:id="rId49"/>
     <p:sldId id="300" r:id="rId50"/>
-    <p:sldId id="301" r:id="rId51"/>
     <p:sldId id="302" r:id="rId52"/>
     <p:sldId id="303" r:id="rId53"/>
     <p:sldId id="304" r:id="rId54"/>
@@ -7136,11 +7135,11 @@
         <p:spPr>
           <a:xfrm>
             <a:off x="548640" y="1637627"/>
-            <a:ext cx="8046720" cy="902970"/>
+            <a:ext cx="8046720" cy="1055370"/>
           </a:xfrm>
         </p:spPr>
         <p:txBody>
-          <a:bodyPr wrap="square" lIns="0" rIns="0" tIns="0" bIns="0">
+          <a:bodyPr wrap="square" lIns="0" rIns="0" tIns="0" bIns="152400">
             <a:noAutofit/>
           </a:bodyPr>
           <a:lstStyle/>
@@ -7184,11 +7183,11 @@
         <p:spPr>
           <a:xfrm>
             <a:off x="548640" y="2647277"/>
-            <a:ext cx="8046720" cy="989965"/>
+            <a:ext cx="8046720" cy="1142365"/>
           </a:xfrm>
         </p:spPr>
         <p:txBody>
-          <a:bodyPr lIns="0" rIns="0" tIns="0" bIns="0">
+          <a:bodyPr lIns="0" rIns="0" tIns="0" bIns="152400">
             <a:noAutofit/>
           </a:bodyPr>
           <a:lstStyle/>
@@ -7581,8 +7580,8 @@
         </p:nvSpPr>
         <p:spPr>
           <a:xfrm>
-            <a:off x="502920" y="4700016"/>
-            <a:ext cx="8183879" cy="530352"/>
+            <a:off x="502920" y="4699000"/>
+            <a:ext cx="8183879" cy="431800"/>
           </a:xfrm>
           <a:prstGeom prst="rect">
             <a:avLst/>
@@ -7603,7 +7602,7 @@
                 <a:spcPts val="0"/>
               </a:spcBef>
               <a:spcAft>
-                <a:spcPts val="140"/>
+                <a:spcPts val="0"/>
               </a:spcAft>
               <a:buNone/>
               <a:defRPr sz="810" b="0">
@@ -7614,35 +7613,24 @@
               </a:defRPr>
             </a:pPr>
             <a:r>
-              <a:rPr sz="810" b="0" lang="ja-JP" altLang="en-US">
-                <a:solidFill>
-                  <a:srgbClr val="626669"/>
-                </a:solidFill>
-                <a:latin typeface="Noto Sans"/>
-                <a:ea typeface="Noto Sans CJK JP"/>
-                <a:cs typeface="Noto Sans"/>
-              </a:rPr>
-              <a:t>[1] Stanford CRFM, HELM ICEScenario. v0.3.0.</a:t>
-            </a:r>
-            <a:r>
-              <a:rPr sz="810" b="0" lang="ja-JP" altLang="en-US">
-                <a:solidFill>
-                  <a:srgbClr val="626669"/>
-                </a:solidFill>
-                <a:latin typeface="Noto Sans"/>
-                <a:ea typeface="Noto Sans CJK JP"/>
-                <a:cs typeface="Noto Sans"/>
-              </a:rPr>
-              <a:t>  </a:t>
-            </a:r>
-            <a:r>
-              <a:rPr sz="810" b="0" lang="ja-JP" altLang="en-US">
-                <a:solidFill>
-                  <a:srgbClr val="626669"/>
-                </a:solidFill>
-                <a:latin typeface="Noto Sans"/>
-                <a:ea typeface="Noto Sans CJK JP"/>
-                <a:cs typeface="Noto Sans"/>
+              <a:rPr sz="830">
+                <a:latin typeface="Noto Sans CJK JP"/>
+              </a:rPr>
+              <a:t>[1] Stanford CRFM, HELM ICEScenario.</a:t>
+            </a:r>
+          </a:p>
+          <a:p>
+            <a:pPr>
+              <a:spcBef>
+                <a:spcPts val="0"/>
+              </a:spcBef>
+              <a:spcAft>
+                <a:spcPts val="0"/>
+              </a:spcAft>
+            </a:pPr>
+            <a:r>
+              <a:rPr sz="830">
+                <a:latin typeface="Noto Sans CJK JP"/>
                 <a:hlinkClick r:id="rId2"/>
               </a:rPr>
               <a:t>https://github.com/stanford-crfm/helm/blob/v0.3.0/src/helm/benchmark/scenarios/ice_scenario.py</a:t>
@@ -7881,7 +7869,7 @@
         <p:spPr>
           <a:xfrm>
             <a:off x="548640" y="1719072"/>
-            <a:ext cx="3931920" cy="2635226"/>
+            <a:ext cx="3931920" cy="2533626"/>
           </a:xfrm>
           <a:prstGeom prst="rect">
             <a:avLst/>
@@ -7909,7 +7897,7 @@
           </a:fontRef>
         </p:style>
         <p:txBody>
-          <a:bodyPr rtlCol="0" anchor="t" wrap="square" lIns="177800" rIns="177800" tIns="63500" bIns="127000">
+          <a:bodyPr rtlCol="0" anchor="t" wrap="square" lIns="177800" rIns="177800" tIns="42333" bIns="127000">
             <a:noAutofit/>
           </a:bodyPr>
           <a:lstStyle/>
@@ -7955,7 +7943,7 @@
         <p:spPr>
           <a:xfrm>
             <a:off x="4663440" y="1719072"/>
-            <a:ext cx="3931920" cy="2906244"/>
+            <a:ext cx="3931920" cy="2846977"/>
           </a:xfrm>
           <a:prstGeom prst="rect">
             <a:avLst/>
@@ -7983,7 +7971,7 @@
           </a:fontRef>
         </p:style>
         <p:txBody>
-          <a:bodyPr rtlCol="0" anchor="t" wrap="square" lIns="177800" rIns="177800" tIns="63500" bIns="127000">
+          <a:bodyPr rtlCol="0" anchor="t" wrap="square" lIns="177800" rIns="177800" tIns="59266" bIns="127000">
             <a:noAutofit/>
           </a:bodyPr>
           <a:lstStyle/>
@@ -8059,8 +8047,8 @@
         </p:nvSpPr>
         <p:spPr>
           <a:xfrm>
-            <a:off x="502920" y="4700016"/>
-            <a:ext cx="8183879" cy="530352"/>
+            <a:off x="502920" y="4699000"/>
+            <a:ext cx="8183879" cy="431800"/>
           </a:xfrm>
           <a:prstGeom prst="rect">
             <a:avLst/>
@@ -8081,7 +8069,7 @@
                 <a:spcPts val="0"/>
               </a:spcBef>
               <a:spcAft>
-                <a:spcPts val="140"/>
+                <a:spcPts val="0"/>
               </a:spcAft>
               <a:buNone/>
               <a:defRPr sz="810" b="0">
@@ -8092,38 +8080,24 @@
               </a:defRPr>
             </a:pPr>
             <a:r>
-              <a:rPr sz="810" b="0" lang="ja-JP" altLang="en-US">
-                <a:solidFill>
-                  <a:srgbClr val="626669"/>
-                </a:solidFill>
-                <a:latin typeface="Noto Sans"/>
-                <a:ea typeface="Noto Sans CJK JP"/>
-                <a:cs typeface="Noto Sans"/>
-              </a:rPr>
-              <a:t>[1] Stanford CRFM, HELM ICEScenario. v0.3.0. 公開docstringのICE-USA例</a:t>
+              <a:rPr sz="830">
+                <a:latin typeface="Noto Sans CJK JP"/>
+              </a:rPr>
+              <a:t>[1] Stanford CRFM (2023). HELM ICEScenario: ICE-USA example.</a:t>
             </a:r>
           </a:p>
           <a:p>
             <a:pPr>
-              <a:lnSpc>
-                <a:spcPts val="940"/>
-              </a:lnSpc>
-              <a:buNone/>
-              <a:defRPr sz="810" b="0">
-                <a:solidFill>
-                  <a:srgbClr val="303437"/>
-                </a:solidFill>
-                <a:latin typeface="Noto Sans"/>
-              </a:defRPr>
-            </a:pPr>
-            <a:r>
-              <a:rPr sz="810" b="0" lang="ja-JP" altLang="en-US">
-                <a:solidFill>
-                  <a:srgbClr val="626669"/>
-                </a:solidFill>
-                <a:latin typeface="Noto Sans"/>
-                <a:ea typeface="Noto Sans CJK JP"/>
-                <a:cs typeface="Noto Sans"/>
+              <a:spcBef>
+                <a:spcPts val="0"/>
+              </a:spcBef>
+              <a:spcAft>
+                <a:spcPts val="0"/>
+              </a:spcAft>
+            </a:pPr>
+            <a:r>
+              <a:rPr sz="830">
+                <a:latin typeface="Noto Sans CJK JP"/>
                 <a:hlinkClick r:id="rId2"/>
               </a:rPr>
               <a:t>https://github.com/stanford-crfm/helm/blob/v0.3.0/src/helm/benchmark/scenarios/ice_scenario.py</a:t>
@@ -8366,8 +8340,8 @@
         </p:nvSpPr>
         <p:spPr>
           <a:xfrm>
-            <a:off x="502920" y="4700016"/>
-            <a:ext cx="8183879" cy="530352"/>
+            <a:off x="502920" y="4508500"/>
+            <a:ext cx="8183879" cy="558800"/>
           </a:xfrm>
           <a:prstGeom prst="rect">
             <a:avLst/>
@@ -8388,7 +8362,7 @@
                 <a:spcPts val="0"/>
               </a:spcBef>
               <a:spcAft>
-                <a:spcPts val="140"/>
+                <a:spcPts val="0"/>
               </a:spcAft>
               <a:buNone/>
               <a:defRPr sz="810" b="0">
@@ -8399,35 +8373,24 @@
               </a:defRPr>
             </a:pPr>
             <a:r>
-              <a:rPr sz="810" b="0" lang="ja-JP" altLang="en-US">
-                <a:solidFill>
-                  <a:srgbClr val="626669"/>
-                </a:solidFill>
-                <a:latin typeface="Noto Sans"/>
-                <a:ea typeface="Noto Sans CJK JP"/>
-                <a:cs typeface="Noto Sans"/>
+              <a:rPr sz="830">
+                <a:latin typeface="Noto Sans CJK JP"/>
               </a:rPr>
               <a:t>[1] International Corpus of English. Design of ICE Corpora.</a:t>
             </a:r>
-            <a:r>
-              <a:rPr sz="810" b="0" lang="ja-JP" altLang="en-US">
-                <a:solidFill>
-                  <a:srgbClr val="626669"/>
-                </a:solidFill>
-                <a:latin typeface="Noto Sans"/>
-                <a:ea typeface="Noto Sans CJK JP"/>
-                <a:cs typeface="Noto Sans"/>
-              </a:rPr>
-              <a:t>  </a:t>
-            </a:r>
-            <a:r>
-              <a:rPr sz="810" b="0" lang="ja-JP" altLang="en-US">
-                <a:solidFill>
-                  <a:srgbClr val="626669"/>
-                </a:solidFill>
-                <a:latin typeface="Noto Sans"/>
-                <a:ea typeface="Noto Sans CJK JP"/>
-                <a:cs typeface="Noto Sans"/>
+          </a:p>
+          <a:p>
+            <a:pPr>
+              <a:spcBef>
+                <a:spcPts val="0"/>
+              </a:spcBef>
+              <a:spcAft>
+                <a:spcPts val="0"/>
+              </a:spcAft>
+            </a:pPr>
+            <a:r>
+              <a:rPr sz="830">
+                <a:latin typeface="Noto Sans CJK JP"/>
                 <a:hlinkClick r:id="rId2"/>
               </a:rPr>
               <a:t>https://www.ice-corpora.uzh.ch/en/design.html</a:t>
@@ -8435,50 +8398,32 @@
           </a:p>
           <a:p>
             <a:pPr>
-              <a:lnSpc>
-                <a:spcPts val="940"/>
-              </a:lnSpc>
-              <a:spcAft>
-                <a:spcPts val="140"/>
-              </a:spcAft>
-              <a:buNone/>
-              <a:defRPr sz="810" b="0">
-                <a:solidFill>
-                  <a:srgbClr val="303437"/>
-                </a:solidFill>
-                <a:latin typeface="Noto Sans"/>
-              </a:defRPr>
-            </a:pPr>
-            <a:r>
-              <a:rPr sz="810" b="0" lang="ja-JP" altLang="en-US">
-                <a:solidFill>
-                  <a:srgbClr val="626669"/>
-                </a:solidFill>
-                <a:latin typeface="Noto Sans"/>
-                <a:ea typeface="Noto Sans CJK JP"/>
-                <a:cs typeface="Noto Sans"/>
-              </a:rPr>
-              <a:t>[2] HELM Classic v0.4.0, ICE. 公開実行はv0.3.0。</a:t>
-            </a:r>
-            <a:r>
-              <a:rPr sz="810" b="0" lang="ja-JP" altLang="en-US">
-                <a:solidFill>
-                  <a:srgbClr val="626669"/>
-                </a:solidFill>
-                <a:latin typeface="Noto Sans"/>
-                <a:ea typeface="Noto Sans CJK JP"/>
-                <a:cs typeface="Noto Sans"/>
-              </a:rPr>
-              <a:t>  </a:t>
-            </a:r>
-            <a:r>
-              <a:rPr sz="810" b="0" lang="ja-JP" altLang="en-US">
-                <a:solidFill>
-                  <a:srgbClr val="626669"/>
-                </a:solidFill>
-                <a:latin typeface="Noto Sans"/>
-                <a:ea typeface="Noto Sans CJK JP"/>
-                <a:cs typeface="Noto Sans"/>
+              <a:spcBef>
+                <a:spcPts val="0"/>
+              </a:spcBef>
+              <a:spcAft>
+                <a:spcPts val="0"/>
+              </a:spcAft>
+            </a:pPr>
+            <a:r>
+              <a:rPr sz="830">
+                <a:latin typeface="Noto Sans CJK JP"/>
+              </a:rPr>
+              <a:t>[2] HELM Classic v0.4.0, ICE.</a:t>
+            </a:r>
+          </a:p>
+          <a:p>
+            <a:pPr>
+              <a:spcBef>
+                <a:spcPts val="0"/>
+              </a:spcBef>
+              <a:spcAft>
+                <a:spcPts val="0"/>
+              </a:spcAft>
+            </a:pPr>
+            <a:r>
+              <a:rPr sz="830">
+                <a:latin typeface="Noto Sans CJK JP"/>
                 <a:hlinkClick r:id="rId3"/>
               </a:rPr>
               <a:t>https://crfm.stanford.edu/helm/classic/v0.4.0/#/groups/ice</a:t>
@@ -8517,11 +8462,11 @@
         <p:spPr>
           <a:xfrm>
             <a:off x="548640" y="2506875"/>
-            <a:ext cx="8046720" cy="585216"/>
+            <a:ext cx="8046720" cy="737616"/>
           </a:xfrm>
         </p:spPr>
         <p:txBody>
-          <a:bodyPr wrap="square" lIns="0" rIns="0" tIns="0" bIns="0" anchor="ctr">
+          <a:bodyPr wrap="square" lIns="0" rIns="0" tIns="0" bIns="152400" anchor="ctr">
             <a:noAutofit/>
           </a:bodyPr>
           <a:lstStyle/>
@@ -8774,7 +8719,7 @@
                 <a:ea typeface="Noto Sans CJK JP"/>
                 <a:cs typeface="Noto Sans"/>
               </a:rPr>
-              <a:t>テキストの種類と注釈方式を共通化し、地域ごとの収集方法だけが比較を決めないように設計した。</a:t>
+              <a:t>収録ジャンルと注釈方式を共通化し、地域ごとに集めた英語を同じ枠組みで比較できるようにした。</a:t>
             </a:r>
           </a:p>
         </p:txBody>
@@ -8835,8 +8780,8 @@
         </p:nvSpPr>
         <p:spPr>
           <a:xfrm>
-            <a:off x="502920" y="4700016"/>
-            <a:ext cx="8183879" cy="530352"/>
+            <a:off x="502920" y="4699000"/>
+            <a:ext cx="8183879" cy="431800"/>
           </a:xfrm>
           <a:prstGeom prst="rect">
             <a:avLst/>
@@ -8857,7 +8802,7 @@
                 <a:spcPts val="0"/>
               </a:spcBef>
               <a:spcAft>
-                <a:spcPts val="140"/>
+                <a:spcPts val="0"/>
               </a:spcAft>
               <a:buNone/>
               <a:defRPr sz="810" b="0">
@@ -8868,35 +8813,24 @@
               </a:defRPr>
             </a:pPr>
             <a:r>
-              <a:rPr sz="810" b="0" lang="ja-JP" altLang="en-US">
-                <a:solidFill>
-                  <a:srgbClr val="626669"/>
-                </a:solidFill>
-                <a:latin typeface="Noto Sans"/>
-                <a:ea typeface="Noto Sans CJK JP"/>
-                <a:cs typeface="Noto Sans"/>
-              </a:rPr>
-              <a:t>[1] International Corpus of English. University of Zurich. 2026-10-18参照。</a:t>
-            </a:r>
-            <a:r>
-              <a:rPr sz="810" b="0" lang="ja-JP" altLang="en-US">
-                <a:solidFill>
-                  <a:srgbClr val="626669"/>
-                </a:solidFill>
-                <a:latin typeface="Noto Sans"/>
-                <a:ea typeface="Noto Sans CJK JP"/>
-                <a:cs typeface="Noto Sans"/>
-              </a:rPr>
-              <a:t>  </a:t>
-            </a:r>
-            <a:r>
-              <a:rPr sz="810" b="0" lang="ja-JP" altLang="en-US">
-                <a:solidFill>
-                  <a:srgbClr val="626669"/>
-                </a:solidFill>
-                <a:latin typeface="Noto Sans"/>
-                <a:ea typeface="Noto Sans CJK JP"/>
-                <a:cs typeface="Noto Sans"/>
+              <a:rPr sz="830">
+                <a:latin typeface="Noto Sans CJK JP"/>
+              </a:rPr>
+              <a:t>[1] International Corpus of English. University of Zurich.</a:t>
+            </a:r>
+          </a:p>
+          <a:p>
+            <a:pPr>
+              <a:spcBef>
+                <a:spcPts val="0"/>
+              </a:spcBef>
+              <a:spcAft>
+                <a:spcPts val="0"/>
+              </a:spcAft>
+            </a:pPr>
+            <a:r>
+              <a:rPr sz="830">
+                <a:latin typeface="Noto Sans CJK JP"/>
                 <a:hlinkClick r:id="rId2"/>
               </a:rPr>
               <a:t>https://www.ice-corpora.uzh.ch/en.html</a:t>
@@ -9901,8 +9835,8 @@
         </p:nvSpPr>
         <p:spPr>
           <a:xfrm>
-            <a:off x="502920" y="4700016"/>
-            <a:ext cx="8183879" cy="530352"/>
+            <a:off x="502920" y="4699000"/>
+            <a:ext cx="8183879" cy="431800"/>
           </a:xfrm>
           <a:prstGeom prst="rect">
             <a:avLst/>
@@ -9923,7 +9857,7 @@
                 <a:spcPts val="0"/>
               </a:spcBef>
               <a:spcAft>
-                <a:spcPts val="140"/>
+                <a:spcPts val="0"/>
               </a:spcAft>
               <a:buNone/>
               <a:defRPr sz="810" b="0">
@@ -9934,35 +9868,24 @@
               </a:defRPr>
             </a:pPr>
             <a:r>
-              <a:rPr sz="810" b="0" lang="ja-JP" altLang="en-US">
-                <a:solidFill>
-                  <a:srgbClr val="626669"/>
-                </a:solidFill>
-                <a:latin typeface="Noto Sans"/>
-                <a:ea typeface="Noto Sans CJK JP"/>
-                <a:cs typeface="Noto Sans"/>
+              <a:rPr sz="830">
+                <a:latin typeface="Noto Sans CJK JP"/>
               </a:rPr>
               <a:t>[1] International Corpus of English. Design of ICE Corpora.</a:t>
             </a:r>
-            <a:r>
-              <a:rPr sz="810" b="0" lang="ja-JP" altLang="en-US">
-                <a:solidFill>
-                  <a:srgbClr val="626669"/>
-                </a:solidFill>
-                <a:latin typeface="Noto Sans"/>
-                <a:ea typeface="Noto Sans CJK JP"/>
-                <a:cs typeface="Noto Sans"/>
-              </a:rPr>
-              <a:t>  </a:t>
-            </a:r>
-            <a:r>
-              <a:rPr sz="810" b="0" lang="ja-JP" altLang="en-US">
-                <a:solidFill>
-                  <a:srgbClr val="626669"/>
-                </a:solidFill>
-                <a:latin typeface="Noto Sans"/>
-                <a:ea typeface="Noto Sans CJK JP"/>
-                <a:cs typeface="Noto Sans"/>
+          </a:p>
+          <a:p>
+            <a:pPr>
+              <a:spcBef>
+                <a:spcPts val="0"/>
+              </a:spcBef>
+              <a:spcAft>
+                <a:spcPts val="0"/>
+              </a:spcAft>
+            </a:pPr>
+            <a:r>
+              <a:rPr sz="830">
+                <a:latin typeface="Noto Sans CJK JP"/>
                 <a:hlinkClick r:id="rId2"/>
               </a:rPr>
               <a:t>https://www.ice-corpora.uzh.ch/en/design.html</a:t>
@@ -10205,8 +10128,8 @@
         </p:nvSpPr>
         <p:spPr>
           <a:xfrm>
-            <a:off x="502920" y="4700016"/>
-            <a:ext cx="8183879" cy="530352"/>
+            <a:off x="502920" y="4699000"/>
+            <a:ext cx="8183879" cy="431800"/>
           </a:xfrm>
           <a:prstGeom prst="rect">
             <a:avLst/>
@@ -10227,7 +10150,7 @@
                 <a:spcPts val="0"/>
               </a:spcBef>
               <a:spcAft>
-                <a:spcPts val="140"/>
+                <a:spcPts val="0"/>
               </a:spcAft>
               <a:buNone/>
               <a:defRPr sz="810" b="0">
@@ -10238,35 +10161,24 @@
               </a:defRPr>
             </a:pPr>
             <a:r>
-              <a:rPr sz="810" b="0" lang="ja-JP" altLang="en-US">
-                <a:solidFill>
-                  <a:srgbClr val="626669"/>
-                </a:solidFill>
-                <a:latin typeface="Noto Sans"/>
-                <a:ea typeface="Noto Sans CJK JP"/>
-                <a:cs typeface="Noto Sans"/>
+              <a:rPr sz="830">
+                <a:latin typeface="Noto Sans CJK JP"/>
               </a:rPr>
               <a:t>[1] International Corpus of English. Design of ICE Corpora.</a:t>
             </a:r>
-            <a:r>
-              <a:rPr sz="810" b="0" lang="ja-JP" altLang="en-US">
-                <a:solidFill>
-                  <a:srgbClr val="626669"/>
-                </a:solidFill>
-                <a:latin typeface="Noto Sans"/>
-                <a:ea typeface="Noto Sans CJK JP"/>
-                <a:cs typeface="Noto Sans"/>
-              </a:rPr>
-              <a:t>  </a:t>
-            </a:r>
-            <a:r>
-              <a:rPr sz="810" b="0" lang="ja-JP" altLang="en-US">
-                <a:solidFill>
-                  <a:srgbClr val="626669"/>
-                </a:solidFill>
-                <a:latin typeface="Noto Sans"/>
-                <a:ea typeface="Noto Sans CJK JP"/>
-                <a:cs typeface="Noto Sans"/>
+          </a:p>
+          <a:p>
+            <a:pPr>
+              <a:spcBef>
+                <a:spcPts val="0"/>
+              </a:spcBef>
+              <a:spcAft>
+                <a:spcPts val="0"/>
+              </a:spcAft>
+            </a:pPr>
+            <a:r>
+              <a:rPr sz="830">
+                <a:latin typeface="Noto Sans CJK JP"/>
                 <a:hlinkClick r:id="rId2"/>
               </a:rPr>
               <a:t>https://www.ice-corpora.uzh.ch/en/design.html</a:t>
@@ -10509,8 +10421,8 @@
         </p:nvSpPr>
         <p:spPr>
           <a:xfrm>
-            <a:off x="502920" y="4700016"/>
-            <a:ext cx="8183879" cy="530352"/>
+            <a:off x="502920" y="4699000"/>
+            <a:ext cx="8183879" cy="431800"/>
           </a:xfrm>
           <a:prstGeom prst="rect">
             <a:avLst/>
@@ -10531,7 +10443,7 @@
                 <a:spcPts val="0"/>
               </a:spcBef>
               <a:spcAft>
-                <a:spcPts val="140"/>
+                <a:spcPts val="0"/>
               </a:spcAft>
               <a:buNone/>
               <a:defRPr sz="810" b="0">
@@ -10542,35 +10454,24 @@
               </a:defRPr>
             </a:pPr>
             <a:r>
-              <a:rPr sz="810" b="0" lang="ja-JP" altLang="en-US">
-                <a:solidFill>
-                  <a:srgbClr val="626669"/>
-                </a:solidFill>
-                <a:latin typeface="Noto Sans"/>
-                <a:ea typeface="Noto Sans CJK JP"/>
-                <a:cs typeface="Noto Sans"/>
+              <a:rPr sz="830">
+                <a:latin typeface="Noto Sans CJK JP"/>
               </a:rPr>
               <a:t>[1] International Corpus of English. Annotation.</a:t>
             </a:r>
-            <a:r>
-              <a:rPr sz="810" b="0" lang="ja-JP" altLang="en-US">
-                <a:solidFill>
-                  <a:srgbClr val="626669"/>
-                </a:solidFill>
-                <a:latin typeface="Noto Sans"/>
-                <a:ea typeface="Noto Sans CJK JP"/>
-                <a:cs typeface="Noto Sans"/>
-              </a:rPr>
-              <a:t>  </a:t>
-            </a:r>
-            <a:r>
-              <a:rPr sz="810" b="0" lang="ja-JP" altLang="en-US">
-                <a:solidFill>
-                  <a:srgbClr val="626669"/>
-                </a:solidFill>
-                <a:latin typeface="Noto Sans"/>
-                <a:ea typeface="Noto Sans CJK JP"/>
-                <a:cs typeface="Noto Sans"/>
+          </a:p>
+          <a:p>
+            <a:pPr>
+              <a:spcBef>
+                <a:spcPts val="0"/>
+              </a:spcBef>
+              <a:spcAft>
+                <a:spcPts val="0"/>
+              </a:spcAft>
+            </a:pPr>
+            <a:r>
+              <a:rPr sz="830">
+                <a:latin typeface="Noto Sans CJK JP"/>
                 <a:hlinkClick r:id="rId2"/>
               </a:rPr>
               <a:t>https://www.ice-corpora.uzh.ch/en/annotate.html</a:t>
@@ -10639,7 +10540,7 @@
                 <a:ea typeface="Noto Sans CJK JP"/>
                 <a:cs typeface="Noto Sans"/>
               </a:rPr>
-              <a:t>HELMは注釈の多くを除き、本文を使う</a:t>
+              <a:t>HELMは注釈を整理し、本文を評価する</a:t>
             </a:r>
           </a:p>
         </p:txBody>
@@ -10692,7 +10593,7 @@
                 <a:ea typeface="Noto Sans CJK JP"/>
                 <a:cs typeface="Noto Sans"/>
               </a:rPr>
-              <a:t>シナリオの前処理で見出し・段落・強調などのタグを外す。一部の非コーパス部分や削除部分は内容ごと除く。</a:t>
+              <a:t>前処理では見出し・段落・強調などのタグを外し、コーパスに含めないと指定された部分や削除部分は内容ごと除く。</a:t>
             </a:r>
           </a:p>
           <a:p>
@@ -10722,7 +10623,7 @@
                 <a:ea typeface="Noto Sans CJK JP"/>
                 <a:cs typeface="Noto Sans"/>
               </a:rPr>
-              <a:t>話者記号や、一部の休止記号などは残る。タグをすべて除去した均一な平文ではない。</a:t>
+              <a:t>話者記号や一部の休止記号は残るため、書き起こしの特徴を含むテキストが評価対象になる。</a:t>
             </a:r>
           </a:p>
           <a:p>
@@ -10752,7 +10653,7 @@
                 <a:ea typeface="Noto Sans CJK JP"/>
                 <a:cs typeface="Noto Sans"/>
               </a:rPr>
-              <a:t>文書はtestとして登録し、参照回答の配列は空にする。学習・開発用の質問と正解には分けない。</a:t>
+              <a:t>文書はテスト用の入力として読み込み、本文への確率を評価する。質問に対する参照回答は付いていない。</a:t>
             </a:r>
           </a:p>
         </p:txBody>
@@ -10813,8 +10714,8 @@
         </p:nvSpPr>
         <p:spPr>
           <a:xfrm>
-            <a:off x="502920" y="4700016"/>
-            <a:ext cx="8183879" cy="530352"/>
+            <a:off x="502920" y="4699000"/>
+            <a:ext cx="8183879" cy="431800"/>
           </a:xfrm>
           <a:prstGeom prst="rect">
             <a:avLst/>
@@ -10835,7 +10736,7 @@
                 <a:spcPts val="0"/>
               </a:spcBef>
               <a:spcAft>
-                <a:spcPts val="140"/>
+                <a:spcPts val="0"/>
               </a:spcAft>
               <a:buNone/>
               <a:defRPr sz="810" b="0">
@@ -10846,35 +10747,24 @@
               </a:defRPr>
             </a:pPr>
             <a:r>
-              <a:rPr sz="810" b="0" lang="ja-JP" altLang="en-US">
-                <a:solidFill>
-                  <a:srgbClr val="626669"/>
-                </a:solidFill>
-                <a:latin typeface="Noto Sans"/>
-                <a:ea typeface="Noto Sans CJK JP"/>
-                <a:cs typeface="Noto Sans"/>
-              </a:rPr>
-              <a:t>[1] Stanford CRFM, HELM ICEScenario. v0.3.0.</a:t>
-            </a:r>
-            <a:r>
-              <a:rPr sz="810" b="0" lang="ja-JP" altLang="en-US">
-                <a:solidFill>
-                  <a:srgbClr val="626669"/>
-                </a:solidFill>
-                <a:latin typeface="Noto Sans"/>
-                <a:ea typeface="Noto Sans CJK JP"/>
-                <a:cs typeface="Noto Sans"/>
-              </a:rPr>
-              <a:t>  </a:t>
-            </a:r>
-            <a:r>
-              <a:rPr sz="810" b="0" lang="ja-JP" altLang="en-US">
-                <a:solidFill>
-                  <a:srgbClr val="626669"/>
-                </a:solidFill>
-                <a:latin typeface="Noto Sans"/>
-                <a:ea typeface="Noto Sans CJK JP"/>
-                <a:cs typeface="Noto Sans"/>
+              <a:rPr sz="830">
+                <a:latin typeface="Noto Sans CJK JP"/>
+              </a:rPr>
+              <a:t>[1] Stanford CRFM, HELM ICEScenario.</a:t>
+            </a:r>
+          </a:p>
+          <a:p>
+            <a:pPr>
+              <a:spcBef>
+                <a:spcPts val="0"/>
+              </a:spcBef>
+              <a:spcAft>
+                <a:spcPts val="0"/>
+              </a:spcAft>
+            </a:pPr>
+            <a:r>
+              <a:rPr sz="830">
+                <a:latin typeface="Noto Sans CJK JP"/>
                 <a:hlinkClick r:id="rId2"/>
               </a:rPr>
               <a:t>https://github.com/stanford-crfm/helm/blob/v0.3.0/src/helm/benchmark/scenarios/ice_scenario.py</a:t>
@@ -10913,11 +10803,11 @@
         <p:spPr>
           <a:xfrm>
             <a:off x="548640" y="2506875"/>
-            <a:ext cx="8046720" cy="585216"/>
+            <a:ext cx="8046720" cy="737616"/>
           </a:xfrm>
         </p:spPr>
         <p:txBody>
-          <a:bodyPr wrap="square" lIns="0" rIns="0" tIns="0" bIns="0" anchor="ctr">
+          <a:bodyPr wrap="square" lIns="0" rIns="0" tIns="0" bIns="152400" anchor="ctr">
             <a:noAutofit/>
           </a:bodyPr>
           <a:lstStyle/>
@@ -11142,8 +11032,8 @@
         </p:nvSpPr>
         <p:spPr>
           <a:xfrm>
-            <a:off x="502920" y="4700016"/>
-            <a:ext cx="8183879" cy="530352"/>
+            <a:off x="502920" y="4699000"/>
+            <a:ext cx="8183879" cy="431800"/>
           </a:xfrm>
           <a:prstGeom prst="rect">
             <a:avLst/>
@@ -11164,7 +11054,7 @@
                 <a:spcPts val="0"/>
               </a:spcBef>
               <a:spcAft>
-                <a:spcPts val="140"/>
+                <a:spcPts val="0"/>
               </a:spcAft>
               <a:buNone/>
               <a:defRPr sz="810" b="0">
@@ -11175,35 +11065,24 @@
               </a:defRPr>
             </a:pPr>
             <a:r>
-              <a:rPr sz="810" b="0" lang="ja-JP" altLang="en-US">
-                <a:solidFill>
-                  <a:srgbClr val="626669"/>
-                </a:solidFill>
-                <a:latin typeface="Noto Sans"/>
-                <a:ea typeface="Noto Sans CJK JP"/>
-                <a:cs typeface="Noto Sans"/>
-              </a:rPr>
-              <a:t>[1] International Corpus of English. University of Zurich. 2026-10-18参照。</a:t>
-            </a:r>
-            <a:r>
-              <a:rPr sz="810" b="0" lang="ja-JP" altLang="en-US">
-                <a:solidFill>
-                  <a:srgbClr val="626669"/>
-                </a:solidFill>
-                <a:latin typeface="Noto Sans"/>
-                <a:ea typeface="Noto Sans CJK JP"/>
-                <a:cs typeface="Noto Sans"/>
-              </a:rPr>
-              <a:t>  </a:t>
-            </a:r>
-            <a:r>
-              <a:rPr sz="810" b="0" lang="ja-JP" altLang="en-US">
-                <a:solidFill>
-                  <a:srgbClr val="626669"/>
-                </a:solidFill>
-                <a:latin typeface="Noto Sans"/>
-                <a:ea typeface="Noto Sans CJK JP"/>
-                <a:cs typeface="Noto Sans"/>
+              <a:rPr sz="830">
+                <a:latin typeface="Noto Sans CJK JP"/>
+              </a:rPr>
+              <a:t>[1] International Corpus of English. University of Zurich.</a:t>
+            </a:r>
+          </a:p>
+          <a:p>
+            <a:pPr>
+              <a:spcBef>
+                <a:spcPts val="0"/>
+              </a:spcBef>
+              <a:spcAft>
+                <a:spcPts val="0"/>
+              </a:spcAft>
+            </a:pPr>
+            <a:r>
+              <a:rPr sz="830">
+                <a:latin typeface="Noto Sans CJK JP"/>
                 <a:hlinkClick r:id="rId3"/>
               </a:rPr>
               <a:t>https://www.ice-corpora.uzh.ch/en.html</a:t>
@@ -11446,8 +11325,8 @@
         </p:nvSpPr>
         <p:spPr>
           <a:xfrm>
-            <a:off x="502920" y="4700016"/>
-            <a:ext cx="8183879" cy="530352"/>
+            <a:off x="502920" y="4699000"/>
+            <a:ext cx="8183879" cy="431800"/>
           </a:xfrm>
           <a:prstGeom prst="rect">
             <a:avLst/>
@@ -11468,7 +11347,7 @@
                 <a:spcPts val="0"/>
               </a:spcBef>
               <a:spcAft>
-                <a:spcPts val="140"/>
+                <a:spcPts val="0"/>
               </a:spcAft>
               <a:buNone/>
               <a:defRPr sz="810" b="0">
@@ -11479,35 +11358,24 @@
               </a:defRPr>
             </a:pPr>
             <a:r>
-              <a:rPr sz="810" b="0" lang="ja-JP" altLang="en-US">
-                <a:solidFill>
-                  <a:srgbClr val="626669"/>
-                </a:solidFill>
-                <a:latin typeface="Noto Sans"/>
-                <a:ea typeface="Noto Sans CJK JP"/>
-                <a:cs typeface="Noto Sans"/>
+              <a:rPr sz="830">
+                <a:latin typeface="Noto Sans CJK JP"/>
               </a:rPr>
               <a:t>[1] Liang et al. (2023), Holistic Evaluation of Language Models. TMLR.</a:t>
             </a:r>
-            <a:r>
-              <a:rPr sz="810" b="0" lang="ja-JP" altLang="en-US">
-                <a:solidFill>
-                  <a:srgbClr val="626669"/>
-                </a:solidFill>
-                <a:latin typeface="Noto Sans"/>
-                <a:ea typeface="Noto Sans CJK JP"/>
-                <a:cs typeface="Noto Sans"/>
-              </a:rPr>
-              <a:t>  </a:t>
-            </a:r>
-            <a:r>
-              <a:rPr sz="810" b="0" lang="ja-JP" altLang="en-US">
-                <a:solidFill>
-                  <a:srgbClr val="626669"/>
-                </a:solidFill>
-                <a:latin typeface="Noto Sans"/>
-                <a:ea typeface="Noto Sans CJK JP"/>
-                <a:cs typeface="Noto Sans"/>
+          </a:p>
+          <a:p>
+            <a:pPr>
+              <a:spcBef>
+                <a:spcPts val="0"/>
+              </a:spcBef>
+              <a:spcAft>
+                <a:spcPts val="0"/>
+              </a:spcAft>
+            </a:pPr>
+            <a:r>
+              <a:rPr sz="830">
+                <a:latin typeface="Noto Sans CJK JP"/>
                 <a:hlinkClick r:id="rId2"/>
               </a:rPr>
               <a:t>https://arxiv.org/abs/2211.09110</a:t>
@@ -11576,7 +11444,7 @@
                 <a:ea typeface="Noto Sans CJK JP"/>
                 <a:cs typeface="Noto Sans"/>
               </a:rPr>
-              <a:t>公開実行のbits per byte</a:t>
+              <a:t>4地域の英語で、モデルを比較する</a:t>
             </a:r>
           </a:p>
         </p:txBody>
@@ -12499,7 +12367,7 @@
                 <a:ea typeface="Noto Sans CJK JP"/>
                 <a:cs typeface="Noto Sans"/>
               </a:rPr>
-              <a:t>HELM Classic v0.4.0掲載、実行suite v0.3.0。各1試行、値は小さいほどよい。</a:t>
+              <a:t>HELM Classicの2023年の公開結果。各1試行、bits per byteは小さいほどよい。</a:t>
             </a:r>
           </a:p>
         </p:txBody>
@@ -12512,8 +12380,8 @@
         </p:nvSpPr>
         <p:spPr>
           <a:xfrm>
-            <a:off x="502920" y="4700016"/>
-            <a:ext cx="8183879" cy="530352"/>
+            <a:off x="502920" y="4699000"/>
+            <a:ext cx="8183879" cy="431800"/>
           </a:xfrm>
           <a:prstGeom prst="rect">
             <a:avLst/>
@@ -12534,7 +12402,7 @@
                 <a:spcPts val="0"/>
               </a:spcBef>
               <a:spcAft>
-                <a:spcPts val="140"/>
+                <a:spcPts val="0"/>
               </a:spcAft>
               <a:buNone/>
               <a:defRPr sz="810" b="0">
@@ -12545,35 +12413,24 @@
               </a:defRPr>
             </a:pPr>
             <a:r>
-              <a:rPr sz="810" b="0" lang="ja-JP" altLang="en-US">
-                <a:solidFill>
-                  <a:srgbClr val="626669"/>
-                </a:solidFill>
-                <a:latin typeface="Noto Sans"/>
-                <a:ea typeface="Noto Sans CJK JP"/>
-                <a:cs typeface="Noto Sans"/>
-              </a:rPr>
-              <a:t>[1] HELM Classic v0.4.0, ICE. 公開実行はv0.3.0。</a:t>
-            </a:r>
-            <a:r>
-              <a:rPr sz="810" b="0" lang="ja-JP" altLang="en-US">
-                <a:solidFill>
-                  <a:srgbClr val="626669"/>
-                </a:solidFill>
-                <a:latin typeface="Noto Sans"/>
-                <a:ea typeface="Noto Sans CJK JP"/>
-                <a:cs typeface="Noto Sans"/>
-              </a:rPr>
-              <a:t>  </a:t>
-            </a:r>
-            <a:r>
-              <a:rPr sz="810" b="0" lang="ja-JP" altLang="en-US">
-                <a:solidFill>
-                  <a:srgbClr val="626669"/>
-                </a:solidFill>
-                <a:latin typeface="Noto Sans"/>
-                <a:ea typeface="Noto Sans CJK JP"/>
-                <a:cs typeface="Noto Sans"/>
+              <a:rPr sz="830">
+                <a:latin typeface="Noto Sans CJK JP"/>
+              </a:rPr>
+              <a:t>[1] HELM Classic v0.4.0, ICE.</a:t>
+            </a:r>
+          </a:p>
+          <a:p>
+            <a:pPr>
+              <a:spcBef>
+                <a:spcPts val="0"/>
+              </a:spcBef>
+              <a:spcAft>
+                <a:spcPts val="0"/>
+              </a:spcAft>
+            </a:pPr>
+            <a:r>
+              <a:rPr sz="830">
+                <a:latin typeface="Noto Sans CJK JP"/>
                 <a:hlinkClick r:id="rId2"/>
               </a:rPr>
               <a:t>https://crfm.stanford.edu/helm/classic/v0.4.0/#/groups/ice</a:t>
@@ -12642,7 +12499,7 @@
                 <a:ea typeface="Noto Sans CJK JP"/>
                 <a:cs typeface="Noto Sans"/>
               </a:rPr>
-              <a:t>この比較は2023年の公開実行を表す</a:t>
+              <a:t>地域ごとに、異なる構成のテキストを評価</a:t>
             </a:r>
           </a:p>
         </p:txBody>
@@ -12695,7 +12552,7 @@
                 <a:ea typeface="Noto Sans CJK JP"/>
                 <a:cs typeface="Noto Sans"/>
               </a:rPr>
-              <a:t>OPT-175B（2022年）とtext-davinci-003（2022年）の二つの系列を示した。4地域ではOPTのbits per byteが小さい。</a:t>
+              <a:t>2023年の公開結果では、OPT-175Bとtext-davinci-003の2モデルを比較できる。ともに2022年に登場したモデルで、示した4地域ではOPT-175Bのbits per byteが小さい。</a:t>
             </a:r>
           </a:p>
           <a:p>
@@ -12725,37 +12582,7 @@
                 <a:ea typeface="Noto Sans CJK JP"/>
                 <a:cs typeface="Noto Sans"/>
               </a:rPr>
-              <a:t>評価件数はEast Africa 625件、Hong KongとIndiaが各500件、USAが200件。地域別に同じ件数ではない。</a:t>
-            </a:r>
-          </a:p>
-          <a:p>
-            <a:pPr marL="457200" indent="-355600">
-              <a:lnSpc>
-                <a:spcPts val="2499"/>
-              </a:lnSpc>
-              <a:spcAft>
-                <a:spcPts val="0"/>
-              </a:spcAft>
-              <a:buSzPct val="63333"/>
-              <a:buFont typeface="Noto Sans CJK JP"/>
-              <a:buChar char="●"/>
-              <a:defRPr sz="2100" b="0">
-                <a:solidFill>
-                  <a:srgbClr val="303437"/>
-                </a:solidFill>
-                <a:latin typeface="Noto Sans"/>
-              </a:defRPr>
-            </a:pPr>
-            <a:r>
-              <a:rPr sz="2100" b="0" lang="ja-JP" altLang="en-US">
-                <a:solidFill>
-                  <a:srgbClr val="303437"/>
-                </a:solidFill>
-                <a:latin typeface="Noto Sans"/>
-                <a:ea typeface="Noto Sans CJK JP"/>
-                <a:cs typeface="Noto Sans"/>
-              </a:rPr>
-              <a:t>表示版v0.4.0の公開日は2023-11-17。2026年のモデル性能順位を表す表ではない。</a:t>
+              <a:t>評価対象はEast Africaが625件、Hong KongとIndiaが各500件、USAが200件。USAは書き言葉のみで、他地域とは件数やジャンル構成が異なる。</a:t>
             </a:r>
           </a:p>
         </p:txBody>
@@ -12816,8 +12643,8 @@
         </p:nvSpPr>
         <p:spPr>
           <a:xfrm>
-            <a:off x="502920" y="4700016"/>
-            <a:ext cx="8183879" cy="530352"/>
+            <a:off x="502920" y="4699000"/>
+            <a:ext cx="8183879" cy="431800"/>
           </a:xfrm>
           <a:prstGeom prst="rect">
             <a:avLst/>
@@ -12838,7 +12665,7 @@
                 <a:spcPts val="0"/>
               </a:spcBef>
               <a:spcAft>
-                <a:spcPts val="140"/>
+                <a:spcPts val="0"/>
               </a:spcAft>
               <a:buNone/>
               <a:defRPr sz="810" b="0">
@@ -12849,35 +12676,24 @@
               </a:defRPr>
             </a:pPr>
             <a:r>
-              <a:rPr sz="810" b="0" lang="ja-JP" altLang="en-US">
-                <a:solidFill>
-                  <a:srgbClr val="626669"/>
-                </a:solidFill>
-                <a:latin typeface="Noto Sans"/>
-                <a:ea typeface="Noto Sans CJK JP"/>
-                <a:cs typeface="Noto Sans"/>
-              </a:rPr>
-              <a:t>[1] HELM Classic v0.4.0, ICE. 公開実行はv0.3.0。</a:t>
-            </a:r>
-            <a:r>
-              <a:rPr sz="810" b="0" lang="ja-JP" altLang="en-US">
-                <a:solidFill>
-                  <a:srgbClr val="626669"/>
-                </a:solidFill>
-                <a:latin typeface="Noto Sans"/>
-                <a:ea typeface="Noto Sans CJK JP"/>
-                <a:cs typeface="Noto Sans"/>
-              </a:rPr>
-              <a:t>  </a:t>
-            </a:r>
-            <a:r>
-              <a:rPr sz="810" b="0" lang="ja-JP" altLang="en-US">
-                <a:solidFill>
-                  <a:srgbClr val="626669"/>
-                </a:solidFill>
-                <a:latin typeface="Noto Sans"/>
-                <a:ea typeface="Noto Sans CJK JP"/>
-                <a:cs typeface="Noto Sans"/>
+              <a:rPr sz="830">
+                <a:latin typeface="Noto Sans CJK JP"/>
+              </a:rPr>
+              <a:t>[1] HELM Classic v0.4.0, ICE.</a:t>
+            </a:r>
+          </a:p>
+          <a:p>
+            <a:pPr>
+              <a:spcBef>
+                <a:spcPts val="0"/>
+              </a:spcBef>
+              <a:spcAft>
+                <a:spcPts val="0"/>
+              </a:spcAft>
+            </a:pPr>
+            <a:r>
+              <a:rPr sz="830">
+                <a:latin typeface="Noto Sans CJK JP"/>
                 <a:hlinkClick r:id="rId2"/>
               </a:rPr>
               <a:t>https://crfm.stanford.edu/helm/classic/v0.4.0/#/groups/ice</a:t>
@@ -12946,7 +12762,7 @@
                 <a:ea typeface="Noto Sans CJK JP"/>
                 <a:cs typeface="Noto Sans"/>
               </a:rPr>
-              <a:t>生成せず、長い入力を区切って確率を得る</a:t>
+              <a:t>長い文書は、入力長に合わせて評価する</a:t>
             </a:r>
           </a:p>
         </p:txBody>
@@ -12999,7 +12815,7 @@
                 <a:ea typeface="Noto Sans CJK JP"/>
                 <a:cs typeface="Noto Sans"/>
               </a:rPr>
-              <a:t>公開runの設定はlanguage_modeling。提示例は0件、生成トークン数は0、最大評価件数は1,000件、試行数は1。</a:t>
+              <a:t>HELMは例題を提示せず、本文の語や記号にモデルが付けた確率を取得する。新しい回答文は生成しない。</a:t>
             </a:r>
           </a:p>
           <a:p>
@@ -13029,37 +12845,7 @@
                 <a:ea typeface="Noto Sans CJK JP"/>
                 <a:cs typeface="Noto Sans"/>
               </a:rPr>
-              <a:t>一つの文書が長い場合は、モデルの入力長に合わせて複数のリクエストで評価する。</a:t>
-            </a:r>
-          </a:p>
-          <a:p>
-            <a:pPr marL="457200" indent="-355600">
-              <a:lnSpc>
-                <a:spcPts val="2499"/>
-              </a:lnSpc>
-              <a:spcAft>
-                <a:spcPts val="0"/>
-              </a:spcAft>
-              <a:buSzPct val="63333"/>
-              <a:buFont typeface="Noto Sans CJK JP"/>
-              <a:buChar char="●"/>
-              <a:defRPr sz="2100" b="0">
-                <a:solidFill>
-                  <a:srgbClr val="303437"/>
-                </a:solidFill>
-                <a:latin typeface="Noto Sans"/>
-              </a:defRPr>
-            </a:pPr>
-            <a:r>
-              <a:rPr sz="2100" b="0" lang="ja-JP" altLang="en-US">
-                <a:solidFill>
-                  <a:srgbClr val="303437"/>
-                </a:solidFill>
-                <a:latin typeface="Noto Sans"/>
-                <a:ea typeface="Noto Sans CJK JP"/>
-                <a:cs typeface="Noto Sans"/>
-              </a:rPr>
-              <a:t>Indiaの評価500件と、計算に使うリクエストの数は異なる。シナリオの本文には参照回答がない。</a:t>
+              <a:t>一つの文書が長い場合は、モデルの入力長に合わせて複数回に分けて処理する。文書数と、モデルを呼び出す回数は一致しない。</a:t>
             </a:r>
           </a:p>
         </p:txBody>
@@ -13120,8 +12906,8 @@
         </p:nvSpPr>
         <p:spPr>
           <a:xfrm>
-            <a:off x="502920" y="4700016"/>
-            <a:ext cx="8183879" cy="530352"/>
+            <a:off x="502920" y="4699000"/>
+            <a:ext cx="8183879" cy="431800"/>
           </a:xfrm>
           <a:prstGeom prst="rect">
             <a:avLst/>
@@ -13142,7 +12928,7 @@
                 <a:spcPts val="0"/>
               </a:spcBef>
               <a:spcAft>
-                <a:spcPts val="140"/>
+                <a:spcPts val="0"/>
               </a:spcAft>
               <a:buNone/>
               <a:defRPr sz="810" b="0">
@@ -13153,35 +12939,24 @@
               </a:defRPr>
             </a:pPr>
             <a:r>
-              <a:rPr sz="810" b="0" lang="ja-JP" altLang="en-US">
-                <a:solidFill>
-                  <a:srgbClr val="626669"/>
-                </a:solidFill>
-                <a:latin typeface="Noto Sans"/>
-                <a:ea typeface="Noto Sans CJK JP"/>
-                <a:cs typeface="Noto Sans"/>
-              </a:rPr>
-              <a:t>[1] HELM Classic v0.4.0, ICE. 公開実行はv0.3.0。</a:t>
-            </a:r>
-            <a:r>
-              <a:rPr sz="810" b="0" lang="ja-JP" altLang="en-US">
-                <a:solidFill>
-                  <a:srgbClr val="626669"/>
-                </a:solidFill>
-                <a:latin typeface="Noto Sans"/>
-                <a:ea typeface="Noto Sans CJK JP"/>
-                <a:cs typeface="Noto Sans"/>
-              </a:rPr>
-              <a:t>  </a:t>
-            </a:r>
-            <a:r>
-              <a:rPr sz="810" b="0" lang="ja-JP" altLang="en-US">
-                <a:solidFill>
-                  <a:srgbClr val="626669"/>
-                </a:solidFill>
-                <a:latin typeface="Noto Sans"/>
-                <a:ea typeface="Noto Sans CJK JP"/>
-                <a:cs typeface="Noto Sans"/>
+              <a:rPr sz="830">
+                <a:latin typeface="Noto Sans CJK JP"/>
+              </a:rPr>
+              <a:t>[1] HELM Classic v0.4.0, ICE.</a:t>
+            </a:r>
+          </a:p>
+          <a:p>
+            <a:pPr>
+              <a:spcBef>
+                <a:spcPts val="0"/>
+              </a:spcBef>
+              <a:spcAft>
+                <a:spcPts val="0"/>
+              </a:spcAft>
+            </a:pPr>
+            <a:r>
+              <a:rPr sz="830">
+                <a:latin typeface="Noto Sans CJK JP"/>
                 <a:hlinkClick r:id="rId2"/>
               </a:rPr>
               <a:t>https://crfm.stanford.edu/helm/classic/v0.4.0/#/groups/ice</a:t>
@@ -13424,8 +13199,8 @@
         </p:nvSpPr>
         <p:spPr>
           <a:xfrm>
-            <a:off x="502920" y="4700016"/>
-            <a:ext cx="8183879" cy="530352"/>
+            <a:off x="502920" y="4508500"/>
+            <a:ext cx="8183879" cy="558800"/>
           </a:xfrm>
           <a:prstGeom prst="rect">
             <a:avLst/>
@@ -13446,7 +13221,7 @@
                 <a:spcPts val="0"/>
               </a:spcBef>
               <a:spcAft>
-                <a:spcPts val="140"/>
+                <a:spcPts val="0"/>
               </a:spcAft>
               <a:buNone/>
               <a:defRPr sz="810" b="0">
@@ -13457,35 +13232,24 @@
               </a:defRPr>
             </a:pPr>
             <a:r>
-              <a:rPr sz="810" b="0" lang="ja-JP" altLang="en-US">
-                <a:solidFill>
-                  <a:srgbClr val="626669"/>
-                </a:solidFill>
-                <a:latin typeface="Noto Sans"/>
-                <a:ea typeface="Noto Sans CJK JP"/>
-                <a:cs typeface="Noto Sans"/>
+              <a:rPr sz="830">
+                <a:latin typeface="Noto Sans CJK JP"/>
               </a:rPr>
               <a:t>[1] Liang et al. (2023), Holistic Evaluation of Language Models. TMLR.</a:t>
             </a:r>
-            <a:r>
-              <a:rPr sz="810" b="0" lang="ja-JP" altLang="en-US">
-                <a:solidFill>
-                  <a:srgbClr val="626669"/>
-                </a:solidFill>
-                <a:latin typeface="Noto Sans"/>
-                <a:ea typeface="Noto Sans CJK JP"/>
-                <a:cs typeface="Noto Sans"/>
-              </a:rPr>
-              <a:t>  </a:t>
-            </a:r>
-            <a:r>
-              <a:rPr sz="810" b="0" lang="ja-JP" altLang="en-US">
-                <a:solidFill>
-                  <a:srgbClr val="626669"/>
-                </a:solidFill>
-                <a:latin typeface="Noto Sans"/>
-                <a:ea typeface="Noto Sans CJK JP"/>
-                <a:cs typeface="Noto Sans"/>
+          </a:p>
+          <a:p>
+            <a:pPr>
+              <a:spcBef>
+                <a:spcPts val="0"/>
+              </a:spcBef>
+              <a:spcAft>
+                <a:spcPts val="0"/>
+              </a:spcAft>
+            </a:pPr>
+            <a:r>
+              <a:rPr sz="830">
+                <a:latin typeface="Noto Sans CJK JP"/>
                 <a:hlinkClick r:id="rId2"/>
               </a:rPr>
               <a:t>https://arxiv.org/abs/2211.09110</a:t>
@@ -13493,50 +13257,32 @@
           </a:p>
           <a:p>
             <a:pPr>
-              <a:lnSpc>
-                <a:spcPts val="940"/>
-              </a:lnSpc>
-              <a:spcAft>
-                <a:spcPts val="140"/>
-              </a:spcAft>
-              <a:buNone/>
-              <a:defRPr sz="810" b="0">
-                <a:solidFill>
-                  <a:srgbClr val="303437"/>
-                </a:solidFill>
-                <a:latin typeface="Noto Sans"/>
-              </a:defRPr>
-            </a:pPr>
-            <a:r>
-              <a:rPr sz="810" b="0" lang="ja-JP" altLang="en-US">
-                <a:solidFill>
-                  <a:srgbClr val="626669"/>
-                </a:solidFill>
-                <a:latin typeface="Noto Sans"/>
-                <a:ea typeface="Noto Sans CJK JP"/>
-                <a:cs typeface="Noto Sans"/>
+              <a:spcBef>
+                <a:spcPts val="0"/>
+              </a:spcBef>
+              <a:spcAft>
+                <a:spcPts val="0"/>
+              </a:spcAft>
+            </a:pPr>
+            <a:r>
+              <a:rPr sz="830">
+                <a:latin typeface="Noto Sans CJK JP"/>
               </a:rPr>
               <a:t>[2] Stanford CRFM, HELM ICEScenario. v0.3.0.</a:t>
             </a:r>
-            <a:r>
-              <a:rPr sz="810" b="0" lang="ja-JP" altLang="en-US">
-                <a:solidFill>
-                  <a:srgbClr val="626669"/>
-                </a:solidFill>
-                <a:latin typeface="Noto Sans"/>
-                <a:ea typeface="Noto Sans CJK JP"/>
-                <a:cs typeface="Noto Sans"/>
-              </a:rPr>
-              <a:t>  </a:t>
-            </a:r>
-            <a:r>
-              <a:rPr sz="810" b="0" lang="ja-JP" altLang="en-US">
-                <a:solidFill>
-                  <a:srgbClr val="626669"/>
-                </a:solidFill>
-                <a:latin typeface="Noto Sans"/>
-                <a:ea typeface="Noto Sans CJK JP"/>
-                <a:cs typeface="Noto Sans"/>
+          </a:p>
+          <a:p>
+            <a:pPr>
+              <a:spcBef>
+                <a:spcPts val="0"/>
+              </a:spcBef>
+              <a:spcAft>
+                <a:spcPts val="0"/>
+              </a:spcAft>
+            </a:pPr>
+            <a:r>
+              <a:rPr sz="830">
+                <a:latin typeface="Noto Sans CJK JP"/>
                 <a:hlinkClick r:id="rId3"/>
               </a:rPr>
               <a:t>https://github.com/stanford-crfm/helm/blob/v0.3.0/src/helm/benchmark/scenarios/ice_scenario.py</a:t>
@@ -13575,11 +13321,11 @@
         <p:spPr>
           <a:xfrm>
             <a:off x="548640" y="2506875"/>
-            <a:ext cx="8046720" cy="585216"/>
+            <a:ext cx="8046720" cy="737616"/>
           </a:xfrm>
         </p:spPr>
         <p:txBody>
-          <a:bodyPr wrap="square" lIns="0" rIns="0" tIns="0" bIns="0" anchor="ctr">
+          <a:bodyPr wrap="square" lIns="0" rIns="0" tIns="0" bIns="152400" anchor="ctr">
             <a:noAutofit/>
           </a:bodyPr>
           <a:lstStyle/>
@@ -13605,7 +13351,7 @@
                 <a:ea typeface="Noto Sans CJK JP"/>
                 <a:cs typeface="Noto Sans"/>
               </a:rPr>
-              <a:t>利用の変化と入手方法</a:t>
+              <a:t>入手方法と活用</a:t>
             </a:r>
           </a:p>
         </p:txBody>
@@ -13653,7 +13399,7 @@
                 <a:ea typeface="Noto Sans CJK JP"/>
                 <a:cs typeface="Noto Sans"/>
               </a:rPr>
-              <a:t>4. 利用の変化と入手方法</a:t>
+              <a:t>4. 入手方法と活用</a:t>
             </a:r>
           </a:p>
         </p:txBody>
@@ -13832,7 +13578,7 @@
                 <a:ea typeface="Noto Sans CJK JP"/>
                 <a:cs typeface="Noto Sans"/>
               </a:rPr>
-              <a:t>2026-10-18の公式サイトにはUgandaやTrinidad and Tobagoの完成案内もあり、HELMの対象地域より活動範囲が広い。</a:t>
+              <a:t>2026年の公式サイトにはUgandaやTrinidad and Tobagoの完成案内もあり、HELMの対象地域より活動範囲が広い。</a:t>
             </a:r>
           </a:p>
         </p:txBody>
@@ -13880,7 +13626,7 @@
                 <a:ea typeface="Noto Sans CJK JP"/>
                 <a:cs typeface="Noto Sans"/>
               </a:rPr>
-              <a:t>4. 利用の変化と入手方法</a:t>
+              <a:t>4. 入手方法と活用</a:t>
             </a:r>
           </a:p>
         </p:txBody>
@@ -13893,8 +13639,8 @@
         </p:nvSpPr>
         <p:spPr>
           <a:xfrm>
-            <a:off x="502920" y="4700016"/>
-            <a:ext cx="8183879" cy="530352"/>
+            <a:off x="502920" y="4699000"/>
+            <a:ext cx="8183879" cy="431800"/>
           </a:xfrm>
           <a:prstGeom prst="rect">
             <a:avLst/>
@@ -13915,7 +13661,7 @@
                 <a:spcPts val="0"/>
               </a:spcBef>
               <a:spcAft>
-                <a:spcPts val="140"/>
+                <a:spcPts val="0"/>
               </a:spcAft>
               <a:buNone/>
               <a:defRPr sz="810" b="0">
@@ -13926,35 +13672,24 @@
               </a:defRPr>
             </a:pPr>
             <a:r>
-              <a:rPr sz="810" b="0" lang="ja-JP" altLang="en-US">
-                <a:solidFill>
-                  <a:srgbClr val="626669"/>
-                </a:solidFill>
-                <a:latin typeface="Noto Sans"/>
-                <a:ea typeface="Noto Sans CJK JP"/>
-                <a:cs typeface="Noto Sans"/>
-              </a:rPr>
-              <a:t>[1] International Corpus of English. University of Zurich. 2026-10-18参照。</a:t>
-            </a:r>
-            <a:r>
-              <a:rPr sz="810" b="0" lang="ja-JP" altLang="en-US">
-                <a:solidFill>
-                  <a:srgbClr val="626669"/>
-                </a:solidFill>
-                <a:latin typeface="Noto Sans"/>
-                <a:ea typeface="Noto Sans CJK JP"/>
-                <a:cs typeface="Noto Sans"/>
-              </a:rPr>
-              <a:t>  </a:t>
-            </a:r>
-            <a:r>
-              <a:rPr sz="810" b="0" lang="ja-JP" altLang="en-US">
-                <a:solidFill>
-                  <a:srgbClr val="626669"/>
-                </a:solidFill>
-                <a:latin typeface="Noto Sans"/>
-                <a:ea typeface="Noto Sans CJK JP"/>
-                <a:cs typeface="Noto Sans"/>
+              <a:rPr sz="830">
+                <a:latin typeface="Noto Sans CJK JP"/>
+              </a:rPr>
+              <a:t>[1] International Corpus of English. University of Zurich.</a:t>
+            </a:r>
+          </a:p>
+          <a:p>
+            <a:pPr>
+              <a:spcBef>
+                <a:spcPts val="0"/>
+              </a:spcBef>
+              <a:spcAft>
+                <a:spcPts val="0"/>
+              </a:spcAft>
+            </a:pPr>
+            <a:r>
+              <a:rPr sz="830">
+                <a:latin typeface="Noto Sans CJK JP"/>
                 <a:hlinkClick r:id="rId2"/>
               </a:rPr>
               <a:t>https://www.ice-corpora.uzh.ch/en.html</a:t>
@@ -14023,7 +13758,7 @@
                 <a:ea typeface="Noto Sans CJK JP"/>
                 <a:cs typeface="Noto Sans"/>
               </a:rPr>
-              <a:t>配布は地域ごとのライセンスに従う</a:t>
+              <a:t>地域ごとの配布窓口で、利用を申請する</a:t>
             </a:r>
           </a:p>
         </p:txBody>
@@ -14076,7 +13811,7 @@
                 <a:ea typeface="Noto Sans CJK JP"/>
                 <a:cs typeface="Noto Sans"/>
               </a:rPr>
-              <a:t>Zurich配布のコーパスには学術ライセンスが必要。申請書を送り、教育機関のメールアドレスで資格を示す。</a:t>
+              <a:t>Zurichから配布されるコーパスは、非商用の学術研究向け。申請書を送り、教育機関のメールアドレスで資格を示す。Great Britainなどは各編纂機関が配布する。</a:t>
             </a:r>
           </a:p>
           <a:p>
@@ -14106,7 +13841,7 @@
                 <a:ea typeface="Noto Sans CJK JP"/>
                 <a:cs typeface="Noto Sans"/>
               </a:rPr>
-              <a:t>公式サイトは非商用の学術研究用途に限定している。Great Britainなどは各編纂機関が配布する。</a:t>
+              <a:t>取得したコーパスの再配布は認められておらず、著作権は元の権利者に残る。出版物での短い引用も、著作権法で認められる範囲に従う。</a:t>
             </a:r>
           </a:p>
           <a:p>
@@ -14136,7 +13871,7 @@
                 <a:ea typeface="Noto Sans CJK JP"/>
                 <a:cs typeface="Noto Sans"/>
               </a:rPr>
-              <a:t>HELMコードも自動取得を行わず、利用者が取得済みのファイルをrestricted/ice以下へ配置する実装になっている。</a:t>
+              <a:t>HELMで利用する場合は、取得済みの地域別ファイルをrestricted/ice以下へ配置する。</a:t>
             </a:r>
           </a:p>
         </p:txBody>
@@ -14184,7 +13919,7 @@
                 <a:ea typeface="Noto Sans CJK JP"/>
                 <a:cs typeface="Noto Sans"/>
               </a:rPr>
-              <a:t>4. 利用の変化と入手方法</a:t>
+              <a:t>4. 入手方法と活用</a:t>
             </a:r>
           </a:p>
         </p:txBody>
@@ -14197,8 +13932,8 @@
         </p:nvSpPr>
         <p:spPr>
           <a:xfrm>
-            <a:off x="502920" y="4700016"/>
-            <a:ext cx="8183879" cy="530352"/>
+            <a:off x="502920" y="4699000"/>
+            <a:ext cx="8183879" cy="431800"/>
           </a:xfrm>
           <a:prstGeom prst="rect">
             <a:avLst/>
@@ -14219,7 +13954,7 @@
                 <a:spcPts val="0"/>
               </a:spcBef>
               <a:spcAft>
-                <a:spcPts val="140"/>
+                <a:spcPts val="0"/>
               </a:spcAft>
               <a:buNone/>
               <a:defRPr sz="810" b="0">
@@ -14230,35 +13965,24 @@
               </a:defRPr>
             </a:pPr>
             <a:r>
-              <a:rPr sz="810" b="0" lang="ja-JP" altLang="en-US">
-                <a:solidFill>
-                  <a:srgbClr val="626669"/>
-                </a:solidFill>
-                <a:latin typeface="Noto Sans"/>
-                <a:ea typeface="Noto Sans CJK JP"/>
-                <a:cs typeface="Noto Sans"/>
+              <a:rPr sz="830">
+                <a:latin typeface="Noto Sans CJK JP"/>
               </a:rPr>
               <a:t>[1] International Corpus of English. Getting Access.</a:t>
             </a:r>
-            <a:r>
-              <a:rPr sz="810" b="0" lang="ja-JP" altLang="en-US">
-                <a:solidFill>
-                  <a:srgbClr val="626669"/>
-                </a:solidFill>
-                <a:latin typeface="Noto Sans"/>
-                <a:ea typeface="Noto Sans CJK JP"/>
-                <a:cs typeface="Noto Sans"/>
-              </a:rPr>
-              <a:t>  </a:t>
-            </a:r>
-            <a:r>
-              <a:rPr sz="810" b="0" lang="ja-JP" altLang="en-US">
-                <a:solidFill>
-                  <a:srgbClr val="626669"/>
-                </a:solidFill>
-                <a:latin typeface="Noto Sans"/>
-                <a:ea typeface="Noto Sans CJK JP"/>
-                <a:cs typeface="Noto Sans"/>
+          </a:p>
+          <a:p>
+            <a:pPr>
+              <a:spcBef>
+                <a:spcPts val="0"/>
+              </a:spcBef>
+              <a:spcAft>
+                <a:spcPts val="0"/>
+              </a:spcAft>
+            </a:pPr>
+            <a:r>
+              <a:rPr sz="830">
+                <a:latin typeface="Noto Sans CJK JP"/>
                 <a:hlinkClick r:id="rId2"/>
               </a:rPr>
               <a:t>https://www.ice-corpora.uzh.ch/en/access.html</a:t>
@@ -14440,7 +14164,7 @@
                 <a:ea typeface="Noto Sans CJK JP"/>
                 <a:cs typeface="Noto Sans"/>
               </a:rPr>
-              <a:t>実際の利用では、地域、話し言葉・書き言葉の内訳、前処理、ライセンスをそろえて対象を選ぶ。</a:t>
+              <a:t>利用する地域や、話し言葉・書き言葉の構成、前処理を踏まえて比較し、各地域の利用条件に従う。</a:t>
             </a:r>
           </a:p>
         </p:txBody>
@@ -14488,7 +14212,7 @@
                 <a:ea typeface="Noto Sans CJK JP"/>
                 <a:cs typeface="Noto Sans"/>
               </a:rPr>
-              <a:t>4. 利用の変化と入手方法</a:t>
+              <a:t>4. 入手方法と活用</a:t>
             </a:r>
           </a:p>
         </p:txBody>
@@ -14501,8 +14225,8 @@
         </p:nvSpPr>
         <p:spPr>
           <a:xfrm>
-            <a:off x="502920" y="4700016"/>
-            <a:ext cx="8183879" cy="530352"/>
+            <a:off x="502920" y="4508500"/>
+            <a:ext cx="8183879" cy="558800"/>
           </a:xfrm>
           <a:prstGeom prst="rect">
             <a:avLst/>
@@ -14523,7 +14247,7 @@
                 <a:spcPts val="0"/>
               </a:spcBef>
               <a:spcAft>
-                <a:spcPts val="140"/>
+                <a:spcPts val="0"/>
               </a:spcAft>
               <a:buNone/>
               <a:defRPr sz="810" b="0">
@@ -14534,35 +14258,24 @@
               </a:defRPr>
             </a:pPr>
             <a:r>
-              <a:rPr sz="810" b="0" lang="ja-JP" altLang="en-US">
-                <a:solidFill>
-                  <a:srgbClr val="626669"/>
-                </a:solidFill>
-                <a:latin typeface="Noto Sans"/>
-                <a:ea typeface="Noto Sans CJK JP"/>
-                <a:cs typeface="Noto Sans"/>
+              <a:rPr sz="830">
+                <a:latin typeface="Noto Sans CJK JP"/>
               </a:rPr>
               <a:t>[1] International Corpus of English. Design of ICE Corpora.</a:t>
             </a:r>
-            <a:r>
-              <a:rPr sz="810" b="0" lang="ja-JP" altLang="en-US">
-                <a:solidFill>
-                  <a:srgbClr val="626669"/>
-                </a:solidFill>
-                <a:latin typeface="Noto Sans"/>
-                <a:ea typeface="Noto Sans CJK JP"/>
-                <a:cs typeface="Noto Sans"/>
-              </a:rPr>
-              <a:t>  </a:t>
-            </a:r>
-            <a:r>
-              <a:rPr sz="810" b="0" lang="ja-JP" altLang="en-US">
-                <a:solidFill>
-                  <a:srgbClr val="626669"/>
-                </a:solidFill>
-                <a:latin typeface="Noto Sans"/>
-                <a:ea typeface="Noto Sans CJK JP"/>
-                <a:cs typeface="Noto Sans"/>
+          </a:p>
+          <a:p>
+            <a:pPr>
+              <a:spcBef>
+                <a:spcPts val="0"/>
+              </a:spcBef>
+              <a:spcAft>
+                <a:spcPts val="0"/>
+              </a:spcAft>
+            </a:pPr>
+            <a:r>
+              <a:rPr sz="830">
+                <a:latin typeface="Noto Sans CJK JP"/>
                 <a:hlinkClick r:id="rId2"/>
               </a:rPr>
               <a:t>https://www.ice-corpora.uzh.ch/en/design.html</a:t>
@@ -14570,50 +14283,32 @@
           </a:p>
           <a:p>
             <a:pPr>
-              <a:lnSpc>
-                <a:spcPts val="940"/>
-              </a:lnSpc>
-              <a:spcAft>
-                <a:spcPts val="140"/>
-              </a:spcAft>
-              <a:buNone/>
-              <a:defRPr sz="810" b="0">
-                <a:solidFill>
-                  <a:srgbClr val="303437"/>
-                </a:solidFill>
-                <a:latin typeface="Noto Sans"/>
-              </a:defRPr>
-            </a:pPr>
-            <a:r>
-              <a:rPr sz="810" b="0" lang="ja-JP" altLang="en-US">
-                <a:solidFill>
-                  <a:srgbClr val="626669"/>
-                </a:solidFill>
-                <a:latin typeface="Noto Sans"/>
-                <a:ea typeface="Noto Sans CJK JP"/>
-                <a:cs typeface="Noto Sans"/>
+              <a:spcBef>
+                <a:spcPts val="0"/>
+              </a:spcBef>
+              <a:spcAft>
+                <a:spcPts val="0"/>
+              </a:spcAft>
+            </a:pPr>
+            <a:r>
+              <a:rPr sz="830">
+                <a:latin typeface="Noto Sans CJK JP"/>
               </a:rPr>
               <a:t>[2] Liang et al. (2023), Holistic Evaluation of Language Models. TMLR.</a:t>
             </a:r>
-            <a:r>
-              <a:rPr sz="810" b="0" lang="ja-JP" altLang="en-US">
-                <a:solidFill>
-                  <a:srgbClr val="626669"/>
-                </a:solidFill>
-                <a:latin typeface="Noto Sans"/>
-                <a:ea typeface="Noto Sans CJK JP"/>
-                <a:cs typeface="Noto Sans"/>
-              </a:rPr>
-              <a:t>  </a:t>
-            </a:r>
-            <a:r>
-              <a:rPr sz="810" b="0" lang="ja-JP" altLang="en-US">
-                <a:solidFill>
-                  <a:srgbClr val="626669"/>
-                </a:solidFill>
-                <a:latin typeface="Noto Sans"/>
-                <a:ea typeface="Noto Sans CJK JP"/>
-                <a:cs typeface="Noto Sans"/>
+          </a:p>
+          <a:p>
+            <a:pPr>
+              <a:spcBef>
+                <a:spcPts val="0"/>
+              </a:spcBef>
+              <a:spcAft>
+                <a:spcPts val="0"/>
+              </a:spcAft>
+            </a:pPr>
+            <a:r>
+              <a:rPr sz="830">
+                <a:latin typeface="Noto Sans CJK JP"/>
                 <a:hlinkClick r:id="rId3"/>
               </a:rPr>
               <a:t>https://arxiv.org/abs/2211.09110</a:t>
@@ -14652,11 +14347,11 @@
         <p:spPr>
           <a:xfrm>
             <a:off x="548640" y="2484835"/>
-            <a:ext cx="8046720" cy="585216"/>
+            <a:ext cx="8046720" cy="686816"/>
           </a:xfrm>
         </p:spPr>
         <p:txBody>
-          <a:bodyPr wrap="square" lIns="0" rIns="0" tIns="0" bIns="0" anchor="ctr">
+          <a:bodyPr wrap="square" lIns="0" rIns="0" tIns="0" bIns="101600" anchor="ctr">
             <a:noAutofit/>
           </a:bodyPr>
           <a:lstStyle/>
@@ -14939,7 +14634,7 @@
                 <a:ea typeface="Noto Sans CJK JP"/>
                 <a:cs typeface="Noto Sans"/>
               </a:rPr>
-              <a:t>利用の変化と入手方法</a:t>
+              <a:t>入手方法と活用</a:t>
             </a:r>
           </a:p>
         </p:txBody>
@@ -15136,7 +14831,7 @@
                 <a:ea typeface="Noto Sans CJK JP"/>
                 <a:cs typeface="Noto Sans"/>
               </a:rPr>
-              <a:t>構成と実行条件の補足</a:t>
+              <a:t>収録ジャンルと評価対象</a:t>
             </a:r>
           </a:p>
           <a:p>
@@ -15450,7 +15145,7 @@
         <p:spPr>
           <a:xfrm>
             <a:off x="548640" y="1719072"/>
-            <a:ext cx="3931920" cy="2563847"/>
+            <a:ext cx="3931920" cy="2513047"/>
           </a:xfrm>
           <a:prstGeom prst="rect">
             <a:avLst/>
@@ -15478,7 +15173,7 @@
           </a:fontRef>
         </p:style>
         <p:txBody>
-          <a:bodyPr rtlCol="0" anchor="t" wrap="square" lIns="177800" rIns="177800" tIns="63500" bIns="127000">
+          <a:bodyPr rtlCol="0" anchor="t" wrap="square" lIns="177800" rIns="177800" tIns="33866" bIns="127000">
             <a:noAutofit/>
           </a:bodyPr>
           <a:lstStyle/>
@@ -15524,7 +15219,7 @@
         <p:spPr>
           <a:xfrm>
             <a:off x="4663440" y="1719072"/>
-            <a:ext cx="3931920" cy="2754292"/>
+            <a:ext cx="3931920" cy="2695025"/>
           </a:xfrm>
           <a:prstGeom prst="rect">
             <a:avLst/>
@@ -15552,7 +15247,7 @@
           </a:fontRef>
         </p:style>
         <p:txBody>
-          <a:bodyPr rtlCol="0" anchor="t" wrap="square" lIns="177800" rIns="177800" tIns="63500" bIns="127000">
+          <a:bodyPr rtlCol="0" anchor="t" wrap="square" lIns="177800" rIns="177800" tIns="59266" bIns="127000">
             <a:noAutofit/>
           </a:bodyPr>
           <a:lstStyle/>
@@ -15659,8 +15354,8 @@
         </p:nvSpPr>
         <p:spPr>
           <a:xfrm>
-            <a:off x="502920" y="4700016"/>
-            <a:ext cx="8183879" cy="530352"/>
+            <a:off x="502920" y="4699000"/>
+            <a:ext cx="8183879" cy="431800"/>
           </a:xfrm>
           <a:prstGeom prst="rect">
             <a:avLst/>
@@ -15681,7 +15376,7 @@
                 <a:spcPts val="0"/>
               </a:spcBef>
               <a:spcAft>
-                <a:spcPts val="140"/>
+                <a:spcPts val="0"/>
               </a:spcAft>
               <a:buNone/>
               <a:defRPr sz="810" b="0">
@@ -15692,38 +15387,24 @@
               </a:defRPr>
             </a:pPr>
             <a:r>
-              <a:rPr sz="810" b="0" lang="ja-JP" altLang="en-US">
-                <a:solidFill>
-                  <a:srgbClr val="626669"/>
-                </a:solidFill>
-                <a:latin typeface="Noto Sans"/>
-                <a:ea typeface="Noto Sans CJK JP"/>
-                <a:cs typeface="Noto Sans"/>
-              </a:rPr>
-              <a:t>[1] HELM公開実行 v0.3.0, ICE India / OPT-175B. scenario_stateの実入力から抜粋。 id2 / 文字範囲 [0, 318]</a:t>
+              <a:rPr sz="830">
+                <a:latin typeface="Noto Sans CJK JP"/>
+              </a:rPr>
+              <a:t>[1] Stanford CRFM (2023). HELM Classic: ICE India / OPT-175B.</a:t>
             </a:r>
           </a:p>
           <a:p>
             <a:pPr>
-              <a:lnSpc>
-                <a:spcPts val="940"/>
-              </a:lnSpc>
-              <a:buNone/>
-              <a:defRPr sz="810" b="0">
-                <a:solidFill>
-                  <a:srgbClr val="303437"/>
-                </a:solidFill>
-                <a:latin typeface="Noto Sans"/>
-              </a:defRPr>
-            </a:pPr>
-            <a:r>
-              <a:rPr sz="810" b="0" lang="ja-JP" altLang="en-US">
-                <a:solidFill>
-                  <a:srgbClr val="626669"/>
-                </a:solidFill>
-                <a:latin typeface="Noto Sans"/>
-                <a:ea typeface="Noto Sans CJK JP"/>
-                <a:cs typeface="Noto Sans"/>
+              <a:spcBef>
+                <a:spcPts val="0"/>
+              </a:spcBef>
+              <a:spcAft>
+                <a:spcPts val="0"/>
+              </a:spcAft>
+            </a:pPr>
+            <a:r>
+              <a:rPr sz="830">
+                <a:latin typeface="Noto Sans CJK JP"/>
                 <a:hlinkClick r:id="rId2"/>
               </a:rPr>
               <a:t>https://crfm.stanford.edu/helm/classic/v0.4.0/#/runs/ice:subset=ind,model=together_opt-175b</a:t>
@@ -15962,7 +15643,7 @@
         <p:spPr>
           <a:xfrm>
             <a:off x="548640" y="1719072"/>
-            <a:ext cx="3931920" cy="2635226"/>
+            <a:ext cx="3931920" cy="2575959"/>
           </a:xfrm>
           <a:prstGeom prst="rect">
             <a:avLst/>
@@ -15990,7 +15671,7 @@
           </a:fontRef>
         </p:style>
         <p:txBody>
-          <a:bodyPr rtlCol="0" anchor="t" wrap="square" lIns="177800" rIns="177800" tIns="63500" bIns="127000">
+          <a:bodyPr rtlCol="0" anchor="t" wrap="square" lIns="177800" rIns="177800" tIns="42333" bIns="127000">
             <a:noAutofit/>
           </a:bodyPr>
           <a:lstStyle/>
@@ -16036,7 +15717,7 @@
         <p:spPr>
           <a:xfrm>
             <a:off x="4663440" y="1719072"/>
-            <a:ext cx="3931920" cy="2634083"/>
+            <a:ext cx="3931920" cy="2566349"/>
           </a:xfrm>
           <a:prstGeom prst="rect">
             <a:avLst/>
@@ -16064,7 +15745,7 @@
           </a:fontRef>
         </p:style>
         <p:txBody>
-          <a:bodyPr rtlCol="0" anchor="t" wrap="square" lIns="177800" rIns="177800" tIns="63500" bIns="127000">
+          <a:bodyPr rtlCol="0" anchor="t" wrap="square" lIns="177800" rIns="177800" tIns="59266" bIns="127000">
             <a:noAutofit/>
           </a:bodyPr>
           <a:lstStyle/>
@@ -16171,8 +15852,8 @@
         </p:nvSpPr>
         <p:spPr>
           <a:xfrm>
-            <a:off x="502920" y="4700016"/>
-            <a:ext cx="8183879" cy="530352"/>
+            <a:off x="502920" y="4699000"/>
+            <a:ext cx="8183879" cy="431800"/>
           </a:xfrm>
           <a:prstGeom prst="rect">
             <a:avLst/>
@@ -16193,7 +15874,7 @@
                 <a:spcPts val="0"/>
               </a:spcBef>
               <a:spcAft>
-                <a:spcPts val="140"/>
+                <a:spcPts val="0"/>
               </a:spcAft>
               <a:buNone/>
               <a:defRPr sz="810" b="0">
@@ -16204,38 +15885,24 @@
               </a:defRPr>
             </a:pPr>
             <a:r>
-              <a:rPr sz="810" b="0" lang="ja-JP" altLang="en-US">
-                <a:solidFill>
-                  <a:srgbClr val="626669"/>
-                </a:solidFill>
-                <a:latin typeface="Noto Sans"/>
-                <a:ea typeface="Noto Sans CJK JP"/>
-                <a:cs typeface="Noto Sans"/>
-              </a:rPr>
-              <a:t>[1] HELM公開実行 v0.3.0, ICE India / OPT-175B. scenario_stateの実入力から抜粋。 id1 / 文字範囲 [0, 259]</a:t>
+              <a:rPr sz="830">
+                <a:latin typeface="Noto Sans CJK JP"/>
+              </a:rPr>
+              <a:t>[1] Stanford CRFM (2023). HELM Classic: ICE India / OPT-175B.</a:t>
             </a:r>
           </a:p>
           <a:p>
             <a:pPr>
-              <a:lnSpc>
-                <a:spcPts val="940"/>
-              </a:lnSpc>
-              <a:buNone/>
-              <a:defRPr sz="810" b="0">
-                <a:solidFill>
-                  <a:srgbClr val="303437"/>
-                </a:solidFill>
-                <a:latin typeface="Noto Sans"/>
-              </a:defRPr>
-            </a:pPr>
-            <a:r>
-              <a:rPr sz="810" b="0" lang="ja-JP" altLang="en-US">
-                <a:solidFill>
-                  <a:srgbClr val="626669"/>
-                </a:solidFill>
-                <a:latin typeface="Noto Sans"/>
-                <a:ea typeface="Noto Sans CJK JP"/>
-                <a:cs typeface="Noto Sans"/>
+              <a:spcBef>
+                <a:spcPts val="0"/>
+              </a:spcBef>
+              <a:spcAft>
+                <a:spcPts val="0"/>
+              </a:spcAft>
+            </a:pPr>
+            <a:r>
+              <a:rPr sz="830">
+                <a:latin typeface="Noto Sans CJK JP"/>
                 <a:hlinkClick r:id="rId2"/>
               </a:rPr>
               <a:t>https://crfm.stanford.edu/helm/classic/v0.4.0/#/runs/ice:subset=ind,model=together_opt-175b</a:t>
@@ -16474,7 +16141,7 @@
         <p:spPr>
           <a:xfrm>
             <a:off x="548640" y="1719072"/>
-            <a:ext cx="3931920" cy="1274434"/>
+            <a:ext cx="3931920" cy="1240567"/>
           </a:xfrm>
           <a:prstGeom prst="rect">
             <a:avLst/>
@@ -16502,7 +16169,7 @@
           </a:fontRef>
         </p:style>
         <p:txBody>
-          <a:bodyPr rtlCol="0" anchor="t" wrap="square" lIns="177800" rIns="177800" tIns="63500" bIns="127000">
+          <a:bodyPr rtlCol="0" anchor="t" wrap="square" lIns="177800" rIns="177800" tIns="42333" bIns="127000">
             <a:noAutofit/>
           </a:bodyPr>
           <a:lstStyle/>
@@ -16548,7 +16215,7 @@
         <p:spPr>
           <a:xfrm>
             <a:off x="4663440" y="1719072"/>
-            <a:ext cx="3931920" cy="1273291"/>
+            <a:ext cx="3931920" cy="1214024"/>
           </a:xfrm>
           <a:prstGeom prst="rect">
             <a:avLst/>
@@ -16576,7 +16243,7 @@
           </a:fontRef>
         </p:style>
         <p:txBody>
-          <a:bodyPr rtlCol="0" anchor="t" wrap="square" lIns="177800" rIns="177800" tIns="63500" bIns="127000">
+          <a:bodyPr rtlCol="0" anchor="t" wrap="square" lIns="177800" rIns="177800" tIns="59266" bIns="127000">
             <a:noAutofit/>
           </a:bodyPr>
           <a:lstStyle/>
@@ -16621,8 +16288,8 @@
         </p:nvSpPr>
         <p:spPr>
           <a:xfrm>
-            <a:off x="502920" y="4700016"/>
-            <a:ext cx="8183879" cy="530352"/>
+            <a:off x="502920" y="4699000"/>
+            <a:ext cx="8183879" cy="431800"/>
           </a:xfrm>
           <a:prstGeom prst="rect">
             <a:avLst/>
@@ -16643,7 +16310,7 @@
                 <a:spcPts val="0"/>
               </a:spcBef>
               <a:spcAft>
-                <a:spcPts val="140"/>
+                <a:spcPts val="0"/>
               </a:spcAft>
               <a:buNone/>
               <a:defRPr sz="810" b="0">
@@ -16654,38 +16321,24 @@
               </a:defRPr>
             </a:pPr>
             <a:r>
-              <a:rPr sz="810" b="0" lang="ja-JP" altLang="en-US">
-                <a:solidFill>
-                  <a:srgbClr val="626669"/>
-                </a:solidFill>
-                <a:latin typeface="Noto Sans"/>
-                <a:ea typeface="Noto Sans CJK JP"/>
-                <a:cs typeface="Noto Sans"/>
-              </a:rPr>
-              <a:t>[1] HELM公開実行 v0.3.0, ICE India / OPT-175B. scenario_stateの実入力から抜粋。 id4 / 文字範囲 [0, 120]</a:t>
+              <a:rPr sz="830">
+                <a:latin typeface="Noto Sans CJK JP"/>
+              </a:rPr>
+              <a:t>[1] Stanford CRFM (2023). HELM Classic: ICE India / OPT-175B.</a:t>
             </a:r>
           </a:p>
           <a:p>
             <a:pPr>
-              <a:lnSpc>
-                <a:spcPts val="940"/>
-              </a:lnSpc>
-              <a:buNone/>
-              <a:defRPr sz="810" b="0">
-                <a:solidFill>
-                  <a:srgbClr val="303437"/>
-                </a:solidFill>
-                <a:latin typeface="Noto Sans"/>
-              </a:defRPr>
-            </a:pPr>
-            <a:r>
-              <a:rPr sz="810" b="0" lang="ja-JP" altLang="en-US">
-                <a:solidFill>
-                  <a:srgbClr val="626669"/>
-                </a:solidFill>
-                <a:latin typeface="Noto Sans"/>
-                <a:ea typeface="Noto Sans CJK JP"/>
-                <a:cs typeface="Noto Sans"/>
+              <a:spcBef>
+                <a:spcPts val="0"/>
+              </a:spcBef>
+              <a:spcAft>
+                <a:spcPts val="0"/>
+              </a:spcAft>
+            </a:pPr>
+            <a:r>
+              <a:rPr sz="830">
+                <a:latin typeface="Noto Sans CJK JP"/>
                 <a:hlinkClick r:id="rId2"/>
               </a:rPr>
               <a:t>https://crfm.stanford.edu/helm/classic/v0.4.0/#/runs/ice:subset=ind,model=together_opt-175b</a:t>
@@ -16924,7 +16577,7 @@
         <p:spPr>
           <a:xfrm>
             <a:off x="548640" y="1719072"/>
-            <a:ext cx="3931920" cy="2363433"/>
+            <a:ext cx="3931920" cy="2321099"/>
           </a:xfrm>
           <a:prstGeom prst="rect">
             <a:avLst/>
@@ -16952,7 +16605,7 @@
           </a:fontRef>
         </p:style>
         <p:txBody>
-          <a:bodyPr rtlCol="0" anchor="t" wrap="square" lIns="177800" rIns="177800" tIns="63500" bIns="127000">
+          <a:bodyPr rtlCol="0" anchor="t" wrap="square" lIns="177800" rIns="177800" tIns="42333" bIns="127000">
             <a:noAutofit/>
           </a:bodyPr>
           <a:lstStyle/>
@@ -16998,7 +16651,7 @@
         <p:spPr>
           <a:xfrm>
             <a:off x="4663440" y="1719072"/>
-            <a:ext cx="3931920" cy="2090129"/>
+            <a:ext cx="3931920" cy="2030862"/>
           </a:xfrm>
           <a:prstGeom prst="rect">
             <a:avLst/>
@@ -17026,7 +16679,7 @@
           </a:fontRef>
         </p:style>
         <p:txBody>
-          <a:bodyPr rtlCol="0" anchor="t" wrap="square" lIns="177800" rIns="177800" tIns="63500" bIns="127000">
+          <a:bodyPr rtlCol="0" anchor="t" wrap="square" lIns="177800" rIns="177800" tIns="59266" bIns="127000">
             <a:noAutofit/>
           </a:bodyPr>
           <a:lstStyle/>
@@ -17071,8 +16724,8 @@
         </p:nvSpPr>
         <p:spPr>
           <a:xfrm>
-            <a:off x="502920" y="4700016"/>
-            <a:ext cx="8183879" cy="530352"/>
+            <a:off x="502920" y="4699000"/>
+            <a:ext cx="8183879" cy="431800"/>
           </a:xfrm>
           <a:prstGeom prst="rect">
             <a:avLst/>
@@ -17093,7 +16746,7 @@
                 <a:spcPts val="0"/>
               </a:spcBef>
               <a:spcAft>
-                <a:spcPts val="140"/>
+                <a:spcPts val="0"/>
               </a:spcAft>
               <a:buNone/>
               <a:defRPr sz="810" b="0">
@@ -17104,38 +16757,24 @@
               </a:defRPr>
             </a:pPr>
             <a:r>
-              <a:rPr sz="810" b="0" lang="ja-JP" altLang="en-US">
-                <a:solidFill>
-                  <a:srgbClr val="626669"/>
-                </a:solidFill>
-                <a:latin typeface="Noto Sans"/>
-                <a:ea typeface="Noto Sans CJK JP"/>
-                <a:cs typeface="Noto Sans"/>
-              </a:rPr>
-              <a:t>[1] HELM公開実行 v0.3.0, ICE India / OPT-175B. scenario_stateの実入力から抜粋。 id6 / 文字範囲 [0, 254]</a:t>
+              <a:rPr sz="830">
+                <a:latin typeface="Noto Sans CJK JP"/>
+              </a:rPr>
+              <a:t>[1] Stanford CRFM (2023). HELM Classic: ICE India / OPT-175B.</a:t>
             </a:r>
           </a:p>
           <a:p>
             <a:pPr>
-              <a:lnSpc>
-                <a:spcPts val="940"/>
-              </a:lnSpc>
-              <a:buNone/>
-              <a:defRPr sz="810" b="0">
-                <a:solidFill>
-                  <a:srgbClr val="303437"/>
-                </a:solidFill>
-                <a:latin typeface="Noto Sans"/>
-              </a:defRPr>
-            </a:pPr>
-            <a:r>
-              <a:rPr sz="810" b="0" lang="ja-JP" altLang="en-US">
-                <a:solidFill>
-                  <a:srgbClr val="626669"/>
-                </a:solidFill>
-                <a:latin typeface="Noto Sans"/>
-                <a:ea typeface="Noto Sans CJK JP"/>
-                <a:cs typeface="Noto Sans"/>
+              <a:spcBef>
+                <a:spcPts val="0"/>
+              </a:spcBef>
+              <a:spcAft>
+                <a:spcPts val="0"/>
+              </a:spcAft>
+            </a:pPr>
+            <a:r>
+              <a:rPr sz="830">
+                <a:latin typeface="Noto Sans CJK JP"/>
                 <a:hlinkClick r:id="rId2"/>
               </a:rPr>
               <a:t>https://crfm.stanford.edu/helm/classic/v0.4.0/#/runs/ice:subset=ind,model=together_opt-175b</a:t>
@@ -17374,7 +17013,7 @@
         <p:spPr>
           <a:xfrm>
             <a:off x="548640" y="1719072"/>
-            <a:ext cx="3931920" cy="2498337"/>
+            <a:ext cx="3931920" cy="2396737"/>
           </a:xfrm>
           <a:prstGeom prst="rect">
             <a:avLst/>
@@ -17402,7 +17041,7 @@
           </a:fontRef>
         </p:style>
         <p:txBody>
-          <a:bodyPr rtlCol="0" anchor="t" wrap="square" lIns="177800" rIns="177800" tIns="63500" bIns="127000">
+          <a:bodyPr rtlCol="0" anchor="t" wrap="square" lIns="177800" rIns="177800" tIns="33866" bIns="127000">
             <a:noAutofit/>
           </a:bodyPr>
           <a:lstStyle/>
@@ -17448,7 +17087,7 @@
         <p:spPr>
           <a:xfrm>
             <a:off x="4663440" y="1719072"/>
-            <a:ext cx="3931920" cy="2362290"/>
+            <a:ext cx="3931920" cy="2303023"/>
           </a:xfrm>
           <a:prstGeom prst="rect">
             <a:avLst/>
@@ -17476,7 +17115,7 @@
           </a:fontRef>
         </p:style>
         <p:txBody>
-          <a:bodyPr rtlCol="0" anchor="t" wrap="square" lIns="177800" rIns="177800" tIns="63500" bIns="127000">
+          <a:bodyPr rtlCol="0" anchor="t" wrap="square" lIns="177800" rIns="177800" tIns="59266" bIns="127000">
             <a:noAutofit/>
           </a:bodyPr>
           <a:lstStyle/>
@@ -17539,7 +17178,7 @@
                 <a:ea typeface="Noto Sans CJK JP"/>
                 <a:cs typeface="Noto Sans"/>
               </a:rPr>
-              <a:t>空から来る殺人の光跡？</a:t>
+              <a:t>空から飛来する殺し屋？</a:t>
             </a:r>
           </a:p>
           <a:p>
@@ -17583,8 +17222,8 @@
         </p:nvSpPr>
         <p:spPr>
           <a:xfrm>
-            <a:off x="502920" y="4700016"/>
-            <a:ext cx="8183879" cy="530352"/>
+            <a:off x="502920" y="4699000"/>
+            <a:ext cx="8183879" cy="431800"/>
           </a:xfrm>
           <a:prstGeom prst="rect">
             <a:avLst/>
@@ -17605,7 +17244,7 @@
                 <a:spcPts val="0"/>
               </a:spcBef>
               <a:spcAft>
-                <a:spcPts val="140"/>
+                <a:spcPts val="0"/>
               </a:spcAft>
               <a:buNone/>
               <a:defRPr sz="810" b="0">
@@ -17616,38 +17255,24 @@
               </a:defRPr>
             </a:pPr>
             <a:r>
-              <a:rPr sz="810" b="0" lang="ja-JP" altLang="en-US">
-                <a:solidFill>
-                  <a:srgbClr val="626669"/>
-                </a:solidFill>
-                <a:latin typeface="Noto Sans"/>
-                <a:ea typeface="Noto Sans CJK JP"/>
-                <a:cs typeface="Noto Sans"/>
-              </a:rPr>
-              <a:t>[1] HELM公開実行 v0.3.0, ICE India / OPT-175B. scenario_stateの実入力から抜粋。 id10 / 文字範囲 [0, 305]</a:t>
+              <a:rPr sz="830">
+                <a:latin typeface="Noto Sans CJK JP"/>
+              </a:rPr>
+              <a:t>[1] Stanford CRFM (2023). HELM Classic: ICE India / OPT-175B.</a:t>
             </a:r>
           </a:p>
           <a:p>
             <a:pPr>
-              <a:lnSpc>
-                <a:spcPts val="940"/>
-              </a:lnSpc>
-              <a:buNone/>
-              <a:defRPr sz="810" b="0">
-                <a:solidFill>
-                  <a:srgbClr val="303437"/>
-                </a:solidFill>
-                <a:latin typeface="Noto Sans"/>
-              </a:defRPr>
-            </a:pPr>
-            <a:r>
-              <a:rPr sz="810" b="0" lang="ja-JP" altLang="en-US">
-                <a:solidFill>
-                  <a:srgbClr val="626669"/>
-                </a:solidFill>
-                <a:latin typeface="Noto Sans"/>
-                <a:ea typeface="Noto Sans CJK JP"/>
-                <a:cs typeface="Noto Sans"/>
+              <a:spcBef>
+                <a:spcPts val="0"/>
+              </a:spcBef>
+              <a:spcAft>
+                <a:spcPts val="0"/>
+              </a:spcAft>
+            </a:pPr>
+            <a:r>
+              <a:rPr sz="830">
+                <a:latin typeface="Noto Sans CJK JP"/>
                 <a:hlinkClick r:id="rId2"/>
               </a:rPr>
               <a:t>https://crfm.stanford.edu/helm/classic/v0.4.0/#/runs/ice:subset=ind,model=together_opt-175b</a:t>
@@ -17886,7 +17511,7 @@
         <p:spPr>
           <a:xfrm>
             <a:off x="548640" y="1719072"/>
-            <a:ext cx="3931920" cy="2593815"/>
+            <a:ext cx="3931920" cy="2517615"/>
           </a:xfrm>
           <a:prstGeom prst="rect">
             <a:avLst/>
@@ -17914,7 +17539,7 @@
           </a:fontRef>
         </p:style>
         <p:txBody>
-          <a:bodyPr rtlCol="0" anchor="t" wrap="square" lIns="177800" rIns="177800" tIns="63500" bIns="127000">
+          <a:bodyPr rtlCol="0" anchor="t" wrap="square" lIns="177800" rIns="177800" tIns="50800" bIns="127000">
             <a:noAutofit/>
           </a:bodyPr>
           <a:lstStyle/>
@@ -17960,7 +17585,7 @@
         <p:spPr>
           <a:xfrm>
             <a:off x="4663440" y="1719072"/>
-            <a:ext cx="3931920" cy="2497257"/>
+            <a:ext cx="3931920" cy="2446457"/>
           </a:xfrm>
           <a:prstGeom prst="rect">
             <a:avLst/>
@@ -17988,7 +17613,7 @@
           </a:fontRef>
         </p:style>
         <p:txBody>
-          <a:bodyPr rtlCol="0" anchor="t" wrap="square" lIns="177800" rIns="177800" tIns="63500" bIns="127000">
+          <a:bodyPr rtlCol="0" anchor="t" wrap="square" lIns="177800" rIns="177800" tIns="59266" bIns="127000">
             <a:noAutofit/>
           </a:bodyPr>
           <a:lstStyle/>
@@ -18095,8 +17720,8 @@
         </p:nvSpPr>
         <p:spPr>
           <a:xfrm>
-            <a:off x="502920" y="4700016"/>
-            <a:ext cx="8183879" cy="530352"/>
+            <a:off x="502920" y="4699000"/>
+            <a:ext cx="8183879" cy="431800"/>
           </a:xfrm>
           <a:prstGeom prst="rect">
             <a:avLst/>
@@ -18117,7 +17742,7 @@
                 <a:spcPts val="0"/>
               </a:spcBef>
               <a:spcAft>
-                <a:spcPts val="140"/>
+                <a:spcPts val="0"/>
               </a:spcAft>
               <a:buNone/>
               <a:defRPr sz="810" b="0">
@@ -18128,38 +17753,24 @@
               </a:defRPr>
             </a:pPr>
             <a:r>
-              <a:rPr sz="810" b="0" lang="ja-JP" altLang="en-US">
-                <a:solidFill>
-                  <a:srgbClr val="626669"/>
-                </a:solidFill>
-                <a:latin typeface="Noto Sans"/>
-                <a:ea typeface="Noto Sans CJK JP"/>
-                <a:cs typeface="Noto Sans"/>
-              </a:rPr>
-              <a:t>[1] HELM公開実行 v0.3.0, ICE India / OPT-175B. scenario_stateの実入力から抜粋。 id13 / 文字範囲 [0, 438]</a:t>
+              <a:rPr sz="830">
+                <a:latin typeface="Noto Sans CJK JP"/>
+              </a:rPr>
+              <a:t>[1] Stanford CRFM (2023). HELM Classic: ICE India / OPT-175B.</a:t>
             </a:r>
           </a:p>
           <a:p>
             <a:pPr>
-              <a:lnSpc>
-                <a:spcPts val="940"/>
-              </a:lnSpc>
-              <a:buNone/>
-              <a:defRPr sz="810" b="0">
-                <a:solidFill>
-                  <a:srgbClr val="303437"/>
-                </a:solidFill>
-                <a:latin typeface="Noto Sans"/>
-              </a:defRPr>
-            </a:pPr>
-            <a:r>
-              <a:rPr sz="810" b="0" lang="ja-JP" altLang="en-US">
-                <a:solidFill>
-                  <a:srgbClr val="626669"/>
-                </a:solidFill>
-                <a:latin typeface="Noto Sans"/>
-                <a:ea typeface="Noto Sans CJK JP"/>
-                <a:cs typeface="Noto Sans"/>
+              <a:spcBef>
+                <a:spcPts val="0"/>
+              </a:spcBef>
+              <a:spcAft>
+                <a:spcPts val="0"/>
+              </a:spcAft>
+            </a:pPr>
+            <a:r>
+              <a:rPr sz="830">
+                <a:latin typeface="Noto Sans CJK JP"/>
                 <a:hlinkClick r:id="rId2"/>
               </a:rPr>
               <a:t>https://crfm.stanford.edu/helm/classic/v0.4.0/#/runs/ice:subset=ind,model=together_opt-175b</a:t>
@@ -18398,7 +18009,7 @@
         <p:spPr>
           <a:xfrm>
             <a:off x="548640" y="1719072"/>
-            <a:ext cx="3931920" cy="2761315"/>
+            <a:ext cx="3931920" cy="2710515"/>
           </a:xfrm>
           <a:prstGeom prst="rect">
             <a:avLst/>
@@ -18426,7 +18037,7 @@
           </a:fontRef>
         </p:style>
         <p:txBody>
-          <a:bodyPr rtlCol="0" anchor="t" wrap="square" lIns="177800" rIns="177800" tIns="63500" bIns="127000">
+          <a:bodyPr rtlCol="0" anchor="t" wrap="square" lIns="177800" rIns="177800" tIns="33866" bIns="127000">
             <a:noAutofit/>
           </a:bodyPr>
           <a:lstStyle/>
@@ -18472,7 +18083,7 @@
         <p:spPr>
           <a:xfrm>
             <a:off x="4663440" y="1719072"/>
-            <a:ext cx="3931920" cy="2362290"/>
+            <a:ext cx="3931920" cy="2303023"/>
           </a:xfrm>
           <a:prstGeom prst="rect">
             <a:avLst/>
@@ -18500,7 +18111,7 @@
           </a:fontRef>
         </p:style>
         <p:txBody>
-          <a:bodyPr rtlCol="0" anchor="t" wrap="square" lIns="177800" rIns="177800" tIns="63500" bIns="127000">
+          <a:bodyPr rtlCol="0" anchor="t" wrap="square" lIns="177800" rIns="177800" tIns="59266" bIns="127000">
             <a:noAutofit/>
           </a:bodyPr>
           <a:lstStyle/>
@@ -18576,8 +18187,8 @@
         </p:nvSpPr>
         <p:spPr>
           <a:xfrm>
-            <a:off x="502920" y="4700016"/>
-            <a:ext cx="8183879" cy="530352"/>
+            <a:off x="502920" y="4699000"/>
+            <a:ext cx="8183879" cy="431800"/>
           </a:xfrm>
           <a:prstGeom prst="rect">
             <a:avLst/>
@@ -18598,7 +18209,7 @@
                 <a:spcPts val="0"/>
               </a:spcBef>
               <a:spcAft>
-                <a:spcPts val="140"/>
+                <a:spcPts val="0"/>
               </a:spcAft>
               <a:buNone/>
               <a:defRPr sz="810" b="0">
@@ -18609,38 +18220,24 @@
               </a:defRPr>
             </a:pPr>
             <a:r>
-              <a:rPr sz="810" b="0" lang="ja-JP" altLang="en-US">
-                <a:solidFill>
-                  <a:srgbClr val="626669"/>
-                </a:solidFill>
-                <a:latin typeface="Noto Sans"/>
-                <a:ea typeface="Noto Sans CJK JP"/>
-                <a:cs typeface="Noto Sans"/>
-              </a:rPr>
-              <a:t>[1] HELM公開実行 v0.3.0, ICE India / OPT-175B. scenario_stateの実入力から抜粋。 id14 / 文字範囲 [0, 365]</a:t>
+              <a:rPr sz="830">
+                <a:latin typeface="Noto Sans CJK JP"/>
+              </a:rPr>
+              <a:t>[1] Stanford CRFM (2023). HELM Classic: ICE India / OPT-175B.</a:t>
             </a:r>
           </a:p>
           <a:p>
             <a:pPr>
-              <a:lnSpc>
-                <a:spcPts val="940"/>
-              </a:lnSpc>
-              <a:buNone/>
-              <a:defRPr sz="810" b="0">
-                <a:solidFill>
-                  <a:srgbClr val="303437"/>
-                </a:solidFill>
-                <a:latin typeface="Noto Sans"/>
-              </a:defRPr>
-            </a:pPr>
-            <a:r>
-              <a:rPr sz="810" b="0" lang="ja-JP" altLang="en-US">
-                <a:solidFill>
-                  <a:srgbClr val="626669"/>
-                </a:solidFill>
-                <a:latin typeface="Noto Sans"/>
-                <a:ea typeface="Noto Sans CJK JP"/>
-                <a:cs typeface="Noto Sans"/>
+              <a:spcBef>
+                <a:spcPts val="0"/>
+              </a:spcBef>
+              <a:spcAft>
+                <a:spcPts val="0"/>
+              </a:spcAft>
+            </a:pPr>
+            <a:r>
+              <a:rPr sz="830">
+                <a:latin typeface="Noto Sans CJK JP"/>
                 <a:hlinkClick r:id="rId2"/>
               </a:rPr>
               <a:t>https://crfm.stanford.edu/helm/classic/v0.4.0/#/runs/ice:subset=ind,model=together_opt-175b</a:t>
@@ -18879,7 +18476,7 @@
         <p:spPr>
           <a:xfrm>
             <a:off x="548640" y="1719072"/>
-            <a:ext cx="3931920" cy="2363433"/>
+            <a:ext cx="3931920" cy="2295699"/>
           </a:xfrm>
           <a:prstGeom prst="rect">
             <a:avLst/>
@@ -18907,7 +18504,7 @@
           </a:fontRef>
         </p:style>
         <p:txBody>
-          <a:bodyPr rtlCol="0" anchor="t" wrap="square" lIns="177800" rIns="177800" tIns="63500" bIns="127000">
+          <a:bodyPr rtlCol="0" anchor="t" wrap="square" lIns="177800" rIns="177800" tIns="42333" bIns="127000">
             <a:noAutofit/>
           </a:bodyPr>
           <a:lstStyle/>
@@ -18953,7 +18550,7 @@
         <p:spPr>
           <a:xfrm>
             <a:off x="4663440" y="1719072"/>
-            <a:ext cx="3931920" cy="2362290"/>
+            <a:ext cx="3931920" cy="2286090"/>
           </a:xfrm>
           <a:prstGeom prst="rect">
             <a:avLst/>
@@ -18981,7 +18578,7 @@
           </a:fontRef>
         </p:style>
         <p:txBody>
-          <a:bodyPr rtlCol="0" anchor="t" wrap="square" lIns="177800" rIns="177800" tIns="63500" bIns="127000">
+          <a:bodyPr rtlCol="0" anchor="t" wrap="square" lIns="177800" rIns="177800" tIns="42333" bIns="127000">
             <a:noAutofit/>
           </a:bodyPr>
           <a:lstStyle/>
@@ -19088,8 +18685,8 @@
         </p:nvSpPr>
         <p:spPr>
           <a:xfrm>
-            <a:off x="502920" y="4700016"/>
-            <a:ext cx="8183879" cy="530352"/>
+            <a:off x="502920" y="4699000"/>
+            <a:ext cx="8183879" cy="431800"/>
           </a:xfrm>
           <a:prstGeom prst="rect">
             <a:avLst/>
@@ -19110,7 +18707,7 @@
                 <a:spcPts val="0"/>
               </a:spcBef>
               <a:spcAft>
-                <a:spcPts val="140"/>
+                <a:spcPts val="0"/>
               </a:spcAft>
               <a:buNone/>
               <a:defRPr sz="810" b="0">
@@ -19121,38 +18718,24 @@
               </a:defRPr>
             </a:pPr>
             <a:r>
-              <a:rPr sz="810" b="0" lang="ja-JP" altLang="en-US">
-                <a:solidFill>
-                  <a:srgbClr val="626669"/>
-                </a:solidFill>
-                <a:latin typeface="Noto Sans"/>
-                <a:ea typeface="Noto Sans CJK JP"/>
-                <a:cs typeface="Noto Sans"/>
-              </a:rPr>
-              <a:t>[1] HELM公開実行 v0.3.0, ICE India / OPT-175B. scenario_stateの実入力から抜粋。 id18 / 文字範囲 [0, 256]</a:t>
+              <a:rPr sz="830">
+                <a:latin typeface="Noto Sans CJK JP"/>
+              </a:rPr>
+              <a:t>[1] Stanford CRFM (2023). HELM Classic: ICE India / OPT-175B.</a:t>
             </a:r>
           </a:p>
           <a:p>
             <a:pPr>
-              <a:lnSpc>
-                <a:spcPts val="940"/>
-              </a:lnSpc>
-              <a:buNone/>
-              <a:defRPr sz="810" b="0">
-                <a:solidFill>
-                  <a:srgbClr val="303437"/>
-                </a:solidFill>
-                <a:latin typeface="Noto Sans"/>
-              </a:defRPr>
-            </a:pPr>
-            <a:r>
-              <a:rPr sz="810" b="0" lang="ja-JP" altLang="en-US">
-                <a:solidFill>
-                  <a:srgbClr val="626669"/>
-                </a:solidFill>
-                <a:latin typeface="Noto Sans"/>
-                <a:ea typeface="Noto Sans CJK JP"/>
-                <a:cs typeface="Noto Sans"/>
+              <a:spcBef>
+                <a:spcPts val="0"/>
+              </a:spcBef>
+              <a:spcAft>
+                <a:spcPts val="0"/>
+              </a:spcAft>
+            </a:pPr>
+            <a:r>
+              <a:rPr sz="830">
+                <a:latin typeface="Noto Sans CJK JP"/>
                 <a:hlinkClick r:id="rId2"/>
               </a:rPr>
               <a:t>https://crfm.stanford.edu/helm/classic/v0.4.0/#/runs/ice:subset=ind,model=together_opt-175b</a:t>
@@ -19445,7 +19028,7 @@
         <p:spPr>
           <a:xfrm>
             <a:off x="548640" y="1719072"/>
-            <a:ext cx="3931920" cy="2635226"/>
+            <a:ext cx="3931920" cy="2592892"/>
           </a:xfrm>
           <a:prstGeom prst="rect">
             <a:avLst/>
@@ -19473,7 +19056,7 @@
           </a:fontRef>
         </p:style>
         <p:txBody>
-          <a:bodyPr rtlCol="0" anchor="t" wrap="square" lIns="177800" rIns="177800" tIns="63500" bIns="127000">
+          <a:bodyPr rtlCol="0" anchor="t" wrap="square" lIns="177800" rIns="177800" tIns="42333" bIns="127000">
             <a:noAutofit/>
           </a:bodyPr>
           <a:lstStyle/>
@@ -19519,7 +19102,7 @@
         <p:spPr>
           <a:xfrm>
             <a:off x="4663440" y="1719072"/>
-            <a:ext cx="3931920" cy="2634083"/>
+            <a:ext cx="3931920" cy="2566349"/>
           </a:xfrm>
           <a:prstGeom prst="rect">
             <a:avLst/>
@@ -19547,7 +19130,7 @@
           </a:fontRef>
         </p:style>
         <p:txBody>
-          <a:bodyPr rtlCol="0" anchor="t" wrap="square" lIns="177800" rIns="177800" tIns="63500" bIns="127000">
+          <a:bodyPr rtlCol="0" anchor="t" wrap="square" lIns="177800" rIns="177800" tIns="59266" bIns="127000">
             <a:noAutofit/>
           </a:bodyPr>
           <a:lstStyle/>
@@ -19579,7 +19162,7 @@
                 <a:ea typeface="Noto Sans CJK JP"/>
                 <a:cs typeface="Noto Sans"/>
               </a:rPr>
-              <a:t>&lt;$A&gt; ああ、ええと、ありがとうございます。コーリ教授に素晴らしいお言葉をいただきました。私がどれほどそれに値するかは分かりませんが。</a:t>
+              <a:t>&lt;$A&gt; ああ、ええと、ありがとうございます。コーリ教授に素晴らしいお言葉をいただきました。私がどれほどそのお言葉にふさわしいかは分かりませんが。</a:t>
             </a:r>
           </a:p>
           <a:p>
@@ -19623,8 +19206,8 @@
         </p:nvSpPr>
         <p:spPr>
           <a:xfrm>
-            <a:off x="502920" y="4700016"/>
-            <a:ext cx="8183879" cy="530352"/>
+            <a:off x="502920" y="4699000"/>
+            <a:ext cx="8183879" cy="431800"/>
           </a:xfrm>
           <a:prstGeom prst="rect">
             <a:avLst/>
@@ -19645,7 +19228,7 @@
                 <a:spcPts val="0"/>
               </a:spcBef>
               <a:spcAft>
-                <a:spcPts val="140"/>
+                <a:spcPts val="0"/>
               </a:spcAft>
               <a:buNone/>
               <a:defRPr sz="810" b="0">
@@ -19656,38 +19239,24 @@
               </a:defRPr>
             </a:pPr>
             <a:r>
-              <a:rPr sz="810" b="0" lang="ja-JP" altLang="en-US">
-                <a:solidFill>
-                  <a:srgbClr val="626669"/>
-                </a:solidFill>
-                <a:latin typeface="Noto Sans"/>
-                <a:ea typeface="Noto Sans CJK JP"/>
-                <a:cs typeface="Noto Sans"/>
-              </a:rPr>
-              <a:t>[1] HELM公開実行 v0.3.0, ICE India / OPT-175B. scenario_stateの実入力から抜粋。 id22 / 文字範囲 [0, 277]</a:t>
+              <a:rPr sz="830">
+                <a:latin typeface="Noto Sans CJK JP"/>
+              </a:rPr>
+              <a:t>[1] Stanford CRFM (2023). HELM Classic: ICE India / OPT-175B.</a:t>
             </a:r>
           </a:p>
           <a:p>
             <a:pPr>
-              <a:lnSpc>
-                <a:spcPts val="940"/>
-              </a:lnSpc>
-              <a:buNone/>
-              <a:defRPr sz="810" b="0">
-                <a:solidFill>
-                  <a:srgbClr val="303437"/>
-                </a:solidFill>
-                <a:latin typeface="Noto Sans"/>
-              </a:defRPr>
-            </a:pPr>
-            <a:r>
-              <a:rPr sz="810" b="0" lang="ja-JP" altLang="en-US">
-                <a:solidFill>
-                  <a:srgbClr val="626669"/>
-                </a:solidFill>
-                <a:latin typeface="Noto Sans"/>
-                <a:ea typeface="Noto Sans CJK JP"/>
-                <a:cs typeface="Noto Sans"/>
+              <a:spcBef>
+                <a:spcPts val="0"/>
+              </a:spcBef>
+              <a:spcAft>
+                <a:spcPts val="0"/>
+              </a:spcAft>
+            </a:pPr>
+            <a:r>
+              <a:rPr sz="830">
+                <a:latin typeface="Noto Sans CJK JP"/>
                 <a:hlinkClick r:id="rId2"/>
               </a:rPr>
               <a:t>https://crfm.stanford.edu/helm/classic/v0.4.0/#/runs/ice:subset=ind,model=together_opt-175b</a:t>
@@ -19726,11 +19295,11 @@
         <p:spPr>
           <a:xfrm>
             <a:off x="548640" y="2506875"/>
-            <a:ext cx="8046720" cy="585216"/>
+            <a:ext cx="8046720" cy="737616"/>
           </a:xfrm>
         </p:spPr>
         <p:txBody>
-          <a:bodyPr wrap="square" lIns="0" rIns="0" tIns="0" bIns="0" anchor="ctr">
+          <a:bodyPr wrap="square" lIns="0" rIns="0" tIns="0" bIns="152400" anchor="ctr">
             <a:noAutofit/>
           </a:bodyPr>
           <a:lstStyle/>
@@ -20040,7 +19609,7 @@
         <p:spPr>
           <a:xfrm>
             <a:off x="548640" y="1719072"/>
-            <a:ext cx="3931920" cy="2755017"/>
+            <a:ext cx="3931920" cy="2712683"/>
           </a:xfrm>
           <a:prstGeom prst="rect">
             <a:avLst/>
@@ -20068,7 +19637,7 @@
           </a:fontRef>
         </p:style>
         <p:txBody>
-          <a:bodyPr rtlCol="0" anchor="t" wrap="square" lIns="177800" rIns="177800" tIns="63500" bIns="127000">
+          <a:bodyPr rtlCol="0" anchor="t" wrap="square" lIns="177800" rIns="177800" tIns="42333" bIns="127000">
             <a:noAutofit/>
           </a:bodyPr>
           <a:lstStyle/>
@@ -20114,7 +19683,7 @@
         <p:spPr>
           <a:xfrm>
             <a:off x="4663440" y="1719072"/>
-            <a:ext cx="3931920" cy="2362290"/>
+            <a:ext cx="3931920" cy="2303023"/>
           </a:xfrm>
           <a:prstGeom prst="rect">
             <a:avLst/>
@@ -20142,7 +19711,7 @@
           </a:fontRef>
         </p:style>
         <p:txBody>
-          <a:bodyPr rtlCol="0" anchor="t" wrap="square" lIns="177800" rIns="177800" tIns="63500" bIns="127000">
+          <a:bodyPr rtlCol="0" anchor="t" wrap="square" lIns="177800" rIns="177800" tIns="59266" bIns="127000">
             <a:noAutofit/>
           </a:bodyPr>
           <a:lstStyle/>
@@ -20236,7 +19805,7 @@
                 <a:ea typeface="Noto Sans CJK JP"/>
                 <a:cs typeface="Noto Sans"/>
               </a:rPr>
-              <a:t>インド準備銀行は1989〜90年の通貨・金融報告で、今年度の赤字が拡大すると予測し、安定した成長を促すため、深刻な財政不均衡を減らす調整を求めた。</a:t>
+              <a:t>インド準備銀行は1989〜90年の通貨・金融報告で、今年度の赤字が拡大すると予測し、安定した成長を促すため、深刻な財政不均衡を是正する措置を求めた。</a:t>
             </a:r>
           </a:p>
         </p:txBody>
@@ -20249,8 +19818,8 @@
         </p:nvSpPr>
         <p:spPr>
           <a:xfrm>
-            <a:off x="502920" y="4700016"/>
-            <a:ext cx="8183879" cy="530352"/>
+            <a:off x="502920" y="4699000"/>
+            <a:ext cx="8183879" cy="431800"/>
           </a:xfrm>
           <a:prstGeom prst="rect">
             <a:avLst/>
@@ -20271,7 +19840,7 @@
                 <a:spcPts val="0"/>
               </a:spcBef>
               <a:spcAft>
-                <a:spcPts val="140"/>
+                <a:spcPts val="0"/>
               </a:spcAft>
               <a:buNone/>
               <a:defRPr sz="810" b="0">
@@ -20282,38 +19851,24 @@
               </a:defRPr>
             </a:pPr>
             <a:r>
-              <a:rPr sz="810" b="0" lang="ja-JP" altLang="en-US">
-                <a:solidFill>
-                  <a:srgbClr val="626669"/>
-                </a:solidFill>
-                <a:latin typeface="Noto Sans"/>
-                <a:ea typeface="Noto Sans CJK JP"/>
-                <a:cs typeface="Noto Sans"/>
-              </a:rPr>
-              <a:t>[1] HELM公開実行 v0.3.0, ICE India / OPT-175B. scenario_stateの実入力から抜粋。 id23 / 文字範囲 [0, 340]</a:t>
+              <a:rPr sz="830">
+                <a:latin typeface="Noto Sans CJK JP"/>
+              </a:rPr>
+              <a:t>[1] Stanford CRFM (2023). HELM Classic: ICE India / OPT-175B.</a:t>
             </a:r>
           </a:p>
           <a:p>
             <a:pPr>
-              <a:lnSpc>
-                <a:spcPts val="940"/>
-              </a:lnSpc>
-              <a:buNone/>
-              <a:defRPr sz="810" b="0">
-                <a:solidFill>
-                  <a:srgbClr val="303437"/>
-                </a:solidFill>
-                <a:latin typeface="Noto Sans"/>
-              </a:defRPr>
-            </a:pPr>
-            <a:r>
-              <a:rPr sz="810" b="0" lang="ja-JP" altLang="en-US">
-                <a:solidFill>
-                  <a:srgbClr val="626669"/>
-                </a:solidFill>
-                <a:latin typeface="Noto Sans"/>
-                <a:ea typeface="Noto Sans CJK JP"/>
-                <a:cs typeface="Noto Sans"/>
+              <a:spcBef>
+                <a:spcPts val="0"/>
+              </a:spcBef>
+              <a:spcAft>
+                <a:spcPts val="0"/>
+              </a:spcAft>
+            </a:pPr>
+            <a:r>
+              <a:rPr sz="830">
+                <a:latin typeface="Noto Sans CJK JP"/>
                 <a:hlinkClick r:id="rId2"/>
               </a:rPr>
               <a:t>https://crfm.stanford.edu/helm/classic/v0.4.0/#/runs/ice:subset=ind,model=together_opt-175b</a:t>
@@ -20430,7 +19985,7 @@
                 <a:ea typeface="Noto Sans CJK JP"/>
                 <a:cs typeface="Noto Sans"/>
               </a:rPr>
-              <a:t>Appendix: 2. 構成と実行条件の補足</a:t>
+              <a:t>Appendix: 2. 収録ジャンルと評価対象</a:t>
             </a:r>
           </a:p>
         </p:txBody>
@@ -21264,8 +20819,8 @@
         </p:nvSpPr>
         <p:spPr>
           <a:xfrm>
-            <a:off x="502920" y="4700016"/>
-            <a:ext cx="8183879" cy="530352"/>
+            <a:off x="502920" y="4699000"/>
+            <a:ext cx="8183879" cy="431800"/>
           </a:xfrm>
           <a:prstGeom prst="rect">
             <a:avLst/>
@@ -21286,7 +20841,7 @@
                 <a:spcPts val="0"/>
               </a:spcBef>
               <a:spcAft>
-                <a:spcPts val="140"/>
+                <a:spcPts val="0"/>
               </a:spcAft>
               <a:buNone/>
               <a:defRPr sz="810" b="0">
@@ -21297,35 +20852,24 @@
               </a:defRPr>
             </a:pPr>
             <a:r>
-              <a:rPr sz="810" b="0" lang="ja-JP" altLang="en-US">
-                <a:solidFill>
-                  <a:srgbClr val="626669"/>
-                </a:solidFill>
-                <a:latin typeface="Noto Sans"/>
-                <a:ea typeface="Noto Sans CJK JP"/>
-                <a:cs typeface="Noto Sans"/>
+              <a:rPr sz="830">
+                <a:latin typeface="Noto Sans CJK JP"/>
               </a:rPr>
               <a:t>[1] International Corpus of English. Design of ICE Corpora.</a:t>
             </a:r>
-            <a:r>
-              <a:rPr sz="810" b="0" lang="ja-JP" altLang="en-US">
-                <a:solidFill>
-                  <a:srgbClr val="626669"/>
-                </a:solidFill>
-                <a:latin typeface="Noto Sans"/>
-                <a:ea typeface="Noto Sans CJK JP"/>
-                <a:cs typeface="Noto Sans"/>
-              </a:rPr>
-              <a:t>  </a:t>
-            </a:r>
-            <a:r>
-              <a:rPr sz="810" b="0" lang="ja-JP" altLang="en-US">
-                <a:solidFill>
-                  <a:srgbClr val="626669"/>
-                </a:solidFill>
-                <a:latin typeface="Noto Sans"/>
-                <a:ea typeface="Noto Sans CJK JP"/>
-                <a:cs typeface="Noto Sans"/>
+          </a:p>
+          <a:p>
+            <a:pPr>
+              <a:spcBef>
+                <a:spcPts val="0"/>
+              </a:spcBef>
+              <a:spcAft>
+                <a:spcPts val="0"/>
+              </a:spcAft>
+            </a:pPr>
+            <a:r>
+              <a:rPr sz="830">
+                <a:latin typeface="Noto Sans CJK JP"/>
                 <a:hlinkClick r:id="rId2"/>
               </a:rPr>
               <a:t>https://www.ice-corpora.uzh.ch/en/design.html</a:t>
@@ -21442,7 +20986,7 @@
                 <a:ea typeface="Noto Sans CJK JP"/>
                 <a:cs typeface="Noto Sans"/>
               </a:rPr>
-              <a:t>Appendix: 2. 構成と実行条件の補足</a:t>
+              <a:t>Appendix: 2. 収録ジャンルと評価対象</a:t>
             </a:r>
           </a:p>
         </p:txBody>
@@ -22276,8 +21820,8 @@
         </p:nvSpPr>
         <p:spPr>
           <a:xfrm>
-            <a:off x="502920" y="4700016"/>
-            <a:ext cx="8183879" cy="530352"/>
+            <a:off x="502920" y="4699000"/>
+            <a:ext cx="8183879" cy="431800"/>
           </a:xfrm>
           <a:prstGeom prst="rect">
             <a:avLst/>
@@ -22298,7 +21842,7 @@
                 <a:spcPts val="0"/>
               </a:spcBef>
               <a:spcAft>
-                <a:spcPts val="140"/>
+                <a:spcPts val="0"/>
               </a:spcAft>
               <a:buNone/>
               <a:defRPr sz="810" b="0">
@@ -22309,35 +21853,24 @@
               </a:defRPr>
             </a:pPr>
             <a:r>
-              <a:rPr sz="810" b="0" lang="ja-JP" altLang="en-US">
-                <a:solidFill>
-                  <a:srgbClr val="626669"/>
-                </a:solidFill>
-                <a:latin typeface="Noto Sans"/>
-                <a:ea typeface="Noto Sans CJK JP"/>
-                <a:cs typeface="Noto Sans"/>
+              <a:rPr sz="830">
+                <a:latin typeface="Noto Sans CJK JP"/>
               </a:rPr>
               <a:t>[1] International Corpus of English. Design of ICE Corpora.</a:t>
             </a:r>
-            <a:r>
-              <a:rPr sz="810" b="0" lang="ja-JP" altLang="en-US">
-                <a:solidFill>
-                  <a:srgbClr val="626669"/>
-                </a:solidFill>
-                <a:latin typeface="Noto Sans"/>
-                <a:ea typeface="Noto Sans CJK JP"/>
-                <a:cs typeface="Noto Sans"/>
-              </a:rPr>
-              <a:t>  </a:t>
-            </a:r>
-            <a:r>
-              <a:rPr sz="810" b="0" lang="ja-JP" altLang="en-US">
-                <a:solidFill>
-                  <a:srgbClr val="626669"/>
-                </a:solidFill>
-                <a:latin typeface="Noto Sans"/>
-                <a:ea typeface="Noto Sans CJK JP"/>
-                <a:cs typeface="Noto Sans"/>
+          </a:p>
+          <a:p>
+            <a:pPr>
+              <a:spcBef>
+                <a:spcPts val="0"/>
+              </a:spcBef>
+              <a:spcAft>
+                <a:spcPts val="0"/>
+              </a:spcAft>
+            </a:pPr>
+            <a:r>
+              <a:rPr sz="830">
+                <a:latin typeface="Noto Sans CJK JP"/>
                 <a:hlinkClick r:id="rId2"/>
               </a:rPr>
               <a:t>https://www.ice-corpora.uzh.ch/en/design.html</a:t>
@@ -22454,7 +21987,7 @@
                 <a:ea typeface="Noto Sans CJK JP"/>
                 <a:cs typeface="Noto Sans"/>
               </a:rPr>
-              <a:t>Appendix: 2. 構成と実行条件の補足</a:t>
+              <a:t>Appendix: 2. 収録ジャンルと評価対象</a:t>
             </a:r>
           </a:p>
         </p:txBody>
@@ -23025,8 +22558,8 @@
         </p:nvSpPr>
         <p:spPr>
           <a:xfrm>
-            <a:off x="502920" y="4700016"/>
-            <a:ext cx="8183879" cy="530352"/>
+            <a:off x="502920" y="4699000"/>
+            <a:ext cx="8183879" cy="431800"/>
           </a:xfrm>
           <a:prstGeom prst="rect">
             <a:avLst/>
@@ -23047,7 +22580,7 @@
                 <a:spcPts val="0"/>
               </a:spcBef>
               <a:spcAft>
-                <a:spcPts val="140"/>
+                <a:spcPts val="0"/>
               </a:spcAft>
               <a:buNone/>
               <a:defRPr sz="810" b="0">
@@ -23058,35 +22591,24 @@
               </a:defRPr>
             </a:pPr>
             <a:r>
-              <a:rPr sz="810" b="0" lang="ja-JP" altLang="en-US">
-                <a:solidFill>
-                  <a:srgbClr val="626669"/>
-                </a:solidFill>
-                <a:latin typeface="Noto Sans"/>
-                <a:ea typeface="Noto Sans CJK JP"/>
-                <a:cs typeface="Noto Sans"/>
+              <a:rPr sz="830">
+                <a:latin typeface="Noto Sans CJK JP"/>
               </a:rPr>
               <a:t>[1] International Corpus of English. Design of ICE Corpora.</a:t>
             </a:r>
-            <a:r>
-              <a:rPr sz="810" b="0" lang="ja-JP" altLang="en-US">
-                <a:solidFill>
-                  <a:srgbClr val="626669"/>
-                </a:solidFill>
-                <a:latin typeface="Noto Sans"/>
-                <a:ea typeface="Noto Sans CJK JP"/>
-                <a:cs typeface="Noto Sans"/>
-              </a:rPr>
-              <a:t>  </a:t>
-            </a:r>
-            <a:r>
-              <a:rPr sz="810" b="0" lang="ja-JP" altLang="en-US">
-                <a:solidFill>
-                  <a:srgbClr val="626669"/>
-                </a:solidFill>
-                <a:latin typeface="Noto Sans"/>
-                <a:ea typeface="Noto Sans CJK JP"/>
-                <a:cs typeface="Noto Sans"/>
+          </a:p>
+          <a:p>
+            <a:pPr>
+              <a:spcBef>
+                <a:spcPts val="0"/>
+              </a:spcBef>
+              <a:spcAft>
+                <a:spcPts val="0"/>
+              </a:spcAft>
+            </a:pPr>
+            <a:r>
+              <a:rPr sz="830">
+                <a:latin typeface="Noto Sans CJK JP"/>
                 <a:hlinkClick r:id="rId2"/>
               </a:rPr>
               <a:t>https://www.ice-corpora.uzh.ch/en/design.html</a:t>
@@ -23155,7 +22677,7 @@
                 <a:ea typeface="Noto Sans CJK JP"/>
                 <a:cs typeface="Noto Sans"/>
               </a:rPr>
-              <a:t>シナリオの実装と説明文の違い</a:t>
+              <a:t>地域とジャンルを選んで、HELMへ読み込む</a:t>
             </a:r>
           </a:p>
         </p:txBody>
@@ -23208,7 +22730,7 @@
                 <a:ea typeface="Noto Sans CJK JP"/>
                 <a:cs typeface="Noto Sans"/>
               </a:rPr>
-              <a:t>ICESubsetの列挙にはcan、ja、hk、ind、sin、phi、usa、ea、irlの9地域がある。説明文に残る「当初7地域」とは範囲が異なる。</a:t>
+              <a:t>HELMの実装は、Canada、Jamaica、Hong Kong、India、Singapore、Philippines、USA、East Africa、Irelandの9地域に対応する。コーパス本体は、各配布元で取得する。</a:t>
             </a:r>
           </a:p>
           <a:p>
@@ -23238,37 +22760,7 @@
                 <a:ea typeface="Noto Sans CJK JP"/>
                 <a:cs typeface="Noto Sans"/>
               </a:rPr>
-              <a:t>実際のフィルター引数はcategoryで、S、W、S1、S2、W1、W2などを受け付ける。説明文のsplit="written"／"spoken"とは異なる。</a:t>
-            </a:r>
-          </a:p>
-          <a:p>
-            <a:pPr marL="457200" indent="-355600">
-              <a:lnSpc>
-                <a:spcPts val="2379"/>
-              </a:lnSpc>
-              <a:spcAft>
-                <a:spcPts val="0"/>
-              </a:spcAft>
-              <a:buSzPct val="66500"/>
-              <a:buFont typeface="Noto Sans CJK JP"/>
-              <a:buChar char="●"/>
-              <a:defRPr sz="2000" b="0">
-                <a:solidFill>
-                  <a:srgbClr val="303437"/>
-                </a:solidFill>
-                <a:latin typeface="Noto Sans"/>
-              </a:defRPr>
-            </a:pPr>
-            <a:r>
-              <a:rPr sz="2000" b="0" lang="ja-JP" altLang="en-US">
-                <a:solidFill>
-                  <a:srgbClr val="303437"/>
-                </a:solidFill>
-                <a:latin typeface="Noto Sans"/>
-                <a:ea typeface="Noto Sans CJK JP"/>
-                <a:cs typeface="Noto Sans"/>
-              </a:rPr>
-              <a:t>ここでは公開runのscenario_specとadapter_spec、および実装を照合して条件を記録した。</a:t>
+              <a:t>categoryで話し言葉（S）と書き言葉（W）を選べる。さらに対話（S1）・独話（S2）、非刊行（W1）・刊行（W2）の文章に絞ることもできる。</a:t>
             </a:r>
           </a:p>
         </p:txBody>
@@ -23316,7 +22808,7 @@
                 <a:ea typeface="Noto Sans CJK JP"/>
                 <a:cs typeface="Noto Sans"/>
               </a:rPr>
-              <a:t>Appendix: 2. 構成と実行条件の補足</a:t>
+              <a:t>Appendix: 2. 収録ジャンルと評価対象</a:t>
             </a:r>
           </a:p>
         </p:txBody>
@@ -23329,8 +22821,8 @@
         </p:nvSpPr>
         <p:spPr>
           <a:xfrm>
-            <a:off x="502920" y="4700016"/>
-            <a:ext cx="8183879" cy="530352"/>
+            <a:off x="502920" y="4699000"/>
+            <a:ext cx="8183879" cy="431800"/>
           </a:xfrm>
           <a:prstGeom prst="rect">
             <a:avLst/>
@@ -23351,7 +22843,7 @@
                 <a:spcPts val="0"/>
               </a:spcBef>
               <a:spcAft>
-                <a:spcPts val="140"/>
+                <a:spcPts val="0"/>
               </a:spcAft>
               <a:buNone/>
               <a:defRPr sz="810" b="0">
@@ -23362,35 +22854,24 @@
               </a:defRPr>
             </a:pPr>
             <a:r>
-              <a:rPr sz="810" b="0" lang="ja-JP" altLang="en-US">
-                <a:solidFill>
-                  <a:srgbClr val="626669"/>
-                </a:solidFill>
-                <a:latin typeface="Noto Sans"/>
-                <a:ea typeface="Noto Sans CJK JP"/>
-                <a:cs typeface="Noto Sans"/>
-              </a:rPr>
-              <a:t>[1] Stanford CRFM, HELM ICEScenario. v0.3.0.</a:t>
-            </a:r>
-            <a:r>
-              <a:rPr sz="810" b="0" lang="ja-JP" altLang="en-US">
-                <a:solidFill>
-                  <a:srgbClr val="626669"/>
-                </a:solidFill>
-                <a:latin typeface="Noto Sans"/>
-                <a:ea typeface="Noto Sans CJK JP"/>
-                <a:cs typeface="Noto Sans"/>
-              </a:rPr>
-              <a:t>  </a:t>
-            </a:r>
-            <a:r>
-              <a:rPr sz="810" b="0" lang="ja-JP" altLang="en-US">
-                <a:solidFill>
-                  <a:srgbClr val="626669"/>
-                </a:solidFill>
-                <a:latin typeface="Noto Sans"/>
-                <a:ea typeface="Noto Sans CJK JP"/>
-                <a:cs typeface="Noto Sans"/>
+              <a:rPr sz="830">
+                <a:latin typeface="Noto Sans CJK JP"/>
+              </a:rPr>
+              <a:t>[1] Stanford CRFM, HELM ICEScenario.</a:t>
+            </a:r>
+          </a:p>
+          <a:p>
+            <a:pPr>
+              <a:spcBef>
+                <a:spcPts val="0"/>
+              </a:spcBef>
+              <a:spcAft>
+                <a:spcPts val="0"/>
+              </a:spcAft>
+            </a:pPr>
+            <a:r>
+              <a:rPr sz="830">
+                <a:latin typeface="Noto Sans CJK JP"/>
                 <a:hlinkClick r:id="rId2"/>
               </a:rPr>
               <a:t>https://github.com/stanford-crfm/helm/blob/v0.3.0/src/helm/benchmark/scenarios/ice_scenario.py</a:t>
@@ -23459,7 +22940,7 @@
                 <a:ea typeface="Noto Sans CJK JP"/>
                 <a:cs typeface="Noto Sans"/>
               </a:rPr>
-              <a:t>性別条件はメタデータ形式にも依存する</a:t>
+              <a:t>性別で文書を選ぶ方法は、地域ごとに異なる</a:t>
             </a:r>
           </a:p>
         </p:txBody>
@@ -23512,7 +22993,7 @@
                 <a:ea typeface="Noto Sans CJK JP"/>
                 <a:cs typeface="Noto Sans"/>
               </a:rPr>
-              <a:t>CAN、HK、IND、USAの4地域にメタデータ用の処理がある。指定しない地域の性別を推定して補うことはしない。</a:t>
+              <a:t>Canada、Hong Kong、India、USAでは、付属のメタデータからmale／femaleの文書を選べる。</a:t>
             </a:r>
           </a:p>
           <a:p>
@@ -23542,7 +23023,7 @@
                 <a:ea typeface="Noto Sans CJK JP"/>
                 <a:cs typeface="Noto Sans"/>
               </a:rPr>
-              <a:t>IND／USAのHDR処理では、検出したgender値のすべてが指定条件に合う文書を採る。</a:t>
+              <a:t>IndiaとUSAでは、読み取った性別情報がすべて指定条件に合う文書を選ぶ。CanadaとHong Kongでは、所定の列のいずれかが一致すれば選ぶ。</a:t>
             </a:r>
           </a:p>
           <a:p>
@@ -23572,7 +23053,7 @@
                 <a:ea typeface="Noto Sans CJK JP"/>
                 <a:cs typeface="Noto Sans"/>
               </a:rPr>
-              <a:t>CAN／HKのXLS処理では所定の列のいずれかが一致すると選ぶため、説明文の「全員が同じ性別」という記述と実装は一致しない。</a:t>
+              <a:t>地域ごとに選び方が異なるため、性別別の結果を比べる際には、どの話者を含む文書なのかを確認する。</a:t>
             </a:r>
           </a:p>
         </p:txBody>
@@ -23620,7 +23101,7 @@
                 <a:ea typeface="Noto Sans CJK JP"/>
                 <a:cs typeface="Noto Sans"/>
               </a:rPr>
-              <a:t>Appendix: 2. 構成と実行条件の補足</a:t>
+              <a:t>Appendix: 2. 収録ジャンルと評価対象</a:t>
             </a:r>
           </a:p>
         </p:txBody>
@@ -23633,8 +23114,8 @@
         </p:nvSpPr>
         <p:spPr>
           <a:xfrm>
-            <a:off x="502920" y="4700016"/>
-            <a:ext cx="8183879" cy="530352"/>
+            <a:off x="502920" y="4699000"/>
+            <a:ext cx="8183879" cy="431800"/>
           </a:xfrm>
           <a:prstGeom prst="rect">
             <a:avLst/>
@@ -23655,7 +23136,7 @@
                 <a:spcPts val="0"/>
               </a:spcBef>
               <a:spcAft>
-                <a:spcPts val="140"/>
+                <a:spcPts val="0"/>
               </a:spcAft>
               <a:buNone/>
               <a:defRPr sz="810" b="0">
@@ -23666,345 +23147,27 @@
               </a:defRPr>
             </a:pPr>
             <a:r>
-              <a:rPr sz="810" b="0" lang="ja-JP" altLang="en-US">
-                <a:solidFill>
-                  <a:srgbClr val="626669"/>
-                </a:solidFill>
-                <a:latin typeface="Noto Sans"/>
-                <a:ea typeface="Noto Sans CJK JP"/>
-                <a:cs typeface="Noto Sans"/>
-              </a:rPr>
-              <a:t>[1] Stanford CRFM, HELM ICEScenario. v0.3.0.</a:t>
-            </a:r>
-            <a:r>
-              <a:rPr sz="810" b="0" lang="ja-JP" altLang="en-US">
-                <a:solidFill>
-                  <a:srgbClr val="626669"/>
-                </a:solidFill>
-                <a:latin typeface="Noto Sans"/>
-                <a:ea typeface="Noto Sans CJK JP"/>
-                <a:cs typeface="Noto Sans"/>
-              </a:rPr>
-              <a:t>  </a:t>
-            </a:r>
-            <a:r>
-              <a:rPr sz="810" b="0" lang="ja-JP" altLang="en-US">
-                <a:solidFill>
-                  <a:srgbClr val="626669"/>
-                </a:solidFill>
-                <a:latin typeface="Noto Sans"/>
-                <a:ea typeface="Noto Sans CJK JP"/>
-                <a:cs typeface="Noto Sans"/>
+              <a:rPr sz="830">
+                <a:latin typeface="Noto Sans CJK JP"/>
+              </a:rPr>
+              <a:t>[1] Stanford CRFM, HELM ICEScenario.</a:t>
+            </a:r>
+          </a:p>
+          <a:p>
+            <a:pPr>
+              <a:spcBef>
+                <a:spcPts val="0"/>
+              </a:spcBef>
+              <a:spcAft>
+                <a:spcPts val="0"/>
+              </a:spcAft>
+            </a:pPr>
+            <a:r>
+              <a:rPr sz="830">
+                <a:latin typeface="Noto Sans CJK JP"/>
                 <a:hlinkClick r:id="rId2"/>
               </a:rPr>
               <a:t>https://github.com/stanford-crfm/helm/blob/v0.3.0/src/helm/benchmark/scenarios/ice_scenario.py</a:t>
-            </a:r>
-          </a:p>
-        </p:txBody>
-      </p:sp>
-    </p:spTree>
-  </p:cSld>
-  <p:clrMapOvr>
-    <a:masterClrMapping/>
-  </p:clrMapOvr>
-</p:sld>
-</file>
-
-<file path=ppt/slides/slide46.xml><?xml version="1.0" encoding="utf-8"?>
-<p:sld xmlns:a="http://schemas.openxmlformats.org/drawingml/2006/main" xmlns:p="http://schemas.openxmlformats.org/presentationml/2006/main" xmlns:r="http://schemas.openxmlformats.org/officeDocument/2006/relationships">
-  <p:cSld>
-    <p:spTree>
-      <p:nvGrpSpPr>
-        <p:cNvPr id="1" name=""/>
-        <p:cNvGrpSpPr/>
-        <p:nvPr/>
-      </p:nvGrpSpPr>
-      <p:grpSpPr/>
-      <p:sp>
-        <p:nvSpPr>
-          <p:cNvPr id="2" name="Title 1"/>
-          <p:cNvSpPr>
-            <a:spLocks noGrp="1"/>
-          </p:cNvSpPr>
-          <p:nvPr>
-            <p:ph type="title"/>
-          </p:nvPr>
-        </p:nvSpPr>
-        <p:spPr>
-          <a:xfrm>
-            <a:off x="468172" y="650138"/>
-            <a:ext cx="8206740" cy="616305"/>
-          </a:xfrm>
-        </p:spPr>
-        <p:txBody>
-          <a:bodyPr wrap="square" lIns="0" rIns="0" tIns="0" bIns="0">
-            <a:noAutofit/>
-          </a:bodyPr>
-          <a:lstStyle/>
-          <a:p>
-            <a:pPr algn="l">
-              <a:lnSpc>
-                <a:spcPct val="110000"/>
-              </a:lnSpc>
-              <a:buNone/>
-              <a:defRPr sz="2800" b="0">
-                <a:solidFill>
-                  <a:srgbClr val="303437"/>
-                </a:solidFill>
-                <a:latin typeface="Noto Sans"/>
-              </a:defRPr>
-            </a:pPr>
-            <a:r>
-              <a:rPr sz="2800" b="1" lang="ja-JP" altLang="en-US">
-                <a:solidFill>
-                  <a:srgbClr val="303437"/>
-                </a:solidFill>
-                <a:latin typeface="Noto Sans"/>
-                <a:ea typeface="Noto Sans CJK JP"/>
-                <a:cs typeface="Noto Sans"/>
-              </a:rPr>
-              <a:t>公開例の範囲と再現に必要な情報</a:t>
-            </a:r>
-          </a:p>
-        </p:txBody>
-      </p:sp>
-      <p:sp>
-        <p:nvSpPr>
-          <p:cNvPr id="3" name="Text Placeholder 2"/>
-          <p:cNvSpPr>
-            <a:spLocks noGrp="1"/>
-          </p:cNvSpPr>
-          <p:nvPr>
-            <p:ph type="body" idx="1"/>
-          </p:nvPr>
-        </p:nvSpPr>
-        <p:spPr>
-          <a:xfrm>
-            <a:off x="594360" y="1463040"/>
-            <a:ext cx="7955279" cy="3044952"/>
-          </a:xfrm>
-        </p:spPr>
-        <p:txBody>
-          <a:bodyPr wrap="square" tIns="91440" bIns="91440">
-            <a:noAutofit/>
-          </a:bodyPr>
-          <a:lstStyle/>
-          <a:p>
-            <a:pPr marL="457200" indent="-355600">
-              <a:lnSpc>
-                <a:spcPts val="2379"/>
-              </a:lnSpc>
-              <a:spcAft>
-                <a:spcPts val="700"/>
-              </a:spcAft>
-              <a:buSzPct val="66500"/>
-              <a:buFont typeface="Noto Sans CJK JP"/>
-              <a:buChar char="●"/>
-              <a:defRPr sz="2000" b="0">
-                <a:solidFill>
-                  <a:srgbClr val="303437"/>
-                </a:solidFill>
-                <a:latin typeface="Noto Sans"/>
-              </a:defRPr>
-            </a:pPr>
-            <a:r>
-              <a:rPr sz="2000" b="0" lang="ja-JP" altLang="en-US">
-                <a:solidFill>
-                  <a:srgbClr val="303437"/>
-                </a:solidFill>
-                <a:latin typeface="Noto Sans"/>
-                <a:ea typeface="Noto Sans CJK JP"/>
-                <a:cs typeface="Noto Sans"/>
-              </a:rPr>
-              <a:t>Indiaの12件は、公開実行に含まれる500件から選んだ。run内のID、JSON位置、本文と抜粋のSHA-256を保存した。</a:t>
-            </a:r>
-          </a:p>
-          <a:p>
-            <a:pPr marL="457200" indent="-355600">
-              <a:lnSpc>
-                <a:spcPts val="2379"/>
-              </a:lnSpc>
-              <a:spcAft>
-                <a:spcPts val="700"/>
-              </a:spcAft>
-              <a:buSzPct val="66500"/>
-              <a:buFont typeface="Noto Sans CJK JP"/>
-              <a:buChar char="●"/>
-              <a:defRPr sz="2000" b="0">
-                <a:solidFill>
-                  <a:srgbClr val="303437"/>
-                </a:solidFill>
-                <a:latin typeface="Noto Sans"/>
-              </a:defRPr>
-            </a:pPr>
-            <a:r>
-              <a:rPr sz="2000" b="0" lang="ja-JP" altLang="en-US">
-                <a:solidFill>
-                  <a:srgbClr val="303437"/>
-                </a:solidFill>
-                <a:latin typeface="Noto Sans"/>
-                <a:ea typeface="Noto Sans CJK JP"/>
-                <a:cs typeface="Noto Sans"/>
-              </a:rPr>
-              <a:t>USAの1件は公式HELMコードに掲載された書き言葉の抜粋で、元のファイル名は示されていない。</a:t>
-            </a:r>
-          </a:p>
-          <a:p>
-            <a:pPr marL="457200" indent="-355600">
-              <a:lnSpc>
-                <a:spcPts val="2379"/>
-              </a:lnSpc>
-              <a:spcAft>
-                <a:spcPts val="0"/>
-              </a:spcAft>
-              <a:buSzPct val="66500"/>
-              <a:buFont typeface="Noto Sans CJK JP"/>
-              <a:buChar char="●"/>
-              <a:defRPr sz="2000" b="0">
-                <a:solidFill>
-                  <a:srgbClr val="303437"/>
-                </a:solidFill>
-                <a:latin typeface="Noto Sans"/>
-              </a:defRPr>
-            </a:pPr>
-            <a:r>
-              <a:rPr sz="2000" b="0" lang="ja-JP" altLang="en-US">
-                <a:solidFill>
-                  <a:srgbClr val="303437"/>
-                </a:solidFill>
-                <a:latin typeface="Noto Sans"/>
-                <a:ea typeface="Noto Sans CJK JP"/>
-                <a:cs typeface="Noto Sans"/>
-              </a:rPr>
-              <a:t>公開runの入手可能性と、元コーパスの再配布ライセンスは別に扱い、資料には説明に必要な短い範囲を引用した。</a:t>
-            </a:r>
-          </a:p>
-        </p:txBody>
-      </p:sp>
-      <p:sp>
-        <p:nvSpPr>
-          <p:cNvPr id="4" name="Title 3"/>
-          <p:cNvSpPr>
-            <a:spLocks noGrp="1"/>
-          </p:cNvSpPr>
-          <p:nvPr>
-            <p:ph type="title" idx="2"/>
-          </p:nvPr>
-        </p:nvSpPr>
-        <p:spPr>
-          <a:xfrm>
-            <a:off x="75895" y="0"/>
-            <a:ext cx="8115300" cy="480060"/>
-          </a:xfrm>
-        </p:spPr>
-        <p:txBody>
-          <a:bodyPr wrap="square" lIns="0" rIns="0" tIns="0" bIns="0" anchor="ctr">
-            <a:noAutofit/>
-          </a:bodyPr>
-          <a:lstStyle/>
-          <a:p>
-            <a:pPr algn="l">
-              <a:lnSpc>
-                <a:spcPct val="110000"/>
-              </a:lnSpc>
-              <a:buNone/>
-              <a:defRPr sz="1400" b="0">
-                <a:solidFill>
-                  <a:srgbClr val="303437"/>
-                </a:solidFill>
-                <a:latin typeface="Noto Sans"/>
-              </a:defRPr>
-            </a:pPr>
-            <a:r>
-              <a:rPr sz="1400" b="1" lang="ja-JP" altLang="en-US">
-                <a:solidFill>
-                  <a:srgbClr val="FFFEF8"/>
-                </a:solidFill>
-                <a:latin typeface="Noto Sans"/>
-                <a:ea typeface="Noto Sans CJK JP"/>
-                <a:cs typeface="Noto Sans"/>
-              </a:rPr>
-              <a:t>Appendix: 2. 構成と実行条件の補足</a:t>
-            </a:r>
-          </a:p>
-        </p:txBody>
-      </p:sp>
-      <p:sp>
-        <p:nvSpPr>
-          <p:cNvPr id="5" name="sources"/>
-          <p:cNvSpPr txBox="1"/>
-          <p:nvPr/>
-        </p:nvSpPr>
-        <p:spPr>
-          <a:xfrm>
-            <a:off x="502920" y="4700016"/>
-            <a:ext cx="8183879" cy="530352"/>
-          </a:xfrm>
-          <a:prstGeom prst="rect">
-            <a:avLst/>
-          </a:prstGeom>
-          <a:noFill/>
-        </p:spPr>
-        <p:txBody>
-          <a:bodyPr wrap="square" lIns="0" rIns="0" tIns="0" bIns="0">
-            <a:noAutofit/>
-          </a:bodyPr>
-          <a:lstStyle/>
-          <a:p>
-            <a:pPr algn="l">
-              <a:lnSpc>
-                <a:spcPts val="940"/>
-              </a:lnSpc>
-              <a:spcBef>
-                <a:spcPts val="0"/>
-              </a:spcBef>
-              <a:spcAft>
-                <a:spcPts val="140"/>
-              </a:spcAft>
-              <a:buNone/>
-              <a:defRPr sz="810" b="0">
-                <a:solidFill>
-                  <a:srgbClr val="303437"/>
-                </a:solidFill>
-                <a:latin typeface="Noto Sans"/>
-              </a:defRPr>
-            </a:pPr>
-            <a:r>
-              <a:rPr sz="810" b="0" lang="ja-JP" altLang="en-US">
-                <a:solidFill>
-                  <a:srgbClr val="626669"/>
-                </a:solidFill>
-                <a:latin typeface="Noto Sans"/>
-                <a:ea typeface="Noto Sans CJK JP"/>
-                <a:cs typeface="Noto Sans"/>
-              </a:rPr>
-              <a:t>[1] HELM公開実行 v0.3.0, ICE India / OPT-175B. scenario_stateの実入力から抜粋。</a:t>
-            </a:r>
-          </a:p>
-          <a:p>
-            <a:pPr>
-              <a:lnSpc>
-                <a:spcPts val="940"/>
-              </a:lnSpc>
-              <a:buNone/>
-              <a:defRPr sz="810" b="0">
-                <a:solidFill>
-                  <a:srgbClr val="303437"/>
-                </a:solidFill>
-                <a:latin typeface="Noto Sans"/>
-              </a:defRPr>
-            </a:pPr>
-            <a:r>
-              <a:rPr sz="810" b="0" lang="ja-JP" altLang="en-US">
-                <a:solidFill>
-                  <a:srgbClr val="626669"/>
-                </a:solidFill>
-                <a:latin typeface="Noto Sans"/>
-                <a:ea typeface="Noto Sans CJK JP"/>
-                <a:cs typeface="Noto Sans"/>
-                <a:hlinkClick r:id="rId2"/>
-              </a:rPr>
-              <a:t>https://crfm.stanford.edu/helm/classic/v0.4.0/#/runs/ice:subset=ind,model=together_opt-175b</a:t>
             </a:r>
           </a:p>
         </p:txBody>
@@ -24132,7 +23295,7 @@
         <p:spPr>
           <a:xfrm>
             <a:off x="548640" y="1463040"/>
-            <a:ext cx="8046720" cy="1157605"/>
+            <a:ext cx="8046720" cy="1576213"/>
           </a:xfrm>
           <a:prstGeom prst="rect">
             <a:avLst/>
@@ -24203,7 +23366,7 @@
                 <a:ea typeface="Noto Sans CJK JP"/>
                 <a:cs typeface="Noto Sans"/>
               </a:rPr>
-              <a:t>University of Zurich／ICE teams. 1990年開始、公式プロジェクトサイト。</a:t>
+              <a:t>University of Zurich／ICE teams. (n.d.). 1990年開始。2026-10-18参照。</a:t>
             </a:r>
           </a:p>
           <a:p>
@@ -24280,7 +23443,7 @@
         <p:spPr>
           <a:xfrm>
             <a:off x="548640" y="3131693"/>
-            <a:ext cx="8046720" cy="1425448"/>
+            <a:ext cx="8046720" cy="1643637"/>
           </a:xfrm>
           <a:prstGeom prst="rect">
             <a:avLst/>
@@ -24542,7 +23705,7 @@
         <p:spPr>
           <a:xfrm>
             <a:off x="548640" y="1463040"/>
-            <a:ext cx="8046720" cy="1157605"/>
+            <a:ext cx="8046720" cy="1322213"/>
           </a:xfrm>
           <a:prstGeom prst="rect">
             <a:avLst/>
@@ -24690,7 +23853,7 @@
         <p:spPr>
           <a:xfrm>
             <a:off x="548640" y="3131693"/>
-            <a:ext cx="8046720" cy="1425448"/>
+            <a:ext cx="8046720" cy="1643637"/>
           </a:xfrm>
           <a:prstGeom prst="rect">
             <a:avLst/>
@@ -24952,7 +24115,7 @@
         <p:spPr>
           <a:xfrm>
             <a:off x="548640" y="1463040"/>
-            <a:ext cx="8046720" cy="1425448"/>
+            <a:ext cx="8046720" cy="1643688"/>
           </a:xfrm>
           <a:prstGeom prst="rect">
             <a:avLst/>
@@ -25100,7 +24263,7 @@
         <p:spPr>
           <a:xfrm>
             <a:off x="548640" y="3399536"/>
-            <a:ext cx="8046720" cy="1425448"/>
+            <a:ext cx="8046720" cy="1643637"/>
           </a:xfrm>
           <a:prstGeom prst="rect">
             <a:avLst/>
@@ -25202,7 +24365,7 @@
                 <a:ea typeface="Noto Sans CJK JP"/>
                 <a:cs typeface="Noto Sans"/>
               </a:rPr>
-              <a:t>公開runの地域・性別条件と、言語モデルへの確率に基づく評価値を掲載する。</a:t>
+              <a:t>公開runの地域・性別条件と、言語モデルが本文に与えた確率に基づく評価値を掲載する。</a:t>
             </a:r>
           </a:p>
           <a:p>
@@ -25474,8 +24637,8 @@
         </p:nvSpPr>
         <p:spPr>
           <a:xfrm>
-            <a:off x="502920" y="4700016"/>
-            <a:ext cx="8183879" cy="530352"/>
+            <a:off x="502920" y="4699000"/>
+            <a:ext cx="8183879" cy="431800"/>
           </a:xfrm>
           <a:prstGeom prst="rect">
             <a:avLst/>
@@ -25496,7 +24659,7 @@
                 <a:spcPts val="0"/>
               </a:spcBef>
               <a:spcAft>
-                <a:spcPts val="140"/>
+                <a:spcPts val="0"/>
               </a:spcAft>
               <a:buNone/>
               <a:defRPr sz="810" b="0">
@@ -25507,35 +24670,24 @@
               </a:defRPr>
             </a:pPr>
             <a:r>
-              <a:rPr sz="810" b="0" lang="ja-JP" altLang="en-US">
-                <a:solidFill>
-                  <a:srgbClr val="626669"/>
-                </a:solidFill>
-                <a:latin typeface="Noto Sans"/>
-                <a:ea typeface="Noto Sans CJK JP"/>
-                <a:cs typeface="Noto Sans"/>
-              </a:rPr>
-              <a:t>[1] International Corpus of English. University of Zurich. 2026-10-18参照。</a:t>
-            </a:r>
-            <a:r>
-              <a:rPr sz="810" b="0" lang="ja-JP" altLang="en-US">
-                <a:solidFill>
-                  <a:srgbClr val="626669"/>
-                </a:solidFill>
-                <a:latin typeface="Noto Sans"/>
-                <a:ea typeface="Noto Sans CJK JP"/>
-                <a:cs typeface="Noto Sans"/>
-              </a:rPr>
-              <a:t>  </a:t>
-            </a:r>
-            <a:r>
-              <a:rPr sz="810" b="0" lang="ja-JP" altLang="en-US">
-                <a:solidFill>
-                  <a:srgbClr val="626669"/>
-                </a:solidFill>
-                <a:latin typeface="Noto Sans"/>
-                <a:ea typeface="Noto Sans CJK JP"/>
-                <a:cs typeface="Noto Sans"/>
+              <a:rPr sz="830">
+                <a:latin typeface="Noto Sans CJK JP"/>
+              </a:rPr>
+              <a:t>[1] International Corpus of English. University of Zurich.</a:t>
+            </a:r>
+          </a:p>
+          <a:p>
+            <a:pPr>
+              <a:spcBef>
+                <a:spcPts val="0"/>
+              </a:spcBef>
+              <a:spcAft>
+                <a:spcPts val="0"/>
+              </a:spcAft>
+            </a:pPr>
+            <a:r>
+              <a:rPr sz="830">
+                <a:latin typeface="Noto Sans CJK JP"/>
                 <a:hlinkClick r:id="rId2"/>
               </a:rPr>
               <a:t>https://www.ice-corpora.uzh.ch/en.html</a:t>
@@ -25657,7 +24809,7 @@
                 <a:ea typeface="Noto Sans CJK JP"/>
                 <a:cs typeface="Noto Sans"/>
               </a:rPr>
-              <a:t>言語モデルにテキストを与え、各語・記号にどれだけ高い確率を付けるかを測る。自由に回答文を生成する設定ではない。</a:t>
+              <a:t>言語モデルにテキストを与え、各語や記号にどれだけ高い確率を付けるかを測る。本文を予測しやすいモデルほど、よい得点になる。</a:t>
             </a:r>
           </a:p>
           <a:p>
@@ -25687,37 +24839,7 @@
                 <a:ea typeface="Noto Sans CJK JP"/>
                 <a:cs typeface="Noto Sans"/>
               </a:rPr>
-              <a:t>以下は公開HELM実行のIndia入力と、公式コードが掲載するUSA例から選んだ短い抜粋。</a:t>
-            </a:r>
-          </a:p>
-          <a:p>
-            <a:pPr marL="457200" indent="-355600">
-              <a:lnSpc>
-                <a:spcPts val="2618"/>
-              </a:lnSpc>
-              <a:spcAft>
-                <a:spcPts val="0"/>
-              </a:spcAft>
-              <a:buSzPct val="60455"/>
-              <a:buFont typeface="Noto Sans CJK JP"/>
-              <a:buChar char="●"/>
-              <a:defRPr sz="2200" b="0">
-                <a:solidFill>
-                  <a:srgbClr val="303437"/>
-                </a:solidFill>
-                <a:latin typeface="Noto Sans"/>
-              </a:defRPr>
-            </a:pPr>
-            <a:r>
-              <a:rPr sz="2200" b="0" lang="ja-JP" altLang="en-US">
-                <a:solidFill>
-                  <a:srgbClr val="303437"/>
-                </a:solidFill>
-                <a:latin typeface="Noto Sans"/>
-                <a:ea typeface="Noto Sans CJK JP"/>
-                <a:cs typeface="Noto Sans"/>
-              </a:rPr>
-              <a:t>実際の評価はテキスト全体を対象にする。表示部分は、その入力の一部である。</a:t>
+              <a:t>以下の13例は、HELMの公開評価に含まれるインドの英語12件と、公式実装に掲載された米国の英語1件からの短い抜粋。実際の評価には、抜粋元のテキスト全体を使う。</a:t>
             </a:r>
           </a:p>
         </p:txBody>
@@ -25778,8 +24900,8 @@
         </p:nvSpPr>
         <p:spPr>
           <a:xfrm>
-            <a:off x="502920" y="4700016"/>
-            <a:ext cx="8183879" cy="530352"/>
+            <a:off x="502920" y="4699000"/>
+            <a:ext cx="8183879" cy="431800"/>
           </a:xfrm>
           <a:prstGeom prst="rect">
             <a:avLst/>
@@ -25800,7 +24922,7 @@
                 <a:spcPts val="0"/>
               </a:spcBef>
               <a:spcAft>
-                <a:spcPts val="140"/>
+                <a:spcPts val="0"/>
               </a:spcAft>
               <a:buNone/>
               <a:defRPr sz="810" b="0">
@@ -25811,35 +24933,24 @@
               </a:defRPr>
             </a:pPr>
             <a:r>
-              <a:rPr sz="810" b="0" lang="ja-JP" altLang="en-US">
-                <a:solidFill>
-                  <a:srgbClr val="626669"/>
-                </a:solidFill>
-                <a:latin typeface="Noto Sans"/>
-                <a:ea typeface="Noto Sans CJK JP"/>
-                <a:cs typeface="Noto Sans"/>
-              </a:rPr>
-              <a:t>[1] Stanford CRFM, HELM ICEScenario. v0.3.0.</a:t>
-            </a:r>
-            <a:r>
-              <a:rPr sz="810" b="0" lang="ja-JP" altLang="en-US">
-                <a:solidFill>
-                  <a:srgbClr val="626669"/>
-                </a:solidFill>
-                <a:latin typeface="Noto Sans"/>
-                <a:ea typeface="Noto Sans CJK JP"/>
-                <a:cs typeface="Noto Sans"/>
-              </a:rPr>
-              <a:t>  </a:t>
-            </a:r>
-            <a:r>
-              <a:rPr sz="810" b="0" lang="ja-JP" altLang="en-US">
-                <a:solidFill>
-                  <a:srgbClr val="626669"/>
-                </a:solidFill>
-                <a:latin typeface="Noto Sans"/>
-                <a:ea typeface="Noto Sans CJK JP"/>
-                <a:cs typeface="Noto Sans"/>
+              <a:rPr sz="830">
+                <a:latin typeface="Noto Sans CJK JP"/>
+              </a:rPr>
+              <a:t>[1] Stanford CRFM, HELM ICEScenario.</a:t>
+            </a:r>
+          </a:p>
+          <a:p>
+            <a:pPr>
+              <a:spcBef>
+                <a:spcPts val="0"/>
+              </a:spcBef>
+              <a:spcAft>
+                <a:spcPts val="0"/>
+              </a:spcAft>
+            </a:pPr>
+            <a:r>
+              <a:rPr sz="830">
+                <a:latin typeface="Noto Sans CJK JP"/>
                 <a:hlinkClick r:id="rId2"/>
               </a:rPr>
               <a:t>https://github.com/stanford-crfm/helm/blob/v0.3.0/src/helm/benchmark/scenarios/ice_scenario.py</a:t>
@@ -26078,7 +25189,7 @@
         <p:spPr>
           <a:xfrm>
             <a:off x="548640" y="1719072"/>
-            <a:ext cx="3931920" cy="1819112"/>
+            <a:ext cx="3931920" cy="1759845"/>
           </a:xfrm>
           <a:prstGeom prst="rect">
             <a:avLst/>
@@ -26106,7 +25217,7 @@
           </a:fontRef>
         </p:style>
         <p:txBody>
-          <a:bodyPr rtlCol="0" anchor="t" wrap="square" lIns="177800" rIns="177800" tIns="63500" bIns="127000">
+          <a:bodyPr rtlCol="0" anchor="t" wrap="square" lIns="177800" rIns="177800" tIns="42333" bIns="127000">
             <a:noAutofit/>
           </a:bodyPr>
           <a:lstStyle/>
@@ -26152,7 +25263,7 @@
         <p:spPr>
           <a:xfrm>
             <a:off x="4663440" y="1719072"/>
-            <a:ext cx="3931920" cy="2090129"/>
+            <a:ext cx="3931920" cy="2013929"/>
           </a:xfrm>
           <a:prstGeom prst="rect">
             <a:avLst/>
@@ -26180,7 +25291,7 @@
           </a:fontRef>
         </p:style>
         <p:txBody>
-          <a:bodyPr rtlCol="0" anchor="t" wrap="square" lIns="177800" rIns="177800" tIns="63500" bIns="127000">
+          <a:bodyPr rtlCol="0" anchor="t" wrap="square" lIns="177800" rIns="177800" tIns="42333" bIns="127000">
             <a:noAutofit/>
           </a:bodyPr>
           <a:lstStyle/>
@@ -26287,8 +25398,8 @@
         </p:nvSpPr>
         <p:spPr>
           <a:xfrm>
-            <a:off x="502920" y="4700016"/>
-            <a:ext cx="8183879" cy="530352"/>
+            <a:off x="502920" y="4699000"/>
+            <a:ext cx="8183879" cy="431800"/>
           </a:xfrm>
           <a:prstGeom prst="rect">
             <a:avLst/>
@@ -26309,7 +25420,7 @@
                 <a:spcPts val="0"/>
               </a:spcBef>
               <a:spcAft>
-                <a:spcPts val="140"/>
+                <a:spcPts val="0"/>
               </a:spcAft>
               <a:buNone/>
               <a:defRPr sz="810" b="0">
@@ -26320,38 +25431,24 @@
               </a:defRPr>
             </a:pPr>
             <a:r>
-              <a:rPr sz="810" b="0" lang="ja-JP" altLang="en-US">
-                <a:solidFill>
-                  <a:srgbClr val="626669"/>
-                </a:solidFill>
-                <a:latin typeface="Noto Sans"/>
-                <a:ea typeface="Noto Sans CJK JP"/>
-                <a:cs typeface="Noto Sans"/>
-              </a:rPr>
-              <a:t>[1] HELM公開実行 v0.3.0, ICE India / OPT-175B. scenario_stateの実入力から抜粋。 id0 / 文字範囲 [0, 173]</a:t>
+              <a:rPr sz="830">
+                <a:latin typeface="Noto Sans CJK JP"/>
+              </a:rPr>
+              <a:t>[1] Stanford CRFM (2023). HELM Classic: ICE India / OPT-175B.</a:t>
             </a:r>
           </a:p>
           <a:p>
             <a:pPr>
-              <a:lnSpc>
-                <a:spcPts val="940"/>
-              </a:lnSpc>
-              <a:buNone/>
-              <a:defRPr sz="810" b="0">
-                <a:solidFill>
-                  <a:srgbClr val="303437"/>
-                </a:solidFill>
-                <a:latin typeface="Noto Sans"/>
-              </a:defRPr>
-            </a:pPr>
-            <a:r>
-              <a:rPr sz="810" b="0" lang="ja-JP" altLang="en-US">
-                <a:solidFill>
-                  <a:srgbClr val="626669"/>
-                </a:solidFill>
-                <a:latin typeface="Noto Sans"/>
-                <a:ea typeface="Noto Sans CJK JP"/>
-                <a:cs typeface="Noto Sans"/>
+              <a:spcBef>
+                <a:spcPts val="0"/>
+              </a:spcBef>
+              <a:spcAft>
+                <a:spcPts val="0"/>
+              </a:spcAft>
+            </a:pPr>
+            <a:r>
+              <a:rPr sz="830">
+                <a:latin typeface="Noto Sans CJK JP"/>
                 <a:hlinkClick r:id="rId2"/>
               </a:rPr>
               <a:t>https://crfm.stanford.edu/helm/classic/v0.4.0/#/runs/ice:subset=ind,model=together_opt-175b</a:t>
@@ -26564,8 +25661,8 @@
         </p:nvSpPr>
         <p:spPr>
           <a:xfrm>
-            <a:off x="502920" y="4700016"/>
-            <a:ext cx="8183879" cy="530352"/>
+            <a:off x="502920" y="4699000"/>
+            <a:ext cx="8183879" cy="431800"/>
           </a:xfrm>
           <a:prstGeom prst="rect">
             <a:avLst/>
@@ -26586,7 +25683,7 @@
                 <a:spcPts val="0"/>
               </a:spcBef>
               <a:spcAft>
-                <a:spcPts val="140"/>
+                <a:spcPts val="0"/>
               </a:spcAft>
               <a:buNone/>
               <a:defRPr sz="810" b="0">
@@ -26597,35 +25694,24 @@
               </a:defRPr>
             </a:pPr>
             <a:r>
-              <a:rPr sz="810" b="0" lang="ja-JP" altLang="en-US">
-                <a:solidFill>
-                  <a:srgbClr val="626669"/>
-                </a:solidFill>
-                <a:latin typeface="Noto Sans"/>
-                <a:ea typeface="Noto Sans CJK JP"/>
-                <a:cs typeface="Noto Sans"/>
+              <a:rPr sz="830">
+                <a:latin typeface="Noto Sans CJK JP"/>
               </a:rPr>
               <a:t>[1] Nelson (2002), Markup Manuals for Spoken and Written Texts. ICE.</a:t>
             </a:r>
-            <a:r>
-              <a:rPr sz="810" b="0" lang="ja-JP" altLang="en-US">
-                <a:solidFill>
-                  <a:srgbClr val="626669"/>
-                </a:solidFill>
-                <a:latin typeface="Noto Sans"/>
-                <a:ea typeface="Noto Sans CJK JP"/>
-                <a:cs typeface="Noto Sans"/>
-              </a:rPr>
-              <a:t>  </a:t>
-            </a:r>
-            <a:r>
-              <a:rPr sz="810" b="0" lang="ja-JP" altLang="en-US">
-                <a:solidFill>
-                  <a:srgbClr val="626669"/>
-                </a:solidFill>
-                <a:latin typeface="Noto Sans"/>
-                <a:ea typeface="Noto Sans CJK JP"/>
-                <a:cs typeface="Noto Sans"/>
+          </a:p>
+          <a:p>
+            <a:pPr>
+              <a:spcBef>
+                <a:spcPts val="0"/>
+              </a:spcBef>
+              <a:spcAft>
+                <a:spcPts val="0"/>
+              </a:spcAft>
+            </a:pPr>
+            <a:r>
+              <a:rPr sz="830">
+                <a:latin typeface="Noto Sans CJK JP"/>
                 <a:hlinkClick r:id="rId2"/>
               </a:rPr>
               <a:t>https://www.ice-corpora.uzh.ch/en/manuals.html</a:t>
@@ -26864,7 +25950,7 @@
         <p:spPr>
           <a:xfrm>
             <a:off x="548640" y="1719072"/>
-            <a:ext cx="3931920" cy="1546595"/>
+            <a:ext cx="3931920" cy="1512728"/>
           </a:xfrm>
           <a:prstGeom prst="rect">
             <a:avLst/>
@@ -26892,7 +25978,7 @@
           </a:fontRef>
         </p:style>
         <p:txBody>
-          <a:bodyPr rtlCol="0" anchor="t" wrap="square" lIns="177800" rIns="177800" tIns="63500" bIns="127000">
+          <a:bodyPr rtlCol="0" anchor="t" wrap="square" lIns="177800" rIns="177800" tIns="42333" bIns="127000">
             <a:noAutofit/>
           </a:bodyPr>
           <a:lstStyle/>
@@ -26938,7 +26024,7 @@
         <p:spPr>
           <a:xfrm>
             <a:off x="4663440" y="1719072"/>
-            <a:ext cx="3931920" cy="2090129"/>
+            <a:ext cx="3931920" cy="2030862"/>
           </a:xfrm>
           <a:prstGeom prst="rect">
             <a:avLst/>
@@ -26966,7 +26052,7 @@
           </a:fontRef>
         </p:style>
         <p:txBody>
-          <a:bodyPr rtlCol="0" anchor="t" wrap="square" lIns="177800" rIns="177800" tIns="63500" bIns="127000">
+          <a:bodyPr rtlCol="0" anchor="t" wrap="square" lIns="177800" rIns="177800" tIns="59266" bIns="127000">
             <a:noAutofit/>
           </a:bodyPr>
           <a:lstStyle/>
@@ -26998,7 +26084,7 @@
                 <a:ea typeface="Noto Sans CJK JP"/>
                 <a:cs typeface="Noto Sans"/>
               </a:rPr>
-              <a:t>&lt;$A&gt; ええと、ヤーダヴさん、出身地のことを何かお話しでしたね。</a:t>
+              <a:t>&lt;$A&gt; ええと、ヤーダヴさん、出身地のことを少し話していましたね。</a:t>
             </a:r>
           </a:p>
           <a:p>
@@ -27104,8 +26190,8 @@
         </p:nvSpPr>
         <p:spPr>
           <a:xfrm>
-            <a:off x="502920" y="4700016"/>
-            <a:ext cx="8183879" cy="530352"/>
+            <a:off x="502920" y="4699000"/>
+            <a:ext cx="8183879" cy="431800"/>
           </a:xfrm>
           <a:prstGeom prst="rect">
             <a:avLst/>
@@ -27126,7 +26212,7 @@
                 <a:spcPts val="0"/>
               </a:spcBef>
               <a:spcAft>
-                <a:spcPts val="140"/>
+                <a:spcPts val="0"/>
               </a:spcAft>
               <a:buNone/>
               <a:defRPr sz="810" b="0">
@@ -27137,38 +26223,24 @@
               </a:defRPr>
             </a:pPr>
             <a:r>
-              <a:rPr sz="810" b="0" lang="ja-JP" altLang="en-US">
-                <a:solidFill>
-                  <a:srgbClr val="626669"/>
-                </a:solidFill>
-                <a:latin typeface="Noto Sans"/>
-                <a:ea typeface="Noto Sans CJK JP"/>
-                <a:cs typeface="Noto Sans"/>
-              </a:rPr>
-              <a:t>[1] HELM公開実行 v0.3.0, ICE India / OPT-175B. scenario_stateの実入力から抜粋。 id11 / 文字範囲 [0, 162]</a:t>
+              <a:rPr sz="830">
+                <a:latin typeface="Noto Sans CJK JP"/>
+              </a:rPr>
+              <a:t>[1] Stanford CRFM (2023). HELM Classic: ICE India / OPT-175B.</a:t>
             </a:r>
           </a:p>
           <a:p>
             <a:pPr>
-              <a:lnSpc>
-                <a:spcPts val="940"/>
-              </a:lnSpc>
-              <a:buNone/>
-              <a:defRPr sz="810" b="0">
-                <a:solidFill>
-                  <a:srgbClr val="303437"/>
-                </a:solidFill>
-                <a:latin typeface="Noto Sans"/>
-              </a:defRPr>
-            </a:pPr>
-            <a:r>
-              <a:rPr sz="810" b="0" lang="ja-JP" altLang="en-US">
-                <a:solidFill>
-                  <a:srgbClr val="626669"/>
-                </a:solidFill>
-                <a:latin typeface="Noto Sans"/>
-                <a:ea typeface="Noto Sans CJK JP"/>
-                <a:cs typeface="Noto Sans"/>
+              <a:spcBef>
+                <a:spcPts val="0"/>
+              </a:spcBef>
+              <a:spcAft>
+                <a:spcPts val="0"/>
+              </a:spcAft>
+            </a:pPr>
+            <a:r>
+              <a:rPr sz="830">
+                <a:latin typeface="Noto Sans CJK JP"/>
                 <a:hlinkClick r:id="rId2"/>
               </a:rPr>
               <a:t>https://crfm.stanford.edu/helm/classic/v0.4.0/#/runs/ice:subset=ind,model=together_opt-175b</a:t>

</xml_diff>

<commit_message>
Center ICE on regional corpus design and linguistic research
</commit_message>
<xml_diff>
--- a/slides/datasets-in-10-minutes-ice.pptx
+++ b/slides/datasets-in-10-minutes-ice.pptx
@@ -23,12 +23,6 @@
     <p:sldId id="271" r:id="rId21"/>
     <p:sldId id="272" r:id="rId22"/>
     <p:sldId id="273" r:id="rId23"/>
-    <p:sldId id="274" r:id="rId24"/>
-    <p:sldId id="275" r:id="rId25"/>
-    <p:sldId id="276" r:id="rId26"/>
-    <p:sldId id="277" r:id="rId27"/>
-    <p:sldId id="278" r:id="rId28"/>
-    <p:sldId id="279" r:id="rId29"/>
     <p:sldId id="280" r:id="rId30"/>
     <p:sldId id="281" r:id="rId31"/>
     <p:sldId id="282" r:id="rId32"/>
@@ -48,8 +42,6 @@
     <p:sldId id="296" r:id="rId46"/>
     <p:sldId id="297" r:id="rId47"/>
     <p:sldId id="298" r:id="rId48"/>
-    <p:sldId id="299" r:id="rId49"/>
-    <p:sldId id="300" r:id="rId50"/>
     <p:sldId id="302" r:id="rId52"/>
     <p:sldId id="303" r:id="rId53"/>
     <p:sldId id="304" r:id="rId54"/>
@@ -7406,7 +7398,7 @@
                 <a:ea typeface="Noto Sans CJK JP"/>
                 <a:cs typeface="Noto Sans"/>
               </a:rPr>
-              <a:t>話者交替や地域の表現も入力になる</a:t>
+              <a:t>話者交替や地域の表現も研究対象になる</a:t>
             </a:r>
           </a:p>
         </p:txBody>
@@ -7519,7 +7511,7 @@
                 <a:ea typeface="Noto Sans CJK JP"/>
                 <a:cs typeface="Noto Sans"/>
               </a:rPr>
-              <a:t>HELMは文法や地名の正誤を判定せず、記録されたテキストへの確率を採点する。</a:t>
+              <a:t>語句の使い方を調べるときは、前後の発話や相手の応答も読むと、その表現が会話の中でどう使われたかが分かる。</a:t>
             </a:r>
           </a:p>
         </p:txBody>
@@ -7616,7 +7608,7 @@
               <a:rPr sz="830">
                 <a:latin typeface="Noto Sans CJK JP"/>
               </a:rPr>
-              <a:t>[1] Stanford CRFM, HELM ICEScenario.</a:t>
+              <a:t>[1] Nelson (2002). Markup Manual for Spoken Texts. ICE.</a:t>
             </a:r>
           </a:p>
           <a:p>
@@ -7633,7 +7625,7 @@
                 <a:latin typeface="Noto Sans CJK JP"/>
                 <a:hlinkClick r:id="rId2"/>
               </a:rPr>
-              <a:t>https://github.com/stanford-crfm/helm/blob/v0.3.0/src/helm/benchmark/scenarios/ice_scenario.py</a:t>
+              <a:t>https://www.ice-corpora.uzh.ch/en/manuals.html</a:t>
             </a:r>
           </a:p>
         </p:txBody>
@@ -8219,7 +8211,7 @@
                 <a:ea typeface="Noto Sans CJK JP"/>
                 <a:cs typeface="Noto Sans"/>
               </a:rPr>
-              <a:t>USAの例は硬貨収集の案内。文として整えられた書き言葉で、転記された会話とは形が異なる。</a:t>
+              <a:t>米国の例は硬貨収集の案内。文として整えられた書き言葉で、転記された会話とは形が異なる。</a:t>
             </a:r>
           </a:p>
           <a:p>
@@ -8249,7 +8241,7 @@
                 <a:ea typeface="Noto Sans CJK JP"/>
                 <a:cs typeface="Noto Sans"/>
               </a:rPr>
-              <a:t>標準設計には話し言葉300テキストと書き言葉200テキストがある。USAのHELM対象は書き言葉200件だけ。</a:t>
+              <a:t>標準設計には話し言葉300テキストと書き言葉200テキストがある。米国は、書き言葉部の約40万語が配布されている。</a:t>
             </a:r>
           </a:p>
           <a:p>
@@ -8279,7 +8271,7 @@
                 <a:ea typeface="Noto Sans CJK JP"/>
                 <a:cs typeface="Noto Sans"/>
               </a:rPr>
-              <a:t>地域ごとの得点には、語法の差に加えて、収録ジャンルの構成も関わる。</a:t>
+              <a:t>地域を比較するときは、会話同士、学術文同士など、ジャンルをそろえ、対象にする本文の量も確かめる。</a:t>
             </a:r>
           </a:p>
         </p:txBody>
@@ -8409,7 +8401,7 @@
               <a:rPr sz="830">
                 <a:latin typeface="Noto Sans CJK JP"/>
               </a:rPr>
-              <a:t>[2] HELM Classic v0.4.0, ICE.</a:t>
+              <a:t>[2] International Corpus of English. Getting Access.</a:t>
             </a:r>
           </a:p>
           <a:p>
@@ -8426,7 +8418,7 @@
                 <a:latin typeface="Noto Sans CJK JP"/>
                 <a:hlinkClick r:id="rId3"/>
               </a:rPr>
-              <a:t>https://crfm.stanford.edu/helm/classic/v0.4.0/#/groups/ice</a:t>
+              <a:t>https://www.ice-corpora.uzh.ch/en/access.html</a:t>
             </a:r>
           </a:p>
         </p:txBody>
@@ -10540,7 +10532,7 @@
                 <a:ea typeface="Noto Sans CJK JP"/>
                 <a:cs typeface="Noto Sans"/>
               </a:rPr>
-              <a:t>HELMは注釈を整理し、本文を評価する</a:t>
+              <a:t>同じジャンルの用例を、地域ごとに比べる</a:t>
             </a:r>
           </a:p>
         </p:txBody>
@@ -10593,7 +10585,7 @@
                 <a:ea typeface="Noto Sans CJK JP"/>
                 <a:cs typeface="Noto Sans"/>
               </a:rPr>
-              <a:t>前処理では見出し・段落・強調などのタグを外し、コーパスに含めないと指定された部分や削除部分は内容ごと除く。</a:t>
+              <a:t>まず、調べたい語句や文法形式と、比較する地域・ジャンルを決める。たとえば、会話同士、学術文同士で用例を集める。</a:t>
             </a:r>
           </a:p>
           <a:p>
@@ -10623,7 +10615,7 @@
                 <a:ea typeface="Noto Sans CJK JP"/>
                 <a:cs typeface="Noto Sans"/>
               </a:rPr>
-              <a:t>話者記号や一部の休止記号は残るため、書き起こしの特徴を含むテキストが評価対象になる。</a:t>
+              <a:t>頻度を比べるときは、対象にした本文の語数も数える。地域やジャンルで本文量が異なる場合は、一定語数あたりの出現回数にそろえる。</a:t>
             </a:r>
           </a:p>
           <a:p>
@@ -10653,7 +10645,7 @@
                 <a:ea typeface="Noto Sans CJK JP"/>
                 <a:cs typeface="Noto Sans"/>
               </a:rPr>
-              <a:t>文書はテスト用の入力として読み込み、本文への確率を評価する。質問に対する参照回答は付いていない。</a:t>
+              <a:t>検索で見つけた語句は前後の文脈とともに読み、話者・筆者の属性や転記記号も踏まえて使い方を比べる。</a:t>
             </a:r>
           </a:p>
         </p:txBody>
@@ -10750,7 +10742,7 @@
               <a:rPr sz="830">
                 <a:latin typeface="Noto Sans CJK JP"/>
               </a:rPr>
-              <a:t>[1] Stanford CRFM, HELM ICEScenario.</a:t>
+              <a:t>[1] International Corpus of English. Design of ICE Corpora.</a:t>
             </a:r>
           </a:p>
           <a:p>
@@ -10767,121 +10759,7 @@
                 <a:latin typeface="Noto Sans CJK JP"/>
                 <a:hlinkClick r:id="rId2"/>
               </a:rPr>
-              <a:t>https://github.com/stanford-crfm/helm/blob/v0.3.0/src/helm/benchmark/scenarios/ice_scenario.py</a:t>
-            </a:r>
-          </a:p>
-        </p:txBody>
-      </p:sp>
-    </p:spTree>
-  </p:cSld>
-  <p:clrMapOvr>
-    <a:masterClrMapping/>
-  </p:clrMapOvr>
-</p:sld>
-</file>
-
-<file path=ppt/slides/slide19.xml><?xml version="1.0" encoding="utf-8"?>
-<p:sld xmlns:a="http://schemas.openxmlformats.org/drawingml/2006/main" xmlns:p="http://schemas.openxmlformats.org/presentationml/2006/main" xmlns:r="http://schemas.openxmlformats.org/officeDocument/2006/relationships">
-  <p:cSld>
-    <p:spTree>
-      <p:nvGrpSpPr>
-        <p:cNvPr id="1" name=""/>
-        <p:cNvGrpSpPr/>
-        <p:nvPr/>
-      </p:nvGrpSpPr>
-      <p:grpSpPr/>
-      <p:sp>
-        <p:nvSpPr>
-          <p:cNvPr id="2" name="Title 1"/>
-          <p:cNvSpPr>
-            <a:spLocks noGrp="1"/>
-          </p:cNvSpPr>
-          <p:nvPr>
-            <p:ph type="title"/>
-          </p:nvPr>
-        </p:nvSpPr>
-        <p:spPr>
-          <a:xfrm>
-            <a:off x="548640" y="2506875"/>
-            <a:ext cx="8046720" cy="737616"/>
-          </a:xfrm>
-        </p:spPr>
-        <p:txBody>
-          <a:bodyPr wrap="square" lIns="0" rIns="0" tIns="0" bIns="152400" anchor="ctr">
-            <a:noAutofit/>
-          </a:bodyPr>
-          <a:lstStyle/>
-          <a:p>
-            <a:pPr algn="ctr">
-              <a:lnSpc>
-                <a:spcPct val="110000"/>
-              </a:lnSpc>
-              <a:buNone/>
-              <a:defRPr sz="3600" b="0">
-                <a:solidFill>
-                  <a:srgbClr val="303437"/>
-                </a:solidFill>
-                <a:latin typeface="Noto Sans"/>
-              </a:defRPr>
-            </a:pPr>
-            <a:r>
-              <a:rPr sz="3600" b="1" lang="ja-JP" altLang="en-US">
-                <a:solidFill>
-                  <a:srgbClr val="303437"/>
-                </a:solidFill>
-                <a:latin typeface="Noto Sans"/>
-                <a:ea typeface="Noto Sans CJK JP"/>
-                <a:cs typeface="Noto Sans"/>
-              </a:rPr>
-              <a:t>HELMでの言語モデル評価</a:t>
-            </a:r>
-          </a:p>
-        </p:txBody>
-      </p:sp>
-      <p:sp>
-        <p:nvSpPr>
-          <p:cNvPr id="3" name="Title 2"/>
-          <p:cNvSpPr>
-            <a:spLocks noGrp="1"/>
-          </p:cNvSpPr>
-          <p:nvPr>
-            <p:ph type="title" idx="2"/>
-          </p:nvPr>
-        </p:nvSpPr>
-        <p:spPr>
-          <a:xfrm>
-            <a:off x="75895" y="0"/>
-            <a:ext cx="8115300" cy="480060"/>
-          </a:xfrm>
-        </p:spPr>
-        <p:txBody>
-          <a:bodyPr wrap="square" lIns="0" rIns="0" tIns="0" bIns="0" anchor="ctr">
-            <a:noAutofit/>
-          </a:bodyPr>
-          <a:lstStyle/>
-          <a:p>
-            <a:pPr algn="l">
-              <a:lnSpc>
-                <a:spcPct val="110000"/>
-              </a:lnSpc>
-              <a:buNone/>
-              <a:defRPr sz="1400" b="0">
-                <a:solidFill>
-                  <a:srgbClr val="303437"/>
-                </a:solidFill>
-                <a:latin typeface="Noto Sans"/>
-              </a:defRPr>
-            </a:pPr>
-            <a:r>
-              <a:rPr sz="1400" b="1" lang="ja-JP" altLang="en-US">
-                <a:solidFill>
-                  <a:srgbClr val="FFFEF8"/>
-                </a:solidFill>
-                <a:latin typeface="Noto Sans"/>
-                <a:ea typeface="Noto Sans CJK JP"/>
-                <a:cs typeface="Noto Sans"/>
-              </a:rPr>
-              <a:t>3. HELMでの言語モデル評価</a:t>
+              <a:t>https://www.ice-corpora.uzh.ch/en/design.html</a:t>
             </a:r>
           </a:p>
         </p:txBody>
@@ -11098,2206 +10976,6 @@
 </p:sld>
 </file>
 
-<file path=ppt/slides/slide20.xml><?xml version="1.0" encoding="utf-8"?>
-<p:sld xmlns:a="http://schemas.openxmlformats.org/drawingml/2006/main" xmlns:p="http://schemas.openxmlformats.org/presentationml/2006/main" xmlns:r="http://schemas.openxmlformats.org/officeDocument/2006/relationships">
-  <p:cSld>
-    <p:spTree>
-      <p:nvGrpSpPr>
-        <p:cNvPr id="1" name=""/>
-        <p:cNvGrpSpPr/>
-        <p:nvPr/>
-      </p:nvGrpSpPr>
-      <p:grpSpPr/>
-      <p:sp>
-        <p:nvSpPr>
-          <p:cNvPr id="2" name="Title 1"/>
-          <p:cNvSpPr>
-            <a:spLocks noGrp="1"/>
-          </p:cNvSpPr>
-          <p:nvPr>
-            <p:ph type="title"/>
-          </p:nvPr>
-        </p:nvSpPr>
-        <p:spPr>
-          <a:xfrm>
-            <a:off x="468172" y="650138"/>
-            <a:ext cx="8206740" cy="616305"/>
-          </a:xfrm>
-        </p:spPr>
-        <p:txBody>
-          <a:bodyPr wrap="square" lIns="0" rIns="0" tIns="0" bIns="0">
-            <a:noAutofit/>
-          </a:bodyPr>
-          <a:lstStyle/>
-          <a:p>
-            <a:pPr algn="l">
-              <a:lnSpc>
-                <a:spcPct val="110000"/>
-              </a:lnSpc>
-              <a:buNone/>
-              <a:defRPr sz="2800" b="0">
-                <a:solidFill>
-                  <a:srgbClr val="303437"/>
-                </a:solidFill>
-                <a:latin typeface="Noto Sans"/>
-              </a:defRPr>
-            </a:pPr>
-            <a:r>
-              <a:rPr sz="2800" b="1" lang="ja-JP" altLang="en-US">
-                <a:solidFill>
-                  <a:srgbClr val="303437"/>
-                </a:solidFill>
-                <a:latin typeface="Noto Sans"/>
-                <a:ea typeface="Noto Sans CJK JP"/>
-                <a:cs typeface="Noto Sans"/>
-              </a:rPr>
-              <a:t>指標：本文に付けた確率を要約する</a:t>
-            </a:r>
-          </a:p>
-        </p:txBody>
-      </p:sp>
-      <p:sp>
-        <p:nvSpPr>
-          <p:cNvPr id="3" name="Text Placeholder 2"/>
-          <p:cNvSpPr>
-            <a:spLocks noGrp="1"/>
-          </p:cNvSpPr>
-          <p:nvPr>
-            <p:ph type="body" idx="1"/>
-          </p:nvPr>
-        </p:nvSpPr>
-        <p:spPr>
-          <a:xfrm>
-            <a:off x="594360" y="1463040"/>
-            <a:ext cx="7955279" cy="3044952"/>
-          </a:xfrm>
-        </p:spPr>
-        <p:txBody>
-          <a:bodyPr wrap="square" tIns="91440" bIns="91440">
-            <a:noAutofit/>
-          </a:bodyPr>
-          <a:lstStyle/>
-          <a:p>
-            <a:pPr marL="457200" indent="-355600">
-              <a:lnSpc>
-                <a:spcPts val="2499"/>
-              </a:lnSpc>
-              <a:spcAft>
-                <a:spcPts val="700"/>
-              </a:spcAft>
-              <a:buSzPct val="63333"/>
-              <a:buFont typeface="Noto Sans CJK JP"/>
-              <a:buChar char="●"/>
-              <a:defRPr sz="2100" b="0">
-                <a:solidFill>
-                  <a:srgbClr val="303437"/>
-                </a:solidFill>
-                <a:latin typeface="Noto Sans"/>
-              </a:defRPr>
-            </a:pPr>
-            <a:r>
-              <a:rPr sz="2100" b="0" lang="ja-JP" altLang="en-US">
-                <a:solidFill>
-                  <a:srgbClr val="303437"/>
-                </a:solidFill>
-                <a:latin typeface="Noto Sans"/>
-                <a:ea typeface="Noto Sans CJK JP"/>
-                <a:cs typeface="Noto Sans"/>
-              </a:rPr>
-              <a:t>perplexityは、本文のトークンに付けた負の平均対数確率を指数に戻した値。小さいほど、そのモデルが高い確率を付けたことを示す。</a:t>
-            </a:r>
-          </a:p>
-          <a:p>
-            <a:pPr marL="457200" indent="-355600">
-              <a:lnSpc>
-                <a:spcPts val="2499"/>
-              </a:lnSpc>
-              <a:spcAft>
-                <a:spcPts val="700"/>
-              </a:spcAft>
-              <a:buSzPct val="63333"/>
-              <a:buFont typeface="Noto Sans CJK JP"/>
-              <a:buChar char="●"/>
-              <a:defRPr sz="2100" b="0">
-                <a:solidFill>
-                  <a:srgbClr val="303437"/>
-                </a:solidFill>
-                <a:latin typeface="Noto Sans"/>
-              </a:defRPr>
-            </a:pPr>
-            <a:r>
-              <a:rPr sz="2100" b="0" lang="ja-JP" altLang="en-US">
-                <a:solidFill>
-                  <a:srgbClr val="303437"/>
-                </a:solidFill>
-                <a:latin typeface="Noto Sans"/>
-                <a:ea typeface="Noto Sans CJK JP"/>
-                <a:cs typeface="Noto Sans"/>
-              </a:rPr>
-              <a:t>HELMは文字列のUTF-8バイト数で正規化したbits per byteも報告する。これも小さいほどよい。</a:t>
-            </a:r>
-          </a:p>
-          <a:p>
-            <a:pPr marL="457200" indent="-355600">
-              <a:lnSpc>
-                <a:spcPts val="2499"/>
-              </a:lnSpc>
-              <a:spcAft>
-                <a:spcPts val="0"/>
-              </a:spcAft>
-              <a:buSzPct val="63333"/>
-              <a:buFont typeface="Noto Sans CJK JP"/>
-              <a:buChar char="●"/>
-              <a:defRPr sz="2100" b="0">
-                <a:solidFill>
-                  <a:srgbClr val="303437"/>
-                </a:solidFill>
-                <a:latin typeface="Noto Sans"/>
-              </a:defRPr>
-            </a:pPr>
-            <a:r>
-              <a:rPr sz="2100" b="0" lang="ja-JP" altLang="en-US">
-                <a:solidFill>
-                  <a:srgbClr val="303437"/>
-                </a:solidFill>
-                <a:latin typeface="Noto Sans"/>
-                <a:ea typeface="Noto Sans CJK JP"/>
-                <a:cs typeface="Noto Sans"/>
-              </a:rPr>
-              <a:t>モデルごとにトークン分割が異なるため、以下では共通のバイト単位による指標を使う。</a:t>
-            </a:r>
-          </a:p>
-        </p:txBody>
-      </p:sp>
-      <p:sp>
-        <p:nvSpPr>
-          <p:cNvPr id="4" name="Title 3"/>
-          <p:cNvSpPr>
-            <a:spLocks noGrp="1"/>
-          </p:cNvSpPr>
-          <p:nvPr>
-            <p:ph type="title" idx="2"/>
-          </p:nvPr>
-        </p:nvSpPr>
-        <p:spPr>
-          <a:xfrm>
-            <a:off x="75895" y="0"/>
-            <a:ext cx="8115300" cy="480060"/>
-          </a:xfrm>
-        </p:spPr>
-        <p:txBody>
-          <a:bodyPr wrap="square" lIns="0" rIns="0" tIns="0" bIns="0" anchor="ctr">
-            <a:noAutofit/>
-          </a:bodyPr>
-          <a:lstStyle/>
-          <a:p>
-            <a:pPr algn="l">
-              <a:lnSpc>
-                <a:spcPct val="110000"/>
-              </a:lnSpc>
-              <a:buNone/>
-              <a:defRPr sz="1400" b="0">
-                <a:solidFill>
-                  <a:srgbClr val="303437"/>
-                </a:solidFill>
-                <a:latin typeface="Noto Sans"/>
-              </a:defRPr>
-            </a:pPr>
-            <a:r>
-              <a:rPr sz="1400" b="1" lang="ja-JP" altLang="en-US">
-                <a:solidFill>
-                  <a:srgbClr val="FFFEF8"/>
-                </a:solidFill>
-                <a:latin typeface="Noto Sans"/>
-                <a:ea typeface="Noto Sans CJK JP"/>
-                <a:cs typeface="Noto Sans"/>
-              </a:rPr>
-              <a:t>3. HELMでの言語モデル評価</a:t>
-            </a:r>
-          </a:p>
-        </p:txBody>
-      </p:sp>
-      <p:sp>
-        <p:nvSpPr>
-          <p:cNvPr id="5" name="sources"/>
-          <p:cNvSpPr txBox="1"/>
-          <p:nvPr/>
-        </p:nvSpPr>
-        <p:spPr>
-          <a:xfrm>
-            <a:off x="502920" y="4699000"/>
-            <a:ext cx="8183879" cy="431800"/>
-          </a:xfrm>
-          <a:prstGeom prst="rect">
-            <a:avLst/>
-          </a:prstGeom>
-          <a:noFill/>
-        </p:spPr>
-        <p:txBody>
-          <a:bodyPr wrap="square" lIns="0" rIns="0" tIns="0" bIns="0">
-            <a:noAutofit/>
-          </a:bodyPr>
-          <a:lstStyle/>
-          <a:p>
-            <a:pPr algn="l">
-              <a:lnSpc>
-                <a:spcPts val="940"/>
-              </a:lnSpc>
-              <a:spcBef>
-                <a:spcPts val="0"/>
-              </a:spcBef>
-              <a:spcAft>
-                <a:spcPts val="0"/>
-              </a:spcAft>
-              <a:buNone/>
-              <a:defRPr sz="810" b="0">
-                <a:solidFill>
-                  <a:srgbClr val="303437"/>
-                </a:solidFill>
-                <a:latin typeface="Noto Sans"/>
-              </a:defRPr>
-            </a:pPr>
-            <a:r>
-              <a:rPr sz="830">
-                <a:latin typeface="Noto Sans CJK JP"/>
-              </a:rPr>
-              <a:t>[1] Liang et al. (2023), Holistic Evaluation of Language Models. TMLR.</a:t>
-            </a:r>
-          </a:p>
-          <a:p>
-            <a:pPr>
-              <a:spcBef>
-                <a:spcPts val="0"/>
-              </a:spcBef>
-              <a:spcAft>
-                <a:spcPts val="0"/>
-              </a:spcAft>
-            </a:pPr>
-            <a:r>
-              <a:rPr sz="830">
-                <a:latin typeface="Noto Sans CJK JP"/>
-                <a:hlinkClick r:id="rId2"/>
-              </a:rPr>
-              <a:t>https://arxiv.org/abs/2211.09110</a:t>
-            </a:r>
-          </a:p>
-        </p:txBody>
-      </p:sp>
-    </p:spTree>
-  </p:cSld>
-  <p:clrMapOvr>
-    <a:masterClrMapping/>
-  </p:clrMapOvr>
-</p:sld>
-</file>
-
-<file path=ppt/slides/slide21.xml><?xml version="1.0" encoding="utf-8"?>
-<p:sld xmlns:a="http://schemas.openxmlformats.org/drawingml/2006/main" xmlns:p="http://schemas.openxmlformats.org/presentationml/2006/main" xmlns:r="http://schemas.openxmlformats.org/officeDocument/2006/relationships">
-  <p:cSld>
-    <p:spTree>
-      <p:nvGrpSpPr>
-        <p:cNvPr id="1" name=""/>
-        <p:cNvGrpSpPr/>
-        <p:nvPr/>
-      </p:nvGrpSpPr>
-      <p:grpSpPr/>
-      <p:sp>
-        <p:nvSpPr>
-          <p:cNvPr id="2" name="Title 1"/>
-          <p:cNvSpPr>
-            <a:spLocks noGrp="1"/>
-          </p:cNvSpPr>
-          <p:nvPr>
-            <p:ph type="title"/>
-          </p:nvPr>
-        </p:nvSpPr>
-        <p:spPr>
-          <a:xfrm>
-            <a:off x="468172" y="650138"/>
-            <a:ext cx="8206740" cy="616305"/>
-          </a:xfrm>
-        </p:spPr>
-        <p:txBody>
-          <a:bodyPr wrap="square" lIns="0" rIns="0" tIns="0" bIns="0">
-            <a:noAutofit/>
-          </a:bodyPr>
-          <a:lstStyle/>
-          <a:p>
-            <a:pPr algn="l">
-              <a:lnSpc>
-                <a:spcPct val="110000"/>
-              </a:lnSpc>
-              <a:buNone/>
-              <a:defRPr sz="2800" b="0">
-                <a:solidFill>
-                  <a:srgbClr val="303437"/>
-                </a:solidFill>
-                <a:latin typeface="Noto Sans"/>
-              </a:defRPr>
-            </a:pPr>
-            <a:r>
-              <a:rPr sz="2800" b="1" lang="ja-JP" altLang="en-US">
-                <a:solidFill>
-                  <a:srgbClr val="303437"/>
-                </a:solidFill>
-                <a:latin typeface="Noto Sans"/>
-                <a:ea typeface="Noto Sans CJK JP"/>
-                <a:cs typeface="Noto Sans"/>
-              </a:rPr>
-              <a:t>4地域の英語で、モデルを比較する</a:t>
-            </a:r>
-          </a:p>
-        </p:txBody>
-      </p:sp>
-      <p:sp>
-        <p:nvSpPr>
-          <p:cNvPr id="3" name="Title 2"/>
-          <p:cNvSpPr>
-            <a:spLocks noGrp="1"/>
-          </p:cNvSpPr>
-          <p:nvPr>
-            <p:ph type="title" idx="2"/>
-          </p:nvPr>
-        </p:nvSpPr>
-        <p:spPr>
-          <a:xfrm>
-            <a:off x="75895" y="0"/>
-            <a:ext cx="8115300" cy="480060"/>
-          </a:xfrm>
-        </p:spPr>
-        <p:txBody>
-          <a:bodyPr wrap="square" lIns="0" rIns="0" tIns="0" bIns="0" anchor="ctr">
-            <a:noAutofit/>
-          </a:bodyPr>
-          <a:lstStyle/>
-          <a:p>
-            <a:pPr algn="l">
-              <a:lnSpc>
-                <a:spcPct val="110000"/>
-              </a:lnSpc>
-              <a:buNone/>
-              <a:defRPr sz="1400" b="0">
-                <a:solidFill>
-                  <a:srgbClr val="303437"/>
-                </a:solidFill>
-                <a:latin typeface="Noto Sans"/>
-              </a:defRPr>
-            </a:pPr>
-            <a:r>
-              <a:rPr sz="1400" b="1" lang="ja-JP" altLang="en-US">
-                <a:solidFill>
-                  <a:srgbClr val="FFFEF8"/>
-                </a:solidFill>
-                <a:latin typeface="Noto Sans"/>
-                <a:ea typeface="Noto Sans CJK JP"/>
-                <a:cs typeface="Noto Sans"/>
-              </a:rPr>
-              <a:t>3. HELMでの言語モデル評価</a:t>
-            </a:r>
-          </a:p>
-        </p:txBody>
-      </p:sp>
-      <p:graphicFrame>
-        <p:nvGraphicFramePr>
-          <p:cNvPr id="4" name="Table 3"/>
-          <p:cNvGraphicFramePr>
-            <a:graphicFrameLocks noGrp="1"/>
-          </p:cNvGraphicFramePr>
-          <p:nvPr/>
-        </p:nvGraphicFramePr>
-        <p:xfrm>
-          <a:off x="548640" y="1508760"/>
-          <a:ext cx="8046720" cy="2286000"/>
-        </p:xfrm>
-        <a:graphic>
-          <a:graphicData uri="http://schemas.openxmlformats.org/drawingml/2006/table">
-            <a:tbl>
-              <a:tblPr firstRow="0" bandRow="0"/>
-              <a:tblGrid>
-                <a:gridCol w="3200400"/>
-                <a:gridCol w="2286000"/>
-                <a:gridCol w="2560320"/>
-              </a:tblGrid>
-              <a:tr h="457200">
-                <a:tc>
-                  <a:txBody>
-                    <a:bodyPr wrap="square">
-                      <a:noAutofit/>
-                    </a:bodyPr>
-                    <a:lstStyle/>
-                    <a:p>
-                      <a:pPr algn="l">
-                        <a:lnSpc>
-                          <a:spcPts val="2415"/>
-                        </a:lnSpc>
-                        <a:buNone/>
-                        <a:defRPr sz="2100" b="0">
-                          <a:solidFill>
-                            <a:srgbClr val="303437"/>
-                          </a:solidFill>
-                          <a:latin typeface="Noto Sans"/>
-                        </a:defRPr>
-                      </a:pPr>
-                      <a:r>
-                        <a:rPr sz="2100" b="0" lang="ja-JP" altLang="en-US">
-                          <a:solidFill>
-                            <a:srgbClr val="303437"/>
-                          </a:solidFill>
-                          <a:latin typeface="Noto Sans"/>
-                          <a:ea typeface="Noto Sans CJK JP"/>
-                          <a:cs typeface="Noto Sans"/>
-                        </a:rPr>
-                        <a:t>地域</a:t>
-                      </a:r>
-                    </a:p>
-                  </a:txBody>
-                  <a:tcPr marL="63500" marR="63500" marT="38100" marB="38100" anchor="ctr">
-                    <a:lnL w="7620">
-                      <a:noFill/>
-                    </a:lnL>
-                    <a:lnR w="7620">
-                      <a:noFill/>
-                    </a:lnR>
-                    <a:lnT w="15240">
-                      <a:solidFill>
-                        <a:srgbClr val="626669"/>
-                      </a:solidFill>
-                      <a:prstDash val="solid"/>
-                    </a:lnT>
-                    <a:lnB w="7620">
-                      <a:solidFill>
-                        <a:srgbClr val="626669"/>
-                      </a:solidFill>
-                      <a:prstDash val="solid"/>
-                    </a:lnB>
-                    <a:solidFill>
-                      <a:srgbClr val="FFFEF8"/>
-                    </a:solidFill>
-                  </a:tcPr>
-                </a:tc>
-                <a:tc>
-                  <a:txBody>
-                    <a:bodyPr wrap="square">
-                      <a:noAutofit/>
-                    </a:bodyPr>
-                    <a:lstStyle/>
-                    <a:p>
-                      <a:pPr algn="r">
-                        <a:lnSpc>
-                          <a:spcPts val="2415"/>
-                        </a:lnSpc>
-                        <a:buNone/>
-                        <a:defRPr sz="2100" b="0">
-                          <a:solidFill>
-                            <a:srgbClr val="303437"/>
-                          </a:solidFill>
-                          <a:latin typeface="Noto Sans"/>
-                        </a:defRPr>
-                      </a:pPr>
-                      <a:r>
-                        <a:rPr sz="2100" b="0" lang="ja-JP" altLang="en-US">
-                          <a:solidFill>
-                            <a:srgbClr val="303437"/>
-                          </a:solidFill>
-                          <a:latin typeface="Noto Sans"/>
-                          <a:ea typeface="Noto Sans CJK JP"/>
-                          <a:cs typeface="Noto Sans"/>
-                        </a:rPr>
-                        <a:t>OPT-175B</a:t>
-                      </a:r>
-                    </a:p>
-                  </a:txBody>
-                  <a:tcPr marL="63500" marR="63500" marT="38100" marB="38100" anchor="ctr">
-                    <a:lnL w="7620">
-                      <a:noFill/>
-                    </a:lnL>
-                    <a:lnR w="7620">
-                      <a:noFill/>
-                    </a:lnR>
-                    <a:lnT w="15240">
-                      <a:solidFill>
-                        <a:srgbClr val="626669"/>
-                      </a:solidFill>
-                      <a:prstDash val="solid"/>
-                    </a:lnT>
-                    <a:lnB w="7620">
-                      <a:solidFill>
-                        <a:srgbClr val="626669"/>
-                      </a:solidFill>
-                      <a:prstDash val="solid"/>
-                    </a:lnB>
-                    <a:solidFill>
-                      <a:srgbClr val="FFFEF8"/>
-                    </a:solidFill>
-                  </a:tcPr>
-                </a:tc>
-                <a:tc>
-                  <a:txBody>
-                    <a:bodyPr wrap="square">
-                      <a:noAutofit/>
-                    </a:bodyPr>
-                    <a:lstStyle/>
-                    <a:p>
-                      <a:pPr algn="r">
-                        <a:lnSpc>
-                          <a:spcPts val="2415"/>
-                        </a:lnSpc>
-                        <a:buNone/>
-                        <a:defRPr sz="2100" b="0">
-                          <a:solidFill>
-                            <a:srgbClr val="303437"/>
-                          </a:solidFill>
-                          <a:latin typeface="Noto Sans"/>
-                        </a:defRPr>
-                      </a:pPr>
-                      <a:r>
-                        <a:rPr sz="2100" b="0" lang="ja-JP" altLang="en-US">
-                          <a:solidFill>
-                            <a:srgbClr val="303437"/>
-                          </a:solidFill>
-                          <a:latin typeface="Noto Sans"/>
-                          <a:ea typeface="Noto Sans CJK JP"/>
-                          <a:cs typeface="Noto Sans"/>
-                        </a:rPr>
-                        <a:t>text-davinci-003</a:t>
-                      </a:r>
-                    </a:p>
-                  </a:txBody>
-                  <a:tcPr marL="63500" marR="63500" marT="38100" marB="38100" anchor="ctr">
-                    <a:lnL w="7620">
-                      <a:noFill/>
-                    </a:lnL>
-                    <a:lnR w="7620">
-                      <a:noFill/>
-                    </a:lnR>
-                    <a:lnT w="15240">
-                      <a:solidFill>
-                        <a:srgbClr val="626669"/>
-                      </a:solidFill>
-                      <a:prstDash val="solid"/>
-                    </a:lnT>
-                    <a:lnB w="7620">
-                      <a:solidFill>
-                        <a:srgbClr val="626669"/>
-                      </a:solidFill>
-                      <a:prstDash val="solid"/>
-                    </a:lnB>
-                    <a:solidFill>
-                      <a:srgbClr val="FFFEF8"/>
-                    </a:solidFill>
-                  </a:tcPr>
-                </a:tc>
-              </a:tr>
-              <a:tr h="457200">
-                <a:tc>
-                  <a:txBody>
-                    <a:bodyPr wrap="square">
-                      <a:noAutofit/>
-                    </a:bodyPr>
-                    <a:lstStyle/>
-                    <a:p>
-                      <a:pPr algn="l">
-                        <a:lnSpc>
-                          <a:spcPts val="2415"/>
-                        </a:lnSpc>
-                        <a:buNone/>
-                        <a:defRPr sz="2100" b="0">
-                          <a:solidFill>
-                            <a:srgbClr val="303437"/>
-                          </a:solidFill>
-                          <a:latin typeface="Noto Sans"/>
-                        </a:defRPr>
-                      </a:pPr>
-                      <a:r>
-                        <a:rPr sz="2100" b="0" lang="ja-JP" altLang="en-US">
-                          <a:solidFill>
-                            <a:srgbClr val="303437"/>
-                          </a:solidFill>
-                          <a:latin typeface="Noto Sans"/>
-                          <a:ea typeface="Noto Sans CJK JP"/>
-                          <a:cs typeface="Noto Sans"/>
-                        </a:rPr>
-                        <a:t>East Africa</a:t>
-                      </a:r>
-                    </a:p>
-                  </a:txBody>
-                  <a:tcPr marL="63500" marR="63500" marT="38100" marB="38100" anchor="ctr">
-                    <a:lnL w="7620">
-                      <a:noFill/>
-                    </a:lnL>
-                    <a:lnR w="7620">
-                      <a:noFill/>
-                    </a:lnR>
-                    <a:lnT w="7620">
-                      <a:solidFill>
-                        <a:srgbClr val="626669"/>
-                      </a:solidFill>
-                      <a:prstDash val="solid"/>
-                    </a:lnT>
-                    <a:lnB w="7620">
-                      <a:noFill/>
-                    </a:lnB>
-                    <a:solidFill>
-                      <a:srgbClr val="FFFEF8"/>
-                    </a:solidFill>
-                  </a:tcPr>
-                </a:tc>
-                <a:tc>
-                  <a:txBody>
-                    <a:bodyPr wrap="square">
-                      <a:noAutofit/>
-                    </a:bodyPr>
-                    <a:lstStyle/>
-                    <a:p>
-                      <a:pPr algn="r">
-                        <a:lnSpc>
-                          <a:spcPts val="2415"/>
-                        </a:lnSpc>
-                        <a:buNone/>
-                        <a:defRPr sz="2100" b="0">
-                          <a:solidFill>
-                            <a:srgbClr val="303437"/>
-                          </a:solidFill>
-                          <a:latin typeface="Noto Sans"/>
-                        </a:defRPr>
-                      </a:pPr>
-                      <a:r>
-                        <a:rPr sz="2100" b="0" lang="ja-JP" altLang="en-US">
-                          <a:solidFill>
-                            <a:srgbClr val="303437"/>
-                          </a:solidFill>
-                          <a:latin typeface="Noto Sans"/>
-                          <a:ea typeface="Noto Sans CJK JP"/>
-                          <a:cs typeface="Noto Sans"/>
-                        </a:rPr>
-                        <a:t>0.661</a:t>
-                      </a:r>
-                    </a:p>
-                  </a:txBody>
-                  <a:tcPr marL="63500" marR="63500" marT="38100" marB="38100" anchor="ctr">
-                    <a:lnL w="7620">
-                      <a:noFill/>
-                    </a:lnL>
-                    <a:lnR w="7620">
-                      <a:noFill/>
-                    </a:lnR>
-                    <a:lnT w="7620">
-                      <a:solidFill>
-                        <a:srgbClr val="626669"/>
-                      </a:solidFill>
-                      <a:prstDash val="solid"/>
-                    </a:lnT>
-                    <a:lnB w="7620">
-                      <a:noFill/>
-                    </a:lnB>
-                    <a:solidFill>
-                      <a:srgbClr val="FFFEF8"/>
-                    </a:solidFill>
-                  </a:tcPr>
-                </a:tc>
-                <a:tc>
-                  <a:txBody>
-                    <a:bodyPr wrap="square">
-                      <a:noAutofit/>
-                    </a:bodyPr>
-                    <a:lstStyle/>
-                    <a:p>
-                      <a:pPr algn="r">
-                        <a:lnSpc>
-                          <a:spcPts val="2415"/>
-                        </a:lnSpc>
-                        <a:buNone/>
-                        <a:defRPr sz="2100" b="0">
-                          <a:solidFill>
-                            <a:srgbClr val="303437"/>
-                          </a:solidFill>
-                          <a:latin typeface="Noto Sans"/>
-                        </a:defRPr>
-                      </a:pPr>
-                      <a:r>
-                        <a:rPr sz="2100" b="0" lang="ja-JP" altLang="en-US">
-                          <a:solidFill>
-                            <a:srgbClr val="303437"/>
-                          </a:solidFill>
-                          <a:latin typeface="Noto Sans"/>
-                          <a:ea typeface="Noto Sans CJK JP"/>
-                          <a:cs typeface="Noto Sans"/>
-                        </a:rPr>
-                        <a:t>0.764</a:t>
-                      </a:r>
-                    </a:p>
-                  </a:txBody>
-                  <a:tcPr marL="63500" marR="63500" marT="38100" marB="38100" anchor="ctr">
-                    <a:lnL w="7620">
-                      <a:noFill/>
-                    </a:lnL>
-                    <a:lnR w="7620">
-                      <a:noFill/>
-                    </a:lnR>
-                    <a:lnT w="7620">
-                      <a:solidFill>
-                        <a:srgbClr val="626669"/>
-                      </a:solidFill>
-                      <a:prstDash val="solid"/>
-                    </a:lnT>
-                    <a:lnB w="7620">
-                      <a:noFill/>
-                    </a:lnB>
-                    <a:solidFill>
-                      <a:srgbClr val="FFFEF8"/>
-                    </a:solidFill>
-                  </a:tcPr>
-                </a:tc>
-              </a:tr>
-              <a:tr h="457200">
-                <a:tc>
-                  <a:txBody>
-                    <a:bodyPr wrap="square">
-                      <a:noAutofit/>
-                    </a:bodyPr>
-                    <a:lstStyle/>
-                    <a:p>
-                      <a:pPr algn="l">
-                        <a:lnSpc>
-                          <a:spcPts val="2415"/>
-                        </a:lnSpc>
-                        <a:buNone/>
-                        <a:defRPr sz="2100" b="0">
-                          <a:solidFill>
-                            <a:srgbClr val="303437"/>
-                          </a:solidFill>
-                          <a:latin typeface="Noto Sans"/>
-                        </a:defRPr>
-                      </a:pPr>
-                      <a:r>
-                        <a:rPr sz="2100" b="0" lang="ja-JP" altLang="en-US">
-                          <a:solidFill>
-                            <a:srgbClr val="303437"/>
-                          </a:solidFill>
-                          <a:latin typeface="Noto Sans"/>
-                          <a:ea typeface="Noto Sans CJK JP"/>
-                          <a:cs typeface="Noto Sans"/>
-                        </a:rPr>
-                        <a:t>Hong Kong</a:t>
-                      </a:r>
-                    </a:p>
-                  </a:txBody>
-                  <a:tcPr marL="63500" marR="63500" marT="38100" marB="38100" anchor="ctr">
-                    <a:lnL w="7620">
-                      <a:noFill/>
-                    </a:lnL>
-                    <a:lnR w="7620">
-                      <a:noFill/>
-                    </a:lnR>
-                    <a:lnT w="7620">
-                      <a:noFill/>
-                    </a:lnT>
-                    <a:lnB w="7620">
-                      <a:noFill/>
-                    </a:lnB>
-                    <a:solidFill>
-                      <a:srgbClr val="FFFEF8"/>
-                    </a:solidFill>
-                  </a:tcPr>
-                </a:tc>
-                <a:tc>
-                  <a:txBody>
-                    <a:bodyPr wrap="square">
-                      <a:noAutofit/>
-                    </a:bodyPr>
-                    <a:lstStyle/>
-                    <a:p>
-                      <a:pPr algn="r">
-                        <a:lnSpc>
-                          <a:spcPts val="2415"/>
-                        </a:lnSpc>
-                        <a:buNone/>
-                        <a:defRPr sz="2100" b="0">
-                          <a:solidFill>
-                            <a:srgbClr val="303437"/>
-                          </a:solidFill>
-                          <a:latin typeface="Noto Sans"/>
-                        </a:defRPr>
-                      </a:pPr>
-                      <a:r>
-                        <a:rPr sz="2100" b="0" lang="ja-JP" altLang="en-US">
-                          <a:solidFill>
-                            <a:srgbClr val="303437"/>
-                          </a:solidFill>
-                          <a:latin typeface="Noto Sans"/>
-                          <a:ea typeface="Noto Sans CJK JP"/>
-                          <a:cs typeface="Noto Sans"/>
-                        </a:rPr>
-                        <a:t>0.767</a:t>
-                      </a:r>
-                    </a:p>
-                  </a:txBody>
-                  <a:tcPr marL="63500" marR="63500" marT="38100" marB="38100" anchor="ctr">
-                    <a:lnL w="7620">
-                      <a:noFill/>
-                    </a:lnL>
-                    <a:lnR w="7620">
-                      <a:noFill/>
-                    </a:lnR>
-                    <a:lnT w="7620">
-                      <a:noFill/>
-                    </a:lnT>
-                    <a:lnB w="7620">
-                      <a:noFill/>
-                    </a:lnB>
-                    <a:solidFill>
-                      <a:srgbClr val="FFFEF8"/>
-                    </a:solidFill>
-                  </a:tcPr>
-                </a:tc>
-                <a:tc>
-                  <a:txBody>
-                    <a:bodyPr wrap="square">
-                      <a:noAutofit/>
-                    </a:bodyPr>
-                    <a:lstStyle/>
-                    <a:p>
-                      <a:pPr algn="r">
-                        <a:lnSpc>
-                          <a:spcPts val="2415"/>
-                        </a:lnSpc>
-                        <a:buNone/>
-                        <a:defRPr sz="2100" b="0">
-                          <a:solidFill>
-                            <a:srgbClr val="303437"/>
-                          </a:solidFill>
-                          <a:latin typeface="Noto Sans"/>
-                        </a:defRPr>
-                      </a:pPr>
-                      <a:r>
-                        <a:rPr sz="2100" b="0" lang="ja-JP" altLang="en-US">
-                          <a:solidFill>
-                            <a:srgbClr val="303437"/>
-                          </a:solidFill>
-                          <a:latin typeface="Noto Sans"/>
-                          <a:ea typeface="Noto Sans CJK JP"/>
-                          <a:cs typeface="Noto Sans"/>
-                        </a:rPr>
-                        <a:t>0.891</a:t>
-                      </a:r>
-                    </a:p>
-                  </a:txBody>
-                  <a:tcPr marL="63500" marR="63500" marT="38100" marB="38100" anchor="ctr">
-                    <a:lnL w="7620">
-                      <a:noFill/>
-                    </a:lnL>
-                    <a:lnR w="7620">
-                      <a:noFill/>
-                    </a:lnR>
-                    <a:lnT w="7620">
-                      <a:noFill/>
-                    </a:lnT>
-                    <a:lnB w="7620">
-                      <a:noFill/>
-                    </a:lnB>
-                    <a:solidFill>
-                      <a:srgbClr val="FFFEF8"/>
-                    </a:solidFill>
-                  </a:tcPr>
-                </a:tc>
-              </a:tr>
-              <a:tr h="457200">
-                <a:tc>
-                  <a:txBody>
-                    <a:bodyPr wrap="square">
-                      <a:noAutofit/>
-                    </a:bodyPr>
-                    <a:lstStyle/>
-                    <a:p>
-                      <a:pPr algn="l">
-                        <a:lnSpc>
-                          <a:spcPts val="2415"/>
-                        </a:lnSpc>
-                        <a:buNone/>
-                        <a:defRPr sz="2100" b="0">
-                          <a:solidFill>
-                            <a:srgbClr val="303437"/>
-                          </a:solidFill>
-                          <a:latin typeface="Noto Sans"/>
-                        </a:defRPr>
-                      </a:pPr>
-                      <a:r>
-                        <a:rPr sz="2100" b="0" lang="ja-JP" altLang="en-US">
-                          <a:solidFill>
-                            <a:srgbClr val="303437"/>
-                          </a:solidFill>
-                          <a:latin typeface="Noto Sans"/>
-                          <a:ea typeface="Noto Sans CJK JP"/>
-                          <a:cs typeface="Noto Sans"/>
-                        </a:rPr>
-                        <a:t>India</a:t>
-                      </a:r>
-                    </a:p>
-                  </a:txBody>
-                  <a:tcPr marL="63500" marR="63500" marT="38100" marB="38100" anchor="ctr">
-                    <a:lnL w="7620">
-                      <a:noFill/>
-                    </a:lnL>
-                    <a:lnR w="7620">
-                      <a:noFill/>
-                    </a:lnR>
-                    <a:lnT w="7620">
-                      <a:noFill/>
-                    </a:lnT>
-                    <a:lnB w="7620">
-                      <a:noFill/>
-                    </a:lnB>
-                    <a:solidFill>
-                      <a:srgbClr val="FFFEF8"/>
-                    </a:solidFill>
-                  </a:tcPr>
-                </a:tc>
-                <a:tc>
-                  <a:txBody>
-                    <a:bodyPr wrap="square">
-                      <a:noAutofit/>
-                    </a:bodyPr>
-                    <a:lstStyle/>
-                    <a:p>
-                      <a:pPr algn="r">
-                        <a:lnSpc>
-                          <a:spcPts val="2415"/>
-                        </a:lnSpc>
-                        <a:buNone/>
-                        <a:defRPr sz="2100" b="0">
-                          <a:solidFill>
-                            <a:srgbClr val="303437"/>
-                          </a:solidFill>
-                          <a:latin typeface="Noto Sans"/>
-                        </a:defRPr>
-                      </a:pPr>
-                      <a:r>
-                        <a:rPr sz="2100" b="0" lang="ja-JP" altLang="en-US">
-                          <a:solidFill>
-                            <a:srgbClr val="303437"/>
-                          </a:solidFill>
-                          <a:latin typeface="Noto Sans"/>
-                          <a:ea typeface="Noto Sans CJK JP"/>
-                          <a:cs typeface="Noto Sans"/>
-                        </a:rPr>
-                        <a:t>0.794</a:t>
-                      </a:r>
-                    </a:p>
-                  </a:txBody>
-                  <a:tcPr marL="63500" marR="63500" marT="38100" marB="38100" anchor="ctr">
-                    <a:lnL w="7620">
-                      <a:noFill/>
-                    </a:lnL>
-                    <a:lnR w="7620">
-                      <a:noFill/>
-                    </a:lnR>
-                    <a:lnT w="7620">
-                      <a:noFill/>
-                    </a:lnT>
-                    <a:lnB w="7620">
-                      <a:noFill/>
-                    </a:lnB>
-                    <a:solidFill>
-                      <a:srgbClr val="FFFEF8"/>
-                    </a:solidFill>
-                  </a:tcPr>
-                </a:tc>
-                <a:tc>
-                  <a:txBody>
-                    <a:bodyPr wrap="square">
-                      <a:noAutofit/>
-                    </a:bodyPr>
-                    <a:lstStyle/>
-                    <a:p>
-                      <a:pPr algn="r">
-                        <a:lnSpc>
-                          <a:spcPts val="2415"/>
-                        </a:lnSpc>
-                        <a:buNone/>
-                        <a:defRPr sz="2100" b="0">
-                          <a:solidFill>
-                            <a:srgbClr val="303437"/>
-                          </a:solidFill>
-                          <a:latin typeface="Noto Sans"/>
-                        </a:defRPr>
-                      </a:pPr>
-                      <a:r>
-                        <a:rPr sz="2100" b="0" lang="ja-JP" altLang="en-US">
-                          <a:solidFill>
-                            <a:srgbClr val="303437"/>
-                          </a:solidFill>
-                          <a:latin typeface="Noto Sans"/>
-                          <a:ea typeface="Noto Sans CJK JP"/>
-                          <a:cs typeface="Noto Sans"/>
-                        </a:rPr>
-                        <a:t>0.895</a:t>
-                      </a:r>
-                    </a:p>
-                  </a:txBody>
-                  <a:tcPr marL="63500" marR="63500" marT="38100" marB="38100" anchor="ctr">
-                    <a:lnL w="7620">
-                      <a:noFill/>
-                    </a:lnL>
-                    <a:lnR w="7620">
-                      <a:noFill/>
-                    </a:lnR>
-                    <a:lnT w="7620">
-                      <a:noFill/>
-                    </a:lnT>
-                    <a:lnB w="7620">
-                      <a:noFill/>
-                    </a:lnB>
-                    <a:solidFill>
-                      <a:srgbClr val="FFFEF8"/>
-                    </a:solidFill>
-                  </a:tcPr>
-                </a:tc>
-              </a:tr>
-              <a:tr h="457200">
-                <a:tc>
-                  <a:txBody>
-                    <a:bodyPr wrap="square">
-                      <a:noAutofit/>
-                    </a:bodyPr>
-                    <a:lstStyle/>
-                    <a:p>
-                      <a:pPr algn="l">
-                        <a:lnSpc>
-                          <a:spcPts val="2415"/>
-                        </a:lnSpc>
-                        <a:buNone/>
-                        <a:defRPr sz="2100" b="0">
-                          <a:solidFill>
-                            <a:srgbClr val="303437"/>
-                          </a:solidFill>
-                          <a:latin typeface="Noto Sans"/>
-                        </a:defRPr>
-                      </a:pPr>
-                      <a:r>
-                        <a:rPr sz="2100" b="0" lang="ja-JP" altLang="en-US">
-                          <a:solidFill>
-                            <a:srgbClr val="303437"/>
-                          </a:solidFill>
-                          <a:latin typeface="Noto Sans"/>
-                          <a:ea typeface="Noto Sans CJK JP"/>
-                          <a:cs typeface="Noto Sans"/>
-                        </a:rPr>
-                        <a:t>USA（書き言葉）</a:t>
-                      </a:r>
-                    </a:p>
-                  </a:txBody>
-                  <a:tcPr marL="63500" marR="63500" marT="38100" marB="38100" anchor="ctr">
-                    <a:lnL w="7620">
-                      <a:noFill/>
-                    </a:lnL>
-                    <a:lnR w="7620">
-                      <a:noFill/>
-                    </a:lnR>
-                    <a:lnT w="7620">
-                      <a:noFill/>
-                    </a:lnT>
-                    <a:lnB w="15240">
-                      <a:solidFill>
-                        <a:srgbClr val="626669"/>
-                      </a:solidFill>
-                      <a:prstDash val="solid"/>
-                    </a:lnB>
-                    <a:solidFill>
-                      <a:srgbClr val="FFFEF8"/>
-                    </a:solidFill>
-                  </a:tcPr>
-                </a:tc>
-                <a:tc>
-                  <a:txBody>
-                    <a:bodyPr wrap="square">
-                      <a:noAutofit/>
-                    </a:bodyPr>
-                    <a:lstStyle/>
-                    <a:p>
-                      <a:pPr algn="r">
-                        <a:lnSpc>
-                          <a:spcPts val="2415"/>
-                        </a:lnSpc>
-                        <a:buNone/>
-                        <a:defRPr sz="2100" b="0">
-                          <a:solidFill>
-                            <a:srgbClr val="303437"/>
-                          </a:solidFill>
-                          <a:latin typeface="Noto Sans"/>
-                        </a:defRPr>
-                      </a:pPr>
-                      <a:r>
-                        <a:rPr sz="2100" b="0" lang="ja-JP" altLang="en-US">
-                          <a:solidFill>
-                            <a:srgbClr val="303437"/>
-                          </a:solidFill>
-                          <a:latin typeface="Noto Sans"/>
-                          <a:ea typeface="Noto Sans CJK JP"/>
-                          <a:cs typeface="Noto Sans"/>
-                        </a:rPr>
-                        <a:t>0.700</a:t>
-                      </a:r>
-                    </a:p>
-                  </a:txBody>
-                  <a:tcPr marL="63500" marR="63500" marT="38100" marB="38100" anchor="ctr">
-                    <a:lnL w="7620">
-                      <a:noFill/>
-                    </a:lnL>
-                    <a:lnR w="7620">
-                      <a:noFill/>
-                    </a:lnR>
-                    <a:lnT w="7620">
-                      <a:noFill/>
-                    </a:lnT>
-                    <a:lnB w="15240">
-                      <a:solidFill>
-                        <a:srgbClr val="626669"/>
-                      </a:solidFill>
-                      <a:prstDash val="solid"/>
-                    </a:lnB>
-                    <a:solidFill>
-                      <a:srgbClr val="FFFEF8"/>
-                    </a:solidFill>
-                  </a:tcPr>
-                </a:tc>
-                <a:tc>
-                  <a:txBody>
-                    <a:bodyPr wrap="square">
-                      <a:noAutofit/>
-                    </a:bodyPr>
-                    <a:lstStyle/>
-                    <a:p>
-                      <a:pPr algn="r">
-                        <a:lnSpc>
-                          <a:spcPts val="2415"/>
-                        </a:lnSpc>
-                        <a:buNone/>
-                        <a:defRPr sz="2100" b="0">
-                          <a:solidFill>
-                            <a:srgbClr val="303437"/>
-                          </a:solidFill>
-                          <a:latin typeface="Noto Sans"/>
-                        </a:defRPr>
-                      </a:pPr>
-                      <a:r>
-                        <a:rPr sz="2100" b="0" lang="ja-JP" altLang="en-US">
-                          <a:solidFill>
-                            <a:srgbClr val="303437"/>
-                          </a:solidFill>
-                          <a:latin typeface="Noto Sans"/>
-                          <a:ea typeface="Noto Sans CJK JP"/>
-                          <a:cs typeface="Noto Sans"/>
-                        </a:rPr>
-                        <a:t>0.720</a:t>
-                      </a:r>
-                    </a:p>
-                  </a:txBody>
-                  <a:tcPr marL="63500" marR="63500" marT="38100" marB="38100" anchor="ctr">
-                    <a:lnL w="7620">
-                      <a:noFill/>
-                    </a:lnL>
-                    <a:lnR w="7620">
-                      <a:noFill/>
-                    </a:lnR>
-                    <a:lnT w="7620">
-                      <a:noFill/>
-                    </a:lnT>
-                    <a:lnB w="15240">
-                      <a:solidFill>
-                        <a:srgbClr val="626669"/>
-                      </a:solidFill>
-                      <a:prstDash val="solid"/>
-                    </a:lnB>
-                    <a:solidFill>
-                      <a:srgbClr val="FFFEF8"/>
-                    </a:solidFill>
-                  </a:tcPr>
-                </a:tc>
-              </a:tr>
-            </a:tbl>
-          </a:graphicData>
-        </a:graphic>
-      </p:graphicFrame>
-      <p:sp>
-        <p:nvSpPr>
-          <p:cNvPr id="5" name="TextBox 4"/>
-          <p:cNvSpPr txBox="1"/>
-          <p:nvPr/>
-        </p:nvSpPr>
-        <p:spPr>
-          <a:xfrm>
-            <a:off x="594360" y="3995928"/>
-            <a:ext cx="7955279" cy="658368"/>
-          </a:xfrm>
-          <a:prstGeom prst="rect">
-            <a:avLst/>
-          </a:prstGeom>
-          <a:noFill/>
-        </p:spPr>
-        <p:txBody>
-          <a:bodyPr wrap="square" lIns="0" rIns="0" tIns="0" bIns="0">
-            <a:noAutofit/>
-          </a:bodyPr>
-          <a:lstStyle/>
-          <a:p>
-            <a:pPr algn="l">
-              <a:lnSpc>
-                <a:spcPts val="2047"/>
-              </a:lnSpc>
-              <a:spcBef>
-                <a:spcPts val="0"/>
-              </a:spcBef>
-              <a:spcAft>
-                <a:spcPts val="0"/>
-              </a:spcAft>
-              <a:buNone/>
-              <a:defRPr sz="1750" b="0">
-                <a:solidFill>
-                  <a:srgbClr val="303437"/>
-                </a:solidFill>
-                <a:latin typeface="Noto Sans"/>
-              </a:defRPr>
-            </a:pPr>
-            <a:r>
-              <a:rPr sz="1750" b="0" lang="ja-JP" altLang="en-US">
-                <a:solidFill>
-                  <a:srgbClr val="303437"/>
-                </a:solidFill>
-                <a:latin typeface="Noto Sans"/>
-                <a:ea typeface="Noto Sans CJK JP"/>
-                <a:cs typeface="Noto Sans"/>
-              </a:rPr>
-              <a:t>HELM Classicの2023年の公開結果。各1試行、bits per byteは小さいほどよい。</a:t>
-            </a:r>
-          </a:p>
-        </p:txBody>
-      </p:sp>
-      <p:sp>
-        <p:nvSpPr>
-          <p:cNvPr id="6" name="sources"/>
-          <p:cNvSpPr txBox="1"/>
-          <p:nvPr/>
-        </p:nvSpPr>
-        <p:spPr>
-          <a:xfrm>
-            <a:off x="502920" y="4699000"/>
-            <a:ext cx="8183879" cy="431800"/>
-          </a:xfrm>
-          <a:prstGeom prst="rect">
-            <a:avLst/>
-          </a:prstGeom>
-          <a:noFill/>
-        </p:spPr>
-        <p:txBody>
-          <a:bodyPr wrap="square" lIns="0" rIns="0" tIns="0" bIns="0">
-            <a:noAutofit/>
-          </a:bodyPr>
-          <a:lstStyle/>
-          <a:p>
-            <a:pPr algn="l">
-              <a:lnSpc>
-                <a:spcPts val="940"/>
-              </a:lnSpc>
-              <a:spcBef>
-                <a:spcPts val="0"/>
-              </a:spcBef>
-              <a:spcAft>
-                <a:spcPts val="0"/>
-              </a:spcAft>
-              <a:buNone/>
-              <a:defRPr sz="810" b="0">
-                <a:solidFill>
-                  <a:srgbClr val="303437"/>
-                </a:solidFill>
-                <a:latin typeface="Noto Sans"/>
-              </a:defRPr>
-            </a:pPr>
-            <a:r>
-              <a:rPr sz="830">
-                <a:latin typeface="Noto Sans CJK JP"/>
-              </a:rPr>
-              <a:t>[1] HELM Classic v0.4.0, ICE.</a:t>
-            </a:r>
-          </a:p>
-          <a:p>
-            <a:pPr>
-              <a:spcBef>
-                <a:spcPts val="0"/>
-              </a:spcBef>
-              <a:spcAft>
-                <a:spcPts val="0"/>
-              </a:spcAft>
-            </a:pPr>
-            <a:r>
-              <a:rPr sz="830">
-                <a:latin typeface="Noto Sans CJK JP"/>
-                <a:hlinkClick r:id="rId2"/>
-              </a:rPr>
-              <a:t>https://crfm.stanford.edu/helm/classic/v0.4.0/#/groups/ice</a:t>
-            </a:r>
-          </a:p>
-        </p:txBody>
-      </p:sp>
-    </p:spTree>
-  </p:cSld>
-  <p:clrMapOvr>
-    <a:masterClrMapping/>
-  </p:clrMapOvr>
-</p:sld>
-</file>
-
-<file path=ppt/slides/slide22.xml><?xml version="1.0" encoding="utf-8"?>
-<p:sld xmlns:a="http://schemas.openxmlformats.org/drawingml/2006/main" xmlns:p="http://schemas.openxmlformats.org/presentationml/2006/main" xmlns:r="http://schemas.openxmlformats.org/officeDocument/2006/relationships">
-  <p:cSld>
-    <p:spTree>
-      <p:nvGrpSpPr>
-        <p:cNvPr id="1" name=""/>
-        <p:cNvGrpSpPr/>
-        <p:nvPr/>
-      </p:nvGrpSpPr>
-      <p:grpSpPr/>
-      <p:sp>
-        <p:nvSpPr>
-          <p:cNvPr id="2" name="Title 1"/>
-          <p:cNvSpPr>
-            <a:spLocks noGrp="1"/>
-          </p:cNvSpPr>
-          <p:nvPr>
-            <p:ph type="title"/>
-          </p:nvPr>
-        </p:nvSpPr>
-        <p:spPr>
-          <a:xfrm>
-            <a:off x="468172" y="650138"/>
-            <a:ext cx="8206740" cy="616305"/>
-          </a:xfrm>
-        </p:spPr>
-        <p:txBody>
-          <a:bodyPr wrap="square" lIns="0" rIns="0" tIns="0" bIns="0">
-            <a:noAutofit/>
-          </a:bodyPr>
-          <a:lstStyle/>
-          <a:p>
-            <a:pPr algn="l">
-              <a:lnSpc>
-                <a:spcPct val="110000"/>
-              </a:lnSpc>
-              <a:buNone/>
-              <a:defRPr sz="2800" b="0">
-                <a:solidFill>
-                  <a:srgbClr val="303437"/>
-                </a:solidFill>
-                <a:latin typeface="Noto Sans"/>
-              </a:defRPr>
-            </a:pPr>
-            <a:r>
-              <a:rPr sz="2800" b="1" lang="ja-JP" altLang="en-US">
-                <a:solidFill>
-                  <a:srgbClr val="303437"/>
-                </a:solidFill>
-                <a:latin typeface="Noto Sans"/>
-                <a:ea typeface="Noto Sans CJK JP"/>
-                <a:cs typeface="Noto Sans"/>
-              </a:rPr>
-              <a:t>地域ごとに、異なる構成のテキストを評価</a:t>
-            </a:r>
-          </a:p>
-        </p:txBody>
-      </p:sp>
-      <p:sp>
-        <p:nvSpPr>
-          <p:cNvPr id="3" name="Text Placeholder 2"/>
-          <p:cNvSpPr>
-            <a:spLocks noGrp="1"/>
-          </p:cNvSpPr>
-          <p:nvPr>
-            <p:ph type="body" idx="1"/>
-          </p:nvPr>
-        </p:nvSpPr>
-        <p:spPr>
-          <a:xfrm>
-            <a:off x="594360" y="1463040"/>
-            <a:ext cx="7955279" cy="3044952"/>
-          </a:xfrm>
-        </p:spPr>
-        <p:txBody>
-          <a:bodyPr wrap="square" tIns="91440" bIns="91440">
-            <a:noAutofit/>
-          </a:bodyPr>
-          <a:lstStyle/>
-          <a:p>
-            <a:pPr marL="457200" indent="-355600">
-              <a:lnSpc>
-                <a:spcPts val="2499"/>
-              </a:lnSpc>
-              <a:spcAft>
-                <a:spcPts val="700"/>
-              </a:spcAft>
-              <a:buSzPct val="63333"/>
-              <a:buFont typeface="Noto Sans CJK JP"/>
-              <a:buChar char="●"/>
-              <a:defRPr sz="2100" b="0">
-                <a:solidFill>
-                  <a:srgbClr val="303437"/>
-                </a:solidFill>
-                <a:latin typeface="Noto Sans"/>
-              </a:defRPr>
-            </a:pPr>
-            <a:r>
-              <a:rPr sz="2100" b="0" lang="ja-JP" altLang="en-US">
-                <a:solidFill>
-                  <a:srgbClr val="303437"/>
-                </a:solidFill>
-                <a:latin typeface="Noto Sans"/>
-                <a:ea typeface="Noto Sans CJK JP"/>
-                <a:cs typeface="Noto Sans"/>
-              </a:rPr>
-              <a:t>2023年の公開結果では、OPT-175Bとtext-davinci-003の2モデルを比較できる。ともに2022年に登場したモデルで、示した4地域ではOPT-175Bのbits per byteが小さい。</a:t>
-            </a:r>
-          </a:p>
-          <a:p>
-            <a:pPr marL="457200" indent="-355600">
-              <a:lnSpc>
-                <a:spcPts val="2499"/>
-              </a:lnSpc>
-              <a:spcAft>
-                <a:spcPts val="700"/>
-              </a:spcAft>
-              <a:buSzPct val="63333"/>
-              <a:buFont typeface="Noto Sans CJK JP"/>
-              <a:buChar char="●"/>
-              <a:defRPr sz="2100" b="0">
-                <a:solidFill>
-                  <a:srgbClr val="303437"/>
-                </a:solidFill>
-                <a:latin typeface="Noto Sans"/>
-              </a:defRPr>
-            </a:pPr>
-            <a:r>
-              <a:rPr sz="2100" b="0" lang="ja-JP" altLang="en-US">
-                <a:solidFill>
-                  <a:srgbClr val="303437"/>
-                </a:solidFill>
-                <a:latin typeface="Noto Sans"/>
-                <a:ea typeface="Noto Sans CJK JP"/>
-                <a:cs typeface="Noto Sans"/>
-              </a:rPr>
-              <a:t>評価対象はEast Africaが625件、Hong KongとIndiaが各500件、USAが200件。USAは書き言葉のみで、他地域とは件数やジャンル構成が異なる。</a:t>
-            </a:r>
-          </a:p>
-        </p:txBody>
-      </p:sp>
-      <p:sp>
-        <p:nvSpPr>
-          <p:cNvPr id="4" name="Title 3"/>
-          <p:cNvSpPr>
-            <a:spLocks noGrp="1"/>
-          </p:cNvSpPr>
-          <p:nvPr>
-            <p:ph type="title" idx="2"/>
-          </p:nvPr>
-        </p:nvSpPr>
-        <p:spPr>
-          <a:xfrm>
-            <a:off x="75895" y="0"/>
-            <a:ext cx="8115300" cy="480060"/>
-          </a:xfrm>
-        </p:spPr>
-        <p:txBody>
-          <a:bodyPr wrap="square" lIns="0" rIns="0" tIns="0" bIns="0" anchor="ctr">
-            <a:noAutofit/>
-          </a:bodyPr>
-          <a:lstStyle/>
-          <a:p>
-            <a:pPr algn="l">
-              <a:lnSpc>
-                <a:spcPct val="110000"/>
-              </a:lnSpc>
-              <a:buNone/>
-              <a:defRPr sz="1400" b="0">
-                <a:solidFill>
-                  <a:srgbClr val="303437"/>
-                </a:solidFill>
-                <a:latin typeface="Noto Sans"/>
-              </a:defRPr>
-            </a:pPr>
-            <a:r>
-              <a:rPr sz="1400" b="1" lang="ja-JP" altLang="en-US">
-                <a:solidFill>
-                  <a:srgbClr val="FFFEF8"/>
-                </a:solidFill>
-                <a:latin typeface="Noto Sans"/>
-                <a:ea typeface="Noto Sans CJK JP"/>
-                <a:cs typeface="Noto Sans"/>
-              </a:rPr>
-              <a:t>3. HELMでの言語モデル評価</a:t>
-            </a:r>
-          </a:p>
-        </p:txBody>
-      </p:sp>
-      <p:sp>
-        <p:nvSpPr>
-          <p:cNvPr id="5" name="sources"/>
-          <p:cNvSpPr txBox="1"/>
-          <p:nvPr/>
-        </p:nvSpPr>
-        <p:spPr>
-          <a:xfrm>
-            <a:off x="502920" y="4699000"/>
-            <a:ext cx="8183879" cy="431800"/>
-          </a:xfrm>
-          <a:prstGeom prst="rect">
-            <a:avLst/>
-          </a:prstGeom>
-          <a:noFill/>
-        </p:spPr>
-        <p:txBody>
-          <a:bodyPr wrap="square" lIns="0" rIns="0" tIns="0" bIns="0">
-            <a:noAutofit/>
-          </a:bodyPr>
-          <a:lstStyle/>
-          <a:p>
-            <a:pPr algn="l">
-              <a:lnSpc>
-                <a:spcPts val="940"/>
-              </a:lnSpc>
-              <a:spcBef>
-                <a:spcPts val="0"/>
-              </a:spcBef>
-              <a:spcAft>
-                <a:spcPts val="0"/>
-              </a:spcAft>
-              <a:buNone/>
-              <a:defRPr sz="810" b="0">
-                <a:solidFill>
-                  <a:srgbClr val="303437"/>
-                </a:solidFill>
-                <a:latin typeface="Noto Sans"/>
-              </a:defRPr>
-            </a:pPr>
-            <a:r>
-              <a:rPr sz="830">
-                <a:latin typeface="Noto Sans CJK JP"/>
-              </a:rPr>
-              <a:t>[1] HELM Classic v0.4.0, ICE.</a:t>
-            </a:r>
-          </a:p>
-          <a:p>
-            <a:pPr>
-              <a:spcBef>
-                <a:spcPts val="0"/>
-              </a:spcBef>
-              <a:spcAft>
-                <a:spcPts val="0"/>
-              </a:spcAft>
-            </a:pPr>
-            <a:r>
-              <a:rPr sz="830">
-                <a:latin typeface="Noto Sans CJK JP"/>
-                <a:hlinkClick r:id="rId2"/>
-              </a:rPr>
-              <a:t>https://crfm.stanford.edu/helm/classic/v0.4.0/#/groups/ice</a:t>
-            </a:r>
-          </a:p>
-        </p:txBody>
-      </p:sp>
-    </p:spTree>
-  </p:cSld>
-  <p:clrMapOvr>
-    <a:masterClrMapping/>
-  </p:clrMapOvr>
-</p:sld>
-</file>
-
-<file path=ppt/slides/slide23.xml><?xml version="1.0" encoding="utf-8"?>
-<p:sld xmlns:a="http://schemas.openxmlformats.org/drawingml/2006/main" xmlns:p="http://schemas.openxmlformats.org/presentationml/2006/main" xmlns:r="http://schemas.openxmlformats.org/officeDocument/2006/relationships">
-  <p:cSld>
-    <p:spTree>
-      <p:nvGrpSpPr>
-        <p:cNvPr id="1" name=""/>
-        <p:cNvGrpSpPr/>
-        <p:nvPr/>
-      </p:nvGrpSpPr>
-      <p:grpSpPr/>
-      <p:sp>
-        <p:nvSpPr>
-          <p:cNvPr id="2" name="Title 1"/>
-          <p:cNvSpPr>
-            <a:spLocks noGrp="1"/>
-          </p:cNvSpPr>
-          <p:nvPr>
-            <p:ph type="title"/>
-          </p:nvPr>
-        </p:nvSpPr>
-        <p:spPr>
-          <a:xfrm>
-            <a:off x="468172" y="650138"/>
-            <a:ext cx="8206740" cy="616305"/>
-          </a:xfrm>
-        </p:spPr>
-        <p:txBody>
-          <a:bodyPr wrap="square" lIns="0" rIns="0" tIns="0" bIns="0">
-            <a:noAutofit/>
-          </a:bodyPr>
-          <a:lstStyle/>
-          <a:p>
-            <a:pPr algn="l">
-              <a:lnSpc>
-                <a:spcPct val="110000"/>
-              </a:lnSpc>
-              <a:buNone/>
-              <a:defRPr sz="2800" b="0">
-                <a:solidFill>
-                  <a:srgbClr val="303437"/>
-                </a:solidFill>
-                <a:latin typeface="Noto Sans"/>
-              </a:defRPr>
-            </a:pPr>
-            <a:r>
-              <a:rPr sz="2800" b="1" lang="ja-JP" altLang="en-US">
-                <a:solidFill>
-                  <a:srgbClr val="303437"/>
-                </a:solidFill>
-                <a:latin typeface="Noto Sans"/>
-                <a:ea typeface="Noto Sans CJK JP"/>
-                <a:cs typeface="Noto Sans"/>
-              </a:rPr>
-              <a:t>長い文書は、入力長に合わせて評価する</a:t>
-            </a:r>
-          </a:p>
-        </p:txBody>
-      </p:sp>
-      <p:sp>
-        <p:nvSpPr>
-          <p:cNvPr id="3" name="Text Placeholder 2"/>
-          <p:cNvSpPr>
-            <a:spLocks noGrp="1"/>
-          </p:cNvSpPr>
-          <p:nvPr>
-            <p:ph type="body" idx="1"/>
-          </p:nvPr>
-        </p:nvSpPr>
-        <p:spPr>
-          <a:xfrm>
-            <a:off x="594360" y="1463040"/>
-            <a:ext cx="7955279" cy="3044952"/>
-          </a:xfrm>
-        </p:spPr>
-        <p:txBody>
-          <a:bodyPr wrap="square" tIns="91440" bIns="91440">
-            <a:noAutofit/>
-          </a:bodyPr>
-          <a:lstStyle/>
-          <a:p>
-            <a:pPr marL="457200" indent="-355600">
-              <a:lnSpc>
-                <a:spcPts val="2499"/>
-              </a:lnSpc>
-              <a:spcAft>
-                <a:spcPts val="700"/>
-              </a:spcAft>
-              <a:buSzPct val="63333"/>
-              <a:buFont typeface="Noto Sans CJK JP"/>
-              <a:buChar char="●"/>
-              <a:defRPr sz="2100" b="0">
-                <a:solidFill>
-                  <a:srgbClr val="303437"/>
-                </a:solidFill>
-                <a:latin typeface="Noto Sans"/>
-              </a:defRPr>
-            </a:pPr>
-            <a:r>
-              <a:rPr sz="2100" b="0" lang="ja-JP" altLang="en-US">
-                <a:solidFill>
-                  <a:srgbClr val="303437"/>
-                </a:solidFill>
-                <a:latin typeface="Noto Sans"/>
-                <a:ea typeface="Noto Sans CJK JP"/>
-                <a:cs typeface="Noto Sans"/>
-              </a:rPr>
-              <a:t>HELMは例題を提示せず、本文の語や記号にモデルが付けた確率を取得する。新しい回答文は生成しない。</a:t>
-            </a:r>
-          </a:p>
-          <a:p>
-            <a:pPr marL="457200" indent="-355600">
-              <a:lnSpc>
-                <a:spcPts val="2499"/>
-              </a:lnSpc>
-              <a:spcAft>
-                <a:spcPts val="700"/>
-              </a:spcAft>
-              <a:buSzPct val="63333"/>
-              <a:buFont typeface="Noto Sans CJK JP"/>
-              <a:buChar char="●"/>
-              <a:defRPr sz="2100" b="0">
-                <a:solidFill>
-                  <a:srgbClr val="303437"/>
-                </a:solidFill>
-                <a:latin typeface="Noto Sans"/>
-              </a:defRPr>
-            </a:pPr>
-            <a:r>
-              <a:rPr sz="2100" b="0" lang="ja-JP" altLang="en-US">
-                <a:solidFill>
-                  <a:srgbClr val="303437"/>
-                </a:solidFill>
-                <a:latin typeface="Noto Sans"/>
-                <a:ea typeface="Noto Sans CJK JP"/>
-                <a:cs typeface="Noto Sans"/>
-              </a:rPr>
-              <a:t>一つの文書が長い場合は、モデルの入力長に合わせて複数回に分けて処理する。文書数と、モデルを呼び出す回数は一致しない。</a:t>
-            </a:r>
-          </a:p>
-        </p:txBody>
-      </p:sp>
-      <p:sp>
-        <p:nvSpPr>
-          <p:cNvPr id="4" name="Title 3"/>
-          <p:cNvSpPr>
-            <a:spLocks noGrp="1"/>
-          </p:cNvSpPr>
-          <p:nvPr>
-            <p:ph type="title" idx="2"/>
-          </p:nvPr>
-        </p:nvSpPr>
-        <p:spPr>
-          <a:xfrm>
-            <a:off x="75895" y="0"/>
-            <a:ext cx="8115300" cy="480060"/>
-          </a:xfrm>
-        </p:spPr>
-        <p:txBody>
-          <a:bodyPr wrap="square" lIns="0" rIns="0" tIns="0" bIns="0" anchor="ctr">
-            <a:noAutofit/>
-          </a:bodyPr>
-          <a:lstStyle/>
-          <a:p>
-            <a:pPr algn="l">
-              <a:lnSpc>
-                <a:spcPct val="110000"/>
-              </a:lnSpc>
-              <a:buNone/>
-              <a:defRPr sz="1400" b="0">
-                <a:solidFill>
-                  <a:srgbClr val="303437"/>
-                </a:solidFill>
-                <a:latin typeface="Noto Sans"/>
-              </a:defRPr>
-            </a:pPr>
-            <a:r>
-              <a:rPr sz="1400" b="1" lang="ja-JP" altLang="en-US">
-                <a:solidFill>
-                  <a:srgbClr val="FFFEF8"/>
-                </a:solidFill>
-                <a:latin typeface="Noto Sans"/>
-                <a:ea typeface="Noto Sans CJK JP"/>
-                <a:cs typeface="Noto Sans"/>
-              </a:rPr>
-              <a:t>3. HELMでの言語モデル評価</a:t>
-            </a:r>
-          </a:p>
-        </p:txBody>
-      </p:sp>
-      <p:sp>
-        <p:nvSpPr>
-          <p:cNvPr id="5" name="sources"/>
-          <p:cNvSpPr txBox="1"/>
-          <p:nvPr/>
-        </p:nvSpPr>
-        <p:spPr>
-          <a:xfrm>
-            <a:off x="502920" y="4699000"/>
-            <a:ext cx="8183879" cy="431800"/>
-          </a:xfrm>
-          <a:prstGeom prst="rect">
-            <a:avLst/>
-          </a:prstGeom>
-          <a:noFill/>
-        </p:spPr>
-        <p:txBody>
-          <a:bodyPr wrap="square" lIns="0" rIns="0" tIns="0" bIns="0">
-            <a:noAutofit/>
-          </a:bodyPr>
-          <a:lstStyle/>
-          <a:p>
-            <a:pPr algn="l">
-              <a:lnSpc>
-                <a:spcPts val="940"/>
-              </a:lnSpc>
-              <a:spcBef>
-                <a:spcPts val="0"/>
-              </a:spcBef>
-              <a:spcAft>
-                <a:spcPts val="0"/>
-              </a:spcAft>
-              <a:buNone/>
-              <a:defRPr sz="810" b="0">
-                <a:solidFill>
-                  <a:srgbClr val="303437"/>
-                </a:solidFill>
-                <a:latin typeface="Noto Sans"/>
-              </a:defRPr>
-            </a:pPr>
-            <a:r>
-              <a:rPr sz="830">
-                <a:latin typeface="Noto Sans CJK JP"/>
-              </a:rPr>
-              <a:t>[1] HELM Classic v0.4.0, ICE.</a:t>
-            </a:r>
-          </a:p>
-          <a:p>
-            <a:pPr>
-              <a:spcBef>
-                <a:spcPts val="0"/>
-              </a:spcBef>
-              <a:spcAft>
-                <a:spcPts val="0"/>
-              </a:spcAft>
-            </a:pPr>
-            <a:r>
-              <a:rPr sz="830">
-                <a:latin typeface="Noto Sans CJK JP"/>
-                <a:hlinkClick r:id="rId2"/>
-              </a:rPr>
-              <a:t>https://crfm.stanford.edu/helm/classic/v0.4.0/#/groups/ice</a:t>
-            </a:r>
-          </a:p>
-        </p:txBody>
-      </p:sp>
-    </p:spTree>
-  </p:cSld>
-  <p:clrMapOvr>
-    <a:masterClrMapping/>
-  </p:clrMapOvr>
-</p:sld>
-</file>
-
-<file path=ppt/slides/slide24.xml><?xml version="1.0" encoding="utf-8"?>
-<p:sld xmlns:a="http://schemas.openxmlformats.org/drawingml/2006/main" xmlns:p="http://schemas.openxmlformats.org/presentationml/2006/main" xmlns:r="http://schemas.openxmlformats.org/officeDocument/2006/relationships">
-  <p:cSld>
-    <p:spTree>
-      <p:nvGrpSpPr>
-        <p:cNvPr id="1" name=""/>
-        <p:cNvGrpSpPr/>
-        <p:nvPr/>
-      </p:nvGrpSpPr>
-      <p:grpSpPr/>
-      <p:sp>
-        <p:nvSpPr>
-          <p:cNvPr id="2" name="Title 1"/>
-          <p:cNvSpPr>
-            <a:spLocks noGrp="1"/>
-          </p:cNvSpPr>
-          <p:nvPr>
-            <p:ph type="title"/>
-          </p:nvPr>
-        </p:nvSpPr>
-        <p:spPr>
-          <a:xfrm>
-            <a:off x="468172" y="650138"/>
-            <a:ext cx="8206740" cy="616305"/>
-          </a:xfrm>
-        </p:spPr>
-        <p:txBody>
-          <a:bodyPr wrap="square" lIns="0" rIns="0" tIns="0" bIns="0">
-            <a:noAutofit/>
-          </a:bodyPr>
-          <a:lstStyle/>
-          <a:p>
-            <a:pPr algn="l">
-              <a:lnSpc>
-                <a:spcPct val="110000"/>
-              </a:lnSpc>
-              <a:buNone/>
-              <a:defRPr sz="2800" b="0">
-                <a:solidFill>
-                  <a:srgbClr val="303437"/>
-                </a:solidFill>
-                <a:latin typeface="Noto Sans"/>
-              </a:defRPr>
-            </a:pPr>
-            <a:r>
-              <a:rPr sz="2800" b="1" lang="ja-JP" altLang="en-US">
-                <a:solidFill>
-                  <a:srgbClr val="303437"/>
-                </a:solidFill>
-                <a:latin typeface="Noto Sans"/>
-                <a:ea typeface="Noto Sans CJK JP"/>
-                <a:cs typeface="Noto Sans"/>
-              </a:rPr>
-              <a:t>地域や性別による差を調べる入口になる</a:t>
-            </a:r>
-          </a:p>
-        </p:txBody>
-      </p:sp>
-      <p:sp>
-        <p:nvSpPr>
-          <p:cNvPr id="3" name="Text Placeholder 2"/>
-          <p:cNvSpPr>
-            <a:spLocks noGrp="1"/>
-          </p:cNvSpPr>
-          <p:nvPr>
-            <p:ph type="body" idx="1"/>
-          </p:nvPr>
-        </p:nvSpPr>
-        <p:spPr>
-          <a:xfrm>
-            <a:off x="594360" y="1463040"/>
-            <a:ext cx="7955279" cy="3044952"/>
-          </a:xfrm>
-        </p:spPr>
-        <p:txBody>
-          <a:bodyPr wrap="square" tIns="91440" bIns="91440">
-            <a:noAutofit/>
-          </a:bodyPr>
-          <a:lstStyle/>
-          <a:p>
-            <a:pPr marL="457200" indent="-355600">
-              <a:lnSpc>
-                <a:spcPts val="2499"/>
-              </a:lnSpc>
-              <a:spcAft>
-                <a:spcPts val="700"/>
-              </a:spcAft>
-              <a:buSzPct val="63333"/>
-              <a:buFont typeface="Noto Sans CJK JP"/>
-              <a:buChar char="●"/>
-              <a:defRPr sz="2100" b="0">
-                <a:solidFill>
-                  <a:srgbClr val="303437"/>
-                </a:solidFill>
-                <a:latin typeface="Noto Sans"/>
-              </a:defRPr>
-            </a:pPr>
-            <a:r>
-              <a:rPr sz="2100" b="0" lang="ja-JP" altLang="en-US">
-                <a:solidFill>
-                  <a:srgbClr val="303437"/>
-                </a:solidFill>
-                <a:latin typeface="Noto Sans"/>
-                <a:ea typeface="Noto Sans CJK JP"/>
-                <a:cs typeface="Noto Sans"/>
-              </a:rPr>
-              <a:t>HELMは地域に加え、利用可能なメタデータに基づくmale／femaleの条件も用意した。</a:t>
-            </a:r>
-          </a:p>
-          <a:p>
-            <a:pPr marL="457200" indent="-355600">
-              <a:lnSpc>
-                <a:spcPts val="2499"/>
-              </a:lnSpc>
-              <a:spcAft>
-                <a:spcPts val="700"/>
-              </a:spcAft>
-              <a:buSzPct val="63333"/>
-              <a:buFont typeface="Noto Sans CJK JP"/>
-              <a:buChar char="●"/>
-              <a:defRPr sz="2100" b="0">
-                <a:solidFill>
-                  <a:srgbClr val="303437"/>
-                </a:solidFill>
-                <a:latin typeface="Noto Sans"/>
-              </a:defRPr>
-            </a:pPr>
-            <a:r>
-              <a:rPr sz="2100" b="0" lang="ja-JP" altLang="en-US">
-                <a:solidFill>
-                  <a:srgbClr val="303437"/>
-                </a:solidFill>
-                <a:latin typeface="Noto Sans"/>
-                <a:ea typeface="Noto Sans CJK JP"/>
-                <a:cs typeface="Noto Sans"/>
-              </a:rPr>
-              <a:t>収録ジャンル、話題、話者の属性、残った転記記号などが同時に変わるため、得点差だけで地域英語への偏りの原因を特定できない。</a:t>
-            </a:r>
-          </a:p>
-          <a:p>
-            <a:pPr marL="457200" indent="-355600">
-              <a:lnSpc>
-                <a:spcPts val="2499"/>
-              </a:lnSpc>
-              <a:spcAft>
-                <a:spcPts val="0"/>
-              </a:spcAft>
-              <a:buSzPct val="63333"/>
-              <a:buFont typeface="Noto Sans CJK JP"/>
-              <a:buChar char="●"/>
-              <a:defRPr sz="2100" b="0">
-                <a:solidFill>
-                  <a:srgbClr val="303437"/>
-                </a:solidFill>
-                <a:latin typeface="Noto Sans"/>
-              </a:defRPr>
-            </a:pPr>
-            <a:r>
-              <a:rPr sz="2100" b="0" lang="ja-JP" altLang="en-US">
-                <a:solidFill>
-                  <a:srgbClr val="303437"/>
-                </a:solidFill>
-                <a:latin typeface="Noto Sans"/>
-                <a:ea typeface="Noto Sans CJK JP"/>
-                <a:cs typeface="Noto Sans"/>
-              </a:rPr>
-              <a:t>目的は、英語を一つの均質な集合として扱わず、条件を分けて言語モデルの振る舞いを調べることにある。</a:t>
-            </a:r>
-          </a:p>
-        </p:txBody>
-      </p:sp>
-      <p:sp>
-        <p:nvSpPr>
-          <p:cNvPr id="4" name="Title 3"/>
-          <p:cNvSpPr>
-            <a:spLocks noGrp="1"/>
-          </p:cNvSpPr>
-          <p:nvPr>
-            <p:ph type="title" idx="2"/>
-          </p:nvPr>
-        </p:nvSpPr>
-        <p:spPr>
-          <a:xfrm>
-            <a:off x="75895" y="0"/>
-            <a:ext cx="8115300" cy="480060"/>
-          </a:xfrm>
-        </p:spPr>
-        <p:txBody>
-          <a:bodyPr wrap="square" lIns="0" rIns="0" tIns="0" bIns="0" anchor="ctr">
-            <a:noAutofit/>
-          </a:bodyPr>
-          <a:lstStyle/>
-          <a:p>
-            <a:pPr algn="l">
-              <a:lnSpc>
-                <a:spcPct val="110000"/>
-              </a:lnSpc>
-              <a:buNone/>
-              <a:defRPr sz="1400" b="0">
-                <a:solidFill>
-                  <a:srgbClr val="303437"/>
-                </a:solidFill>
-                <a:latin typeface="Noto Sans"/>
-              </a:defRPr>
-            </a:pPr>
-            <a:r>
-              <a:rPr sz="1400" b="1" lang="ja-JP" altLang="en-US">
-                <a:solidFill>
-                  <a:srgbClr val="FFFEF8"/>
-                </a:solidFill>
-                <a:latin typeface="Noto Sans"/>
-                <a:ea typeface="Noto Sans CJK JP"/>
-                <a:cs typeface="Noto Sans"/>
-              </a:rPr>
-              <a:t>3. HELMでの言語モデル評価</a:t>
-            </a:r>
-          </a:p>
-        </p:txBody>
-      </p:sp>
-      <p:sp>
-        <p:nvSpPr>
-          <p:cNvPr id="5" name="sources"/>
-          <p:cNvSpPr txBox="1"/>
-          <p:nvPr/>
-        </p:nvSpPr>
-        <p:spPr>
-          <a:xfrm>
-            <a:off x="502920" y="4508500"/>
-            <a:ext cx="8183879" cy="558800"/>
-          </a:xfrm>
-          <a:prstGeom prst="rect">
-            <a:avLst/>
-          </a:prstGeom>
-          <a:noFill/>
-        </p:spPr>
-        <p:txBody>
-          <a:bodyPr wrap="square" lIns="0" rIns="0" tIns="0" bIns="0">
-            <a:noAutofit/>
-          </a:bodyPr>
-          <a:lstStyle/>
-          <a:p>
-            <a:pPr algn="l">
-              <a:lnSpc>
-                <a:spcPts val="940"/>
-              </a:lnSpc>
-              <a:spcBef>
-                <a:spcPts val="0"/>
-              </a:spcBef>
-              <a:spcAft>
-                <a:spcPts val="0"/>
-              </a:spcAft>
-              <a:buNone/>
-              <a:defRPr sz="810" b="0">
-                <a:solidFill>
-                  <a:srgbClr val="303437"/>
-                </a:solidFill>
-                <a:latin typeface="Noto Sans"/>
-              </a:defRPr>
-            </a:pPr>
-            <a:r>
-              <a:rPr sz="830">
-                <a:latin typeface="Noto Sans CJK JP"/>
-              </a:rPr>
-              <a:t>[1] Liang et al. (2023), Holistic Evaluation of Language Models. TMLR.</a:t>
-            </a:r>
-          </a:p>
-          <a:p>
-            <a:pPr>
-              <a:spcBef>
-                <a:spcPts val="0"/>
-              </a:spcBef>
-              <a:spcAft>
-                <a:spcPts val="0"/>
-              </a:spcAft>
-            </a:pPr>
-            <a:r>
-              <a:rPr sz="830">
-                <a:latin typeface="Noto Sans CJK JP"/>
-                <a:hlinkClick r:id="rId2"/>
-              </a:rPr>
-              <a:t>https://arxiv.org/abs/2211.09110</a:t>
-            </a:r>
-          </a:p>
-          <a:p>
-            <a:pPr>
-              <a:spcBef>
-                <a:spcPts val="0"/>
-              </a:spcBef>
-              <a:spcAft>
-                <a:spcPts val="0"/>
-              </a:spcAft>
-            </a:pPr>
-            <a:r>
-              <a:rPr sz="830">
-                <a:latin typeface="Noto Sans CJK JP"/>
-              </a:rPr>
-              <a:t>[2] Stanford CRFM, HELM ICEScenario. v0.3.0.</a:t>
-            </a:r>
-          </a:p>
-          <a:p>
-            <a:pPr>
-              <a:spcBef>
-                <a:spcPts val="0"/>
-              </a:spcBef>
-              <a:spcAft>
-                <a:spcPts val="0"/>
-              </a:spcAft>
-            </a:pPr>
-            <a:r>
-              <a:rPr sz="830">
-                <a:latin typeface="Noto Sans CJK JP"/>
-                <a:hlinkClick r:id="rId3"/>
-              </a:rPr>
-              <a:t>https://github.com/stanford-crfm/helm/blob/v0.3.0/src/helm/benchmark/scenarios/ice_scenario.py</a:t>
-            </a:r>
-          </a:p>
-        </p:txBody>
-      </p:sp>
-    </p:spTree>
-  </p:cSld>
-  <p:clrMapOvr>
-    <a:masterClrMapping/>
-  </p:clrMapOvr>
-</p:sld>
-</file>
-
 <file path=ppt/slides/slide25.xml><?xml version="1.0" encoding="utf-8"?>
 <p:sld xmlns:a="http://schemas.openxmlformats.org/drawingml/2006/main" xmlns:p="http://schemas.openxmlformats.org/presentationml/2006/main" xmlns:r="http://schemas.openxmlformats.org/officeDocument/2006/relationships">
   <p:cSld>
@@ -13399,7 +11077,7 @@
                 <a:ea typeface="Noto Sans CJK JP"/>
                 <a:cs typeface="Noto Sans"/>
               </a:rPr>
-              <a:t>4. 入手方法と活用</a:t>
+              <a:t>3. 入手方法と活用</a:t>
             </a:r>
           </a:p>
         </p:txBody>
@@ -13465,7 +11143,7 @@
                 <a:ea typeface="Noto Sans CJK JP"/>
                 <a:cs typeface="Noto Sans"/>
               </a:rPr>
-              <a:t>比較言語学の資料から、モデル評価にも</a:t>
+              <a:t>地域ごとの編纂が、比較研究を支える</a:t>
             </a:r>
           </a:p>
         </p:txBody>
@@ -13518,7 +11196,7 @@
                 <a:ea typeface="Noto Sans CJK JP"/>
                 <a:cs typeface="Noto Sans"/>
               </a:rPr>
-              <a:t>1990年に、世界の英語を共通設計で比較する計画として始まった。品詞・構文や談話の分析が主要な用途だった。</a:t>
+              <a:t>1990年に、世界の英語を共通設計で比較する計画として始まった。各地域の研究チームが自分たちの英語を集め、語彙・文法・談話などの研究に使える資料を整える。</a:t>
             </a:r>
           </a:p>
           <a:p>
@@ -13548,7 +11226,7 @@
                 <a:ea typeface="Noto Sans CJK JP"/>
                 <a:cs typeface="Noto Sans"/>
               </a:rPr>
-              <a:t>HELMでは、複数地域の英語への言語モデルの適合度を測る資料として使う。</a:t>
+              <a:t>公式サイトは26の研究チームの参加を紹介し、ウガンダやトリニダード・トバゴの完成案内も掲載している。</a:t>
             </a:r>
           </a:p>
           <a:p>
@@ -13578,7 +11256,7 @@
                 <a:ea typeface="Noto Sans CJK JP"/>
                 <a:cs typeface="Noto Sans"/>
               </a:rPr>
-              <a:t>2026年の公式サイトにはUgandaやTrinidad and Tobagoの完成案内もあり、HELMの対象地域より活動範囲が広い。</a:t>
+              <a:t>共通設計を保ちながら地域別の資料を増やすことで、英語の共通点と地域ごとの特徴を調べられる。</a:t>
             </a:r>
           </a:p>
         </p:txBody>
@@ -13626,7 +11304,7 @@
                 <a:ea typeface="Noto Sans CJK JP"/>
                 <a:cs typeface="Noto Sans"/>
               </a:rPr>
-              <a:t>4. 入手方法と活用</a:t>
+              <a:t>3. 入手方法と活用</a:t>
             </a:r>
           </a:p>
         </p:txBody>
@@ -13871,7 +11549,7 @@
                 <a:ea typeface="Noto Sans CJK JP"/>
                 <a:cs typeface="Noto Sans"/>
               </a:rPr>
-              <a:t>HELMで利用する場合は、取得済みの地域別ファイルをrestricted/ice以下へ配置する。</a:t>
+              <a:t>ICE-onlineは現在、コーパス編纂者向けの検索環境と案内されている。</a:t>
             </a:r>
           </a:p>
         </p:txBody>
@@ -13919,7 +11597,7 @@
                 <a:ea typeface="Noto Sans CJK JP"/>
                 <a:cs typeface="Noto Sans"/>
               </a:rPr>
-              <a:t>4. 入手方法と活用</a:t>
+              <a:t>3. 入手方法と活用</a:t>
             </a:r>
           </a:p>
         </p:txBody>
@@ -14134,7 +11812,7 @@
                 <a:ea typeface="Noto Sans CJK JP"/>
                 <a:cs typeface="Noto Sans"/>
               </a:rPr>
-              <a:t>HELMは本文への確率を採点し、地域やメタデータの条件ごとに言語モデルを比較する。</a:t>
+              <a:t>実際の会話や文章を読み、語彙・文法・談話の特徴を、地域やジャンルごとに調べられる。</a:t>
             </a:r>
           </a:p>
           <a:p>
@@ -14164,7 +11842,7 @@
                 <a:ea typeface="Noto Sans CJK JP"/>
                 <a:cs typeface="Noto Sans"/>
               </a:rPr>
-              <a:t>利用する地域や、話し言葉・書き言葉の構成、前処理を踏まえて比較し、各地域の利用条件に従う。</a:t>
+              <a:t>利用する地域、話し言葉・書き言葉の構成、注釈の種類を確かめ、各地域の利用条件に従って分析する。</a:t>
             </a:r>
           </a:p>
         </p:txBody>
@@ -14212,7 +11890,7 @@
                 <a:ea typeface="Noto Sans CJK JP"/>
                 <a:cs typeface="Noto Sans"/>
               </a:rPr>
-              <a:t>4. 入手方法と活用</a:t>
+              <a:t>3. 入手方法と活用</a:t>
             </a:r>
           </a:p>
         </p:txBody>
@@ -14294,7 +11972,7 @@
               <a:rPr sz="830">
                 <a:latin typeface="Noto Sans CJK JP"/>
               </a:rPr>
-              <a:t>[2] Liang et al. (2023), Holistic Evaluation of Language Models. TMLR.</a:t>
+              <a:t>[2] International Corpus of English. Getting Access.</a:t>
             </a:r>
           </a:p>
           <a:p>
@@ -14311,7 +11989,7 @@
                 <a:latin typeface="Noto Sans CJK JP"/>
                 <a:hlinkClick r:id="rId3"/>
               </a:rPr>
-              <a:t>https://arxiv.org/abs/2211.09110</a:t>
+              <a:t>https://www.ice-corpora.uzh.ch/en/access.html</a:t>
             </a:r>
           </a:p>
         </p:txBody>
@@ -14604,36 +12282,6 @@
                 <a:ea typeface="Noto Sans CJK JP"/>
                 <a:cs typeface="Noto Sans"/>
               </a:rPr>
-              <a:t>HELMでの言語モデル評価</a:t>
-            </a:r>
-          </a:p>
-          <a:p>
-            <a:pPr marL="457200" indent="-457200">
-              <a:lnSpc>
-                <a:spcPts val="3660"/>
-              </a:lnSpc>
-              <a:spcAft>
-                <a:spcPts val="0"/>
-              </a:spcAft>
-              <a:buSzPct val="100000"/>
-              <a:buFont typeface="Noto Sans CJK JP"/>
-              <a:buAutoNum type="arabicPeriod" startAt="4"/>
-              <a:defRPr sz="3000" b="1">
-                <a:solidFill>
-                  <a:srgbClr val="303437"/>
-                </a:solidFill>
-                <a:latin typeface="Noto Sans"/>
-              </a:defRPr>
-            </a:pPr>
-            <a:r>
-              <a:rPr sz="3000" b="1" lang="ja-JP" altLang="en-US">
-                <a:solidFill>
-                  <a:srgbClr val="303437"/>
-                </a:solidFill>
-                <a:latin typeface="Noto Sans"/>
-                <a:ea typeface="Noto Sans CJK JP"/>
-                <a:cs typeface="Noto Sans"/>
-              </a:rPr>
               <a:t>入手方法と活用</a:t>
             </a:r>
           </a:p>
@@ -14831,7 +12479,7 @@
                 <a:ea typeface="Noto Sans CJK JP"/>
                 <a:cs typeface="Noto Sans"/>
               </a:rPr>
-              <a:t>収録ジャンルと評価対象</a:t>
+              <a:t>収録ジャンルの内訳</a:t>
             </a:r>
           </a:p>
           <a:p>
@@ -19985,7 +17633,7 @@
                 <a:ea typeface="Noto Sans CJK JP"/>
                 <a:cs typeface="Noto Sans"/>
               </a:rPr>
-              <a:t>Appendix: 2. 収録ジャンルと評価対象</a:t>
+              <a:t>Appendix: 2. 収録ジャンルの内訳</a:t>
             </a:r>
           </a:p>
         </p:txBody>
@@ -20986,7 +18634,7 @@
                 <a:ea typeface="Noto Sans CJK JP"/>
                 <a:cs typeface="Noto Sans"/>
               </a:rPr>
-              <a:t>Appendix: 2. 収録ジャンルと評価対象</a:t>
+              <a:t>Appendix: 2. 収録ジャンルの内訳</a:t>
             </a:r>
           </a:p>
         </p:txBody>
@@ -21987,7 +19635,7 @@
                 <a:ea typeface="Noto Sans CJK JP"/>
                 <a:cs typeface="Noto Sans"/>
               </a:rPr>
-              <a:t>Appendix: 2. 収録ジャンルと評価対象</a:t>
+              <a:t>Appendix: 2. 収録ジャンルの内訳</a:t>
             </a:r>
           </a:p>
         </p:txBody>
@@ -22624,7 +20272,7 @@
 </p:sld>
 </file>
 
-<file path=ppt/slides/slide44.xml><?xml version="1.0" encoding="utf-8"?>
+<file path=ppt/slides/slide46.xml><?xml version="1.0" encoding="utf-8"?>
 <p:sld xmlns:a="http://schemas.openxmlformats.org/drawingml/2006/main" xmlns:p="http://schemas.openxmlformats.org/presentationml/2006/main" xmlns:r="http://schemas.openxmlformats.org/officeDocument/2006/relationships">
   <p:cSld>
     <p:spTree>
@@ -22677,97 +20325,14 @@
                 <a:ea typeface="Noto Sans CJK JP"/>
                 <a:cs typeface="Noto Sans"/>
               </a:rPr>
-              <a:t>地域とジャンルを選んで、HELMへ読み込む</a:t>
+              <a:t>参考文献</a:t>
             </a:r>
           </a:p>
         </p:txBody>
       </p:sp>
       <p:sp>
         <p:nvSpPr>
-          <p:cNvPr id="3" name="Text Placeholder 2"/>
-          <p:cNvSpPr>
-            <a:spLocks noGrp="1"/>
-          </p:cNvSpPr>
-          <p:nvPr>
-            <p:ph type="body" idx="1"/>
-          </p:nvPr>
-        </p:nvSpPr>
-        <p:spPr>
-          <a:xfrm>
-            <a:off x="594360" y="1463040"/>
-            <a:ext cx="7955279" cy="3044952"/>
-          </a:xfrm>
-        </p:spPr>
-        <p:txBody>
-          <a:bodyPr wrap="square" tIns="91440" bIns="91440">
-            <a:noAutofit/>
-          </a:bodyPr>
-          <a:lstStyle/>
-          <a:p>
-            <a:pPr marL="457200" indent="-355600">
-              <a:lnSpc>
-                <a:spcPts val="2379"/>
-              </a:lnSpc>
-              <a:spcAft>
-                <a:spcPts val="700"/>
-              </a:spcAft>
-              <a:buSzPct val="66500"/>
-              <a:buFont typeface="Noto Sans CJK JP"/>
-              <a:buChar char="●"/>
-              <a:defRPr sz="2000" b="0">
-                <a:solidFill>
-                  <a:srgbClr val="303437"/>
-                </a:solidFill>
-                <a:latin typeface="Noto Sans"/>
-              </a:defRPr>
-            </a:pPr>
-            <a:r>
-              <a:rPr sz="2000" b="0" lang="ja-JP" altLang="en-US">
-                <a:solidFill>
-                  <a:srgbClr val="303437"/>
-                </a:solidFill>
-                <a:latin typeface="Noto Sans"/>
-                <a:ea typeface="Noto Sans CJK JP"/>
-                <a:cs typeface="Noto Sans"/>
-              </a:rPr>
-              <a:t>HELMの実装は、Canada、Jamaica、Hong Kong、India、Singapore、Philippines、USA、East Africa、Irelandの9地域に対応する。コーパス本体は、各配布元で取得する。</a:t>
-            </a:r>
-          </a:p>
-          <a:p>
-            <a:pPr marL="457200" indent="-355600">
-              <a:lnSpc>
-                <a:spcPts val="2379"/>
-              </a:lnSpc>
-              <a:spcAft>
-                <a:spcPts val="700"/>
-              </a:spcAft>
-              <a:buSzPct val="66500"/>
-              <a:buFont typeface="Noto Sans CJK JP"/>
-              <a:buChar char="●"/>
-              <a:defRPr sz="2000" b="0">
-                <a:solidFill>
-                  <a:srgbClr val="303437"/>
-                </a:solidFill>
-                <a:latin typeface="Noto Sans"/>
-              </a:defRPr>
-            </a:pPr>
-            <a:r>
-              <a:rPr sz="2000" b="0" lang="ja-JP" altLang="en-US">
-                <a:solidFill>
-                  <a:srgbClr val="303437"/>
-                </a:solidFill>
-                <a:latin typeface="Noto Sans"/>
-                <a:ea typeface="Noto Sans CJK JP"/>
-                <a:cs typeface="Noto Sans"/>
-              </a:rPr>
-              <a:t>categoryで話し言葉（S）と書き言葉（W）を選べる。さらに対話（S1）・独話（S2）、非刊行（W1）・刊行（W2）の文章に絞ることもできる。</a:t>
-            </a:r>
-          </a:p>
-        </p:txBody>
-      </p:sp>
-      <p:sp>
-        <p:nvSpPr>
-          <p:cNvPr id="4" name="Title 3"/>
+          <p:cNvPr id="3" name="Title 2"/>
           <p:cNvSpPr>
             <a:spLocks noGrp="1"/>
           </p:cNvSpPr>
@@ -22808,21 +20373,21 @@
                 <a:ea typeface="Noto Sans CJK JP"/>
                 <a:cs typeface="Noto Sans"/>
               </a:rPr>
-              <a:t>Appendix: 2. 収録ジャンルと評価対象</a:t>
+              <a:t>Appendix: 3. 研究と参考文献</a:t>
             </a:r>
           </a:p>
         </p:txBody>
       </p:sp>
       <p:sp>
         <p:nvSpPr>
-          <p:cNvPr id="5" name="sources"/>
+          <p:cNvPr id="4" name="文献 1: International Corpus of English"/>
           <p:cNvSpPr txBox="1"/>
           <p:nvPr/>
         </p:nvSpPr>
         <p:spPr>
           <a:xfrm>
-            <a:off x="502920" y="4699000"/>
-            <a:ext cx="8183879" cy="431800"/>
+            <a:off x="548640" y="1463040"/>
+            <a:ext cx="8046720" cy="1576213"/>
           </a:xfrm>
           <a:prstGeom prst="rect">
             <a:avLst/>
@@ -22837,285 +20402,140 @@
           <a:p>
             <a:pPr algn="l">
               <a:lnSpc>
-                <a:spcPts val="940"/>
-              </a:lnSpc>
-              <a:spcBef>
-                <a:spcPts val="0"/>
-              </a:spcBef>
-              <a:spcAft>
-                <a:spcPts val="0"/>
-              </a:spcAft>
-              <a:buNone/>
-              <a:defRPr sz="810" b="0">
-                <a:solidFill>
-                  <a:srgbClr val="303437"/>
-                </a:solidFill>
-                <a:latin typeface="Noto Sans"/>
-              </a:defRPr>
-            </a:pPr>
-            <a:r>
-              <a:rPr sz="830">
-                <a:latin typeface="Noto Sans CJK JP"/>
-              </a:rPr>
-              <a:t>[1] Stanford CRFM, HELM ICEScenario.</a:t>
-            </a:r>
-          </a:p>
-          <a:p>
-            <a:pPr>
-              <a:spcBef>
-                <a:spcPts val="0"/>
-              </a:spcBef>
-              <a:spcAft>
-                <a:spcPts val="0"/>
-              </a:spcAft>
-            </a:pPr>
-            <a:r>
-              <a:rPr sz="830">
-                <a:latin typeface="Noto Sans CJK JP"/>
+                <a:spcPct val="114000"/>
+              </a:lnSpc>
+              <a:spcBef>
+                <a:spcPts val="0"/>
+              </a:spcBef>
+              <a:spcAft>
+                <a:spcPts val="400"/>
+              </a:spcAft>
+              <a:buNone/>
+              <a:defRPr sz="2000" b="0">
+                <a:solidFill>
+                  <a:srgbClr val="303437"/>
+                </a:solidFill>
+                <a:latin typeface="Noto Sans"/>
+              </a:defRPr>
+            </a:pPr>
+            <a:r>
+              <a:rPr sz="2000" b="1" lang="ja-JP" altLang="en-US">
+                <a:solidFill>
+                  <a:srgbClr val="303437"/>
+                </a:solidFill>
+                <a:latin typeface="Noto Sans"/>
+                <a:ea typeface="Noto Sans CJK JP"/>
+                <a:cs typeface="Noto Sans"/>
+              </a:rPr>
+              <a:t>International Corpus of English</a:t>
+            </a:r>
+          </a:p>
+          <a:p>
+            <a:pPr algn="l">
+              <a:lnSpc>
+                <a:spcPct val="114000"/>
+              </a:lnSpc>
+              <a:spcBef>
+                <a:spcPts val="0"/>
+              </a:spcBef>
+              <a:spcAft>
+                <a:spcPts val="500"/>
+              </a:spcAft>
+              <a:buNone/>
+              <a:defRPr sz="1350" b="0">
+                <a:solidFill>
+                  <a:srgbClr val="303437"/>
+                </a:solidFill>
+                <a:latin typeface="Noto Sans"/>
+              </a:defRPr>
+            </a:pPr>
+            <a:r>
+              <a:rPr sz="1350" b="0" lang="ja-JP" altLang="en-US">
+                <a:solidFill>
+                  <a:srgbClr val="626669"/>
+                </a:solidFill>
+                <a:latin typeface="Noto Sans"/>
+                <a:ea typeface="Noto Sans CJK JP"/>
+                <a:cs typeface="Noto Sans"/>
+              </a:rPr>
+              <a:t>University of Zurich／ICE teams. (n.d.). 1990年開始。2026-10-18参照。</a:t>
+            </a:r>
+          </a:p>
+          <a:p>
+            <a:pPr algn="l">
+              <a:lnSpc>
+                <a:spcPct val="114000"/>
+              </a:lnSpc>
+              <a:spcBef>
+                <a:spcPts val="0"/>
+              </a:spcBef>
+              <a:spcAft>
+                <a:spcPts val="400"/>
+              </a:spcAft>
+              <a:buNone/>
+              <a:defRPr sz="1850" b="0">
+                <a:solidFill>
+                  <a:srgbClr val="303437"/>
+                </a:solidFill>
+                <a:latin typeface="Noto Sans"/>
+              </a:defRPr>
+            </a:pPr>
+            <a:r>
+              <a:rPr sz="1850" b="0" lang="ja-JP" altLang="en-US">
+                <a:solidFill>
+                  <a:srgbClr val="303437"/>
+                </a:solidFill>
+                <a:latin typeface="Noto Sans"/>
+                <a:ea typeface="Noto Sans CJK JP"/>
+                <a:cs typeface="Noto Sans"/>
+              </a:rPr>
+              <a:t>地域別コーパスの目的、共通設計、参加チームと配布窓口をまとめる。</a:t>
+            </a:r>
+          </a:p>
+          <a:p>
+            <a:pPr algn="l">
+              <a:lnSpc>
+                <a:spcPct val="114000"/>
+              </a:lnSpc>
+              <a:spcBef>
+                <a:spcPts val="0"/>
+              </a:spcBef>
+              <a:spcAft>
+                <a:spcPts val="0"/>
+              </a:spcAft>
+              <a:buNone/>
+              <a:defRPr sz="1150" b="0">
+                <a:solidFill>
+                  <a:srgbClr val="303437"/>
+                </a:solidFill>
+                <a:latin typeface="Noto Sans"/>
+              </a:defRPr>
+            </a:pPr>
+            <a:r>
+              <a:rPr sz="1150" b="0" lang="ja-JP" altLang="en-US">
+                <a:solidFill>
+                  <a:srgbClr val="626669"/>
+                </a:solidFill>
+                <a:latin typeface="Noto Sans"/>
+                <a:ea typeface="Noto Sans CJK JP"/>
+                <a:cs typeface="Noto Sans"/>
                 <a:hlinkClick r:id="rId2"/>
               </a:rPr>
-              <a:t>https://github.com/stanford-crfm/helm/blob/v0.3.0/src/helm/benchmark/scenarios/ice_scenario.py</a:t>
-            </a:r>
-          </a:p>
-        </p:txBody>
-      </p:sp>
-    </p:spTree>
-  </p:cSld>
-  <p:clrMapOvr>
-    <a:masterClrMapping/>
-  </p:clrMapOvr>
-</p:sld>
-</file>
-
-<file path=ppt/slides/slide45.xml><?xml version="1.0" encoding="utf-8"?>
-<p:sld xmlns:a="http://schemas.openxmlformats.org/drawingml/2006/main" xmlns:p="http://schemas.openxmlformats.org/presentationml/2006/main" xmlns:r="http://schemas.openxmlformats.org/officeDocument/2006/relationships">
-  <p:cSld>
-    <p:spTree>
-      <p:nvGrpSpPr>
-        <p:cNvPr id="1" name=""/>
-        <p:cNvGrpSpPr/>
-        <p:nvPr/>
-      </p:nvGrpSpPr>
-      <p:grpSpPr/>
-      <p:sp>
-        <p:nvSpPr>
-          <p:cNvPr id="2" name="Title 1"/>
-          <p:cNvSpPr>
-            <a:spLocks noGrp="1"/>
-          </p:cNvSpPr>
-          <p:nvPr>
-            <p:ph type="title"/>
-          </p:nvPr>
-        </p:nvSpPr>
-        <p:spPr>
-          <a:xfrm>
-            <a:off x="468172" y="650138"/>
-            <a:ext cx="8206740" cy="616305"/>
-          </a:xfrm>
-        </p:spPr>
-        <p:txBody>
-          <a:bodyPr wrap="square" lIns="0" rIns="0" tIns="0" bIns="0">
-            <a:noAutofit/>
-          </a:bodyPr>
-          <a:lstStyle/>
-          <a:p>
-            <a:pPr algn="l">
-              <a:lnSpc>
-                <a:spcPct val="110000"/>
-              </a:lnSpc>
-              <a:buNone/>
-              <a:defRPr sz="2800" b="0">
-                <a:solidFill>
-                  <a:srgbClr val="303437"/>
-                </a:solidFill>
-                <a:latin typeface="Noto Sans"/>
-              </a:defRPr>
-            </a:pPr>
-            <a:r>
-              <a:rPr sz="2800" b="1" lang="ja-JP" altLang="en-US">
-                <a:solidFill>
-                  <a:srgbClr val="303437"/>
-                </a:solidFill>
-                <a:latin typeface="Noto Sans"/>
-                <a:ea typeface="Noto Sans CJK JP"/>
-                <a:cs typeface="Noto Sans"/>
-              </a:rPr>
-              <a:t>性別で文書を選ぶ方法は、地域ごとに異なる</a:t>
+              <a:t>https://www.ice-corpora.uzh.ch/en.html</a:t>
             </a:r>
           </a:p>
         </p:txBody>
       </p:sp>
       <p:sp>
         <p:nvSpPr>
-          <p:cNvPr id="3" name="Text Placeholder 2"/>
-          <p:cNvSpPr>
-            <a:spLocks noGrp="1"/>
-          </p:cNvSpPr>
-          <p:nvPr>
-            <p:ph type="body" idx="1"/>
-          </p:nvPr>
-        </p:nvSpPr>
-        <p:spPr>
-          <a:xfrm>
-            <a:off x="594360" y="1463040"/>
-            <a:ext cx="7955279" cy="3044952"/>
-          </a:xfrm>
-        </p:spPr>
-        <p:txBody>
-          <a:bodyPr wrap="square" tIns="91440" bIns="91440">
-            <a:noAutofit/>
-          </a:bodyPr>
-          <a:lstStyle/>
-          <a:p>
-            <a:pPr marL="457200" indent="-355600">
-              <a:lnSpc>
-                <a:spcPts val="2379"/>
-              </a:lnSpc>
-              <a:spcAft>
-                <a:spcPts val="700"/>
-              </a:spcAft>
-              <a:buSzPct val="66500"/>
-              <a:buFont typeface="Noto Sans CJK JP"/>
-              <a:buChar char="●"/>
-              <a:defRPr sz="2000" b="0">
-                <a:solidFill>
-                  <a:srgbClr val="303437"/>
-                </a:solidFill>
-                <a:latin typeface="Noto Sans"/>
-              </a:defRPr>
-            </a:pPr>
-            <a:r>
-              <a:rPr sz="2000" b="0" lang="ja-JP" altLang="en-US">
-                <a:solidFill>
-                  <a:srgbClr val="303437"/>
-                </a:solidFill>
-                <a:latin typeface="Noto Sans"/>
-                <a:ea typeface="Noto Sans CJK JP"/>
-                <a:cs typeface="Noto Sans"/>
-              </a:rPr>
-              <a:t>Canada、Hong Kong、India、USAでは、付属のメタデータからmale／femaleの文書を選べる。</a:t>
-            </a:r>
-          </a:p>
-          <a:p>
-            <a:pPr marL="457200" indent="-355600">
-              <a:lnSpc>
-                <a:spcPts val="2379"/>
-              </a:lnSpc>
-              <a:spcAft>
-                <a:spcPts val="700"/>
-              </a:spcAft>
-              <a:buSzPct val="66500"/>
-              <a:buFont typeface="Noto Sans CJK JP"/>
-              <a:buChar char="●"/>
-              <a:defRPr sz="2000" b="0">
-                <a:solidFill>
-                  <a:srgbClr val="303437"/>
-                </a:solidFill>
-                <a:latin typeface="Noto Sans"/>
-              </a:defRPr>
-            </a:pPr>
-            <a:r>
-              <a:rPr sz="2000" b="0" lang="ja-JP" altLang="en-US">
-                <a:solidFill>
-                  <a:srgbClr val="303437"/>
-                </a:solidFill>
-                <a:latin typeface="Noto Sans"/>
-                <a:ea typeface="Noto Sans CJK JP"/>
-                <a:cs typeface="Noto Sans"/>
-              </a:rPr>
-              <a:t>IndiaとUSAでは、読み取った性別情報がすべて指定条件に合う文書を選ぶ。CanadaとHong Kongでは、所定の列のいずれかが一致すれば選ぶ。</a:t>
-            </a:r>
-          </a:p>
-          <a:p>
-            <a:pPr marL="457200" indent="-355600">
-              <a:lnSpc>
-                <a:spcPts val="2379"/>
-              </a:lnSpc>
-              <a:spcAft>
-                <a:spcPts val="0"/>
-              </a:spcAft>
-              <a:buSzPct val="66500"/>
-              <a:buFont typeface="Noto Sans CJK JP"/>
-              <a:buChar char="●"/>
-              <a:defRPr sz="2000" b="0">
-                <a:solidFill>
-                  <a:srgbClr val="303437"/>
-                </a:solidFill>
-                <a:latin typeface="Noto Sans"/>
-              </a:defRPr>
-            </a:pPr>
-            <a:r>
-              <a:rPr sz="2000" b="0" lang="ja-JP" altLang="en-US">
-                <a:solidFill>
-                  <a:srgbClr val="303437"/>
-                </a:solidFill>
-                <a:latin typeface="Noto Sans"/>
-                <a:ea typeface="Noto Sans CJK JP"/>
-                <a:cs typeface="Noto Sans"/>
-              </a:rPr>
-              <a:t>地域ごとに選び方が異なるため、性別別の結果を比べる際には、どの話者を含む文書なのかを確認する。</a:t>
-            </a:r>
-          </a:p>
-        </p:txBody>
-      </p:sp>
-      <p:sp>
-        <p:nvSpPr>
-          <p:cNvPr id="4" name="Title 3"/>
-          <p:cNvSpPr>
-            <a:spLocks noGrp="1"/>
-          </p:cNvSpPr>
-          <p:nvPr>
-            <p:ph type="title" idx="2"/>
-          </p:nvPr>
-        </p:nvSpPr>
-        <p:spPr>
-          <a:xfrm>
-            <a:off x="75895" y="0"/>
-            <a:ext cx="8115300" cy="480060"/>
-          </a:xfrm>
-        </p:spPr>
-        <p:txBody>
-          <a:bodyPr wrap="square" lIns="0" rIns="0" tIns="0" bIns="0" anchor="ctr">
-            <a:noAutofit/>
-          </a:bodyPr>
-          <a:lstStyle/>
-          <a:p>
-            <a:pPr algn="l">
-              <a:lnSpc>
-                <a:spcPct val="110000"/>
-              </a:lnSpc>
-              <a:buNone/>
-              <a:defRPr sz="1400" b="0">
-                <a:solidFill>
-                  <a:srgbClr val="303437"/>
-                </a:solidFill>
-                <a:latin typeface="Noto Sans"/>
-              </a:defRPr>
-            </a:pPr>
-            <a:r>
-              <a:rPr sz="1400" b="1" lang="ja-JP" altLang="en-US">
-                <a:solidFill>
-                  <a:srgbClr val="FFFEF8"/>
-                </a:solidFill>
-                <a:latin typeface="Noto Sans"/>
-                <a:ea typeface="Noto Sans CJK JP"/>
-                <a:cs typeface="Noto Sans"/>
-              </a:rPr>
-              <a:t>Appendix: 2. 収録ジャンルと評価対象</a:t>
-            </a:r>
-          </a:p>
-        </p:txBody>
-      </p:sp>
-      <p:sp>
-        <p:nvSpPr>
-          <p:cNvPr id="5" name="sources"/>
+          <p:cNvPr id="5" name="文献 2: Markup Manual for Spoken Texts"/>
           <p:cNvSpPr txBox="1"/>
           <p:nvPr/>
         </p:nvSpPr>
         <p:spPr>
           <a:xfrm>
-            <a:off x="502920" y="4699000"/>
-            <a:ext cx="8183879" cy="431800"/>
+            <a:off x="548640" y="3131693"/>
+            <a:ext cx="8046720" cy="1643637"/>
           </a:xfrm>
           <a:prstGeom prst="rect">
             <a:avLst/>
@@ -23130,44 +20550,126 @@
           <a:p>
             <a:pPr algn="l">
               <a:lnSpc>
-                <a:spcPts val="940"/>
-              </a:lnSpc>
-              <a:spcBef>
-                <a:spcPts val="0"/>
-              </a:spcBef>
-              <a:spcAft>
-                <a:spcPts val="0"/>
-              </a:spcAft>
-              <a:buNone/>
-              <a:defRPr sz="810" b="0">
-                <a:solidFill>
-                  <a:srgbClr val="303437"/>
-                </a:solidFill>
-                <a:latin typeface="Noto Sans"/>
-              </a:defRPr>
-            </a:pPr>
-            <a:r>
-              <a:rPr sz="830">
-                <a:latin typeface="Noto Sans CJK JP"/>
-              </a:rPr>
-              <a:t>[1] Stanford CRFM, HELM ICEScenario.</a:t>
-            </a:r>
-          </a:p>
-          <a:p>
-            <a:pPr>
-              <a:spcBef>
-                <a:spcPts val="0"/>
-              </a:spcBef>
-              <a:spcAft>
-                <a:spcPts val="0"/>
-              </a:spcAft>
-            </a:pPr>
-            <a:r>
-              <a:rPr sz="830">
-                <a:latin typeface="Noto Sans CJK JP"/>
-                <a:hlinkClick r:id="rId2"/>
-              </a:rPr>
-              <a:t>https://github.com/stanford-crfm/helm/blob/v0.3.0/src/helm/benchmark/scenarios/ice_scenario.py</a:t>
+                <a:spcPct val="114000"/>
+              </a:lnSpc>
+              <a:spcBef>
+                <a:spcPts val="0"/>
+              </a:spcBef>
+              <a:spcAft>
+                <a:spcPts val="400"/>
+              </a:spcAft>
+              <a:buNone/>
+              <a:defRPr sz="2000" b="0">
+                <a:solidFill>
+                  <a:srgbClr val="303437"/>
+                </a:solidFill>
+                <a:latin typeface="Noto Sans"/>
+              </a:defRPr>
+            </a:pPr>
+            <a:r>
+              <a:rPr sz="2000" b="1" lang="ja-JP" altLang="en-US">
+                <a:solidFill>
+                  <a:srgbClr val="303437"/>
+                </a:solidFill>
+                <a:latin typeface="Noto Sans"/>
+                <a:ea typeface="Noto Sans CJK JP"/>
+                <a:cs typeface="Noto Sans"/>
+              </a:rPr>
+              <a:t>Markup Manual for Spoken Texts</a:t>
+            </a:r>
+          </a:p>
+          <a:p>
+            <a:pPr algn="l">
+              <a:lnSpc>
+                <a:spcPct val="114000"/>
+              </a:lnSpc>
+              <a:spcBef>
+                <a:spcPts val="0"/>
+              </a:spcBef>
+              <a:spcAft>
+                <a:spcPts val="500"/>
+              </a:spcAft>
+              <a:buNone/>
+              <a:defRPr sz="1350" b="0">
+                <a:solidFill>
+                  <a:srgbClr val="303437"/>
+                </a:solidFill>
+                <a:latin typeface="Noto Sans"/>
+              </a:defRPr>
+            </a:pPr>
+            <a:r>
+              <a:rPr sz="1350" b="0" lang="ja-JP" altLang="en-US">
+                <a:solidFill>
+                  <a:srgbClr val="626669"/>
+                </a:solidFill>
+                <a:latin typeface="Noto Sans"/>
+                <a:ea typeface="Noto Sans CJK JP"/>
+                <a:cs typeface="Noto Sans"/>
+              </a:rPr>
+              <a:t>Gerald Nelson (2002). International Corpus of English.</a:t>
+            </a:r>
+          </a:p>
+          <a:p>
+            <a:pPr algn="l">
+              <a:lnSpc>
+                <a:spcPct val="114000"/>
+              </a:lnSpc>
+              <a:spcBef>
+                <a:spcPts val="0"/>
+              </a:spcBef>
+              <a:spcAft>
+                <a:spcPts val="400"/>
+              </a:spcAft>
+              <a:buNone/>
+              <a:defRPr sz="1850" b="0">
+                <a:solidFill>
+                  <a:srgbClr val="303437"/>
+                </a:solidFill>
+                <a:latin typeface="Noto Sans"/>
+              </a:defRPr>
+            </a:pPr>
+            <a:r>
+              <a:rPr sz="1850" b="0" lang="ja-JP" altLang="en-US">
+                <a:solidFill>
+                  <a:srgbClr val="303437"/>
+                </a:solidFill>
+                <a:latin typeface="Noto Sans"/>
+                <a:ea typeface="Noto Sans CJK JP"/>
+                <a:cs typeface="Noto Sans"/>
+              </a:rPr>
+              <a:t>休止、話者交替、重なり、言い直しなどの転記規則と、必須・推奨・任意の注釈を定める。</a:t>
+            </a:r>
+          </a:p>
+          <a:p>
+            <a:pPr algn="l">
+              <a:lnSpc>
+                <a:spcPct val="114000"/>
+              </a:lnSpc>
+              <a:spcBef>
+                <a:spcPts val="0"/>
+              </a:spcBef>
+              <a:spcAft>
+                <a:spcPts val="0"/>
+              </a:spcAft>
+              <a:buNone/>
+              <a:defRPr sz="1150" b="0">
+                <a:solidFill>
+                  <a:srgbClr val="303437"/>
+                </a:solidFill>
+                <a:latin typeface="Noto Sans"/>
+              </a:defRPr>
+            </a:pPr>
+            <a:r>
+              <a:rPr sz="1150" b="0" lang="ja-JP" altLang="en-US">
+                <a:solidFill>
+                  <a:srgbClr val="626669"/>
+                </a:solidFill>
+                <a:latin typeface="Noto Sans"/>
+                <a:ea typeface="Noto Sans CJK JP"/>
+                <a:cs typeface="Noto Sans"/>
+                <a:hlinkClick r:id="rId3"/>
+              </a:rPr>
+              <a:t>https://www.ice-corpora.uzh.ch/en/manuals.html</a:t>
             </a:r>
           </a:p>
         </p:txBody>
@@ -23288,14 +20790,14 @@
       </p:sp>
       <p:sp>
         <p:nvSpPr>
-          <p:cNvPr id="4" name="文献 1: International Corpus of English"/>
+          <p:cNvPr id="4" name="文献 1: Markup Manual for Written Texts"/>
           <p:cNvSpPr txBox="1"/>
           <p:nvPr/>
         </p:nvSpPr>
         <p:spPr>
           <a:xfrm>
             <a:off x="548640" y="1463040"/>
-            <a:ext cx="8046720" cy="1576213"/>
+            <a:ext cx="8046720" cy="1322213"/>
           </a:xfrm>
           <a:prstGeom prst="rect">
             <a:avLst/>
@@ -23335,7 +20837,7 @@
                 <a:ea typeface="Noto Sans CJK JP"/>
                 <a:cs typeface="Noto Sans"/>
               </a:rPr>
-              <a:t>International Corpus of English</a:t>
+              <a:t>Markup Manual for Written Texts</a:t>
             </a:r>
           </a:p>
           <a:p>
@@ -23366,7 +20868,7 @@
                 <a:ea typeface="Noto Sans CJK JP"/>
                 <a:cs typeface="Noto Sans"/>
               </a:rPr>
-              <a:t>University of Zurich／ICE teams. (n.d.). 1990年開始。2026-10-18参照。</a:t>
+              <a:t>Gerald Nelson (2002). International Corpus of English.</a:t>
             </a:r>
           </a:p>
           <a:p>
@@ -23397,7 +20899,7 @@
                 <a:ea typeface="Noto Sans CJK JP"/>
                 <a:cs typeface="Noto Sans"/>
               </a:rPr>
-              <a:t>地域別コーパスの目的、共通設計、参加チームと配布窓口をまとめる。</a:t>
+              <a:t>見出し、段落、組版、引用、非コーパス部分などの記号化を規定する。</a:t>
             </a:r>
           </a:p>
           <a:p>
@@ -23429,14 +20931,14 @@
                 <a:cs typeface="Noto Sans"/>
                 <a:hlinkClick r:id="rId2"/>
               </a:rPr>
-              <a:t>https://www.ice-corpora.uzh.ch/en.html</a:t>
+              <a:t>https://www.ice-corpora.uzh.ch/en/manuals.html</a:t>
             </a:r>
           </a:p>
         </p:txBody>
       </p:sp>
       <p:sp>
         <p:nvSpPr>
-          <p:cNvPr id="5" name="文献 2: Markup Manual for Spoken Texts"/>
+          <p:cNvPr id="5" name="文献 2: Holistic Evaluation of Language Models"/>
           <p:cNvSpPr txBox="1"/>
           <p:nvPr/>
         </p:nvSpPr>
@@ -23483,7 +20985,7 @@
                 <a:ea typeface="Noto Sans CJK JP"/>
                 <a:cs typeface="Noto Sans"/>
               </a:rPr>
-              <a:t>Markup Manual for Spoken Texts</a:t>
+              <a:t>Getting Access</a:t>
             </a:r>
           </a:p>
           <a:p>
@@ -23514,7 +21016,7 @@
                 <a:ea typeface="Noto Sans CJK JP"/>
                 <a:cs typeface="Noto Sans"/>
               </a:rPr>
-              <a:t>Gerald Nelson (2002). International Corpus of English.</a:t>
+              <a:t>University of Zurich / ICE teams (n.d.). 2026-10-18参照。</a:t>
             </a:r>
           </a:p>
           <a:p>
@@ -23545,7 +21047,7 @@
                 <a:ea typeface="Noto Sans CJK JP"/>
                 <a:cs typeface="Noto Sans"/>
               </a:rPr>
-              <a:t>休止、話者交替、重なり、言い直しなどの転記規則と、必須・推奨・任意の注釈を定める。</a:t>
+              <a:t>地域別コーパスの申請窓口、配布される構成要素、非商用学術研究の利用条件を案内する。</a:t>
             </a:r>
           </a:p>
           <a:p>
@@ -23577,7 +21079,7 @@
                 <a:cs typeface="Noto Sans"/>
                 <a:hlinkClick r:id="rId3"/>
               </a:rPr>
-              <a:t>https://www.ice-corpora.uzh.ch/en/manuals.html</a:t>
+              <a:t>https://www.ice-corpora.uzh.ch/en/access.html</a:t>
             </a:r>
           </a:p>
         </p:txBody>
@@ -23698,416 +21200,6 @@
       </p:sp>
       <p:sp>
         <p:nvSpPr>
-          <p:cNvPr id="4" name="文献 1: Markup Manual for Written Texts"/>
-          <p:cNvSpPr txBox="1"/>
-          <p:nvPr/>
-        </p:nvSpPr>
-        <p:spPr>
-          <a:xfrm>
-            <a:off x="548640" y="1463040"/>
-            <a:ext cx="8046720" cy="1322213"/>
-          </a:xfrm>
-          <a:prstGeom prst="rect">
-            <a:avLst/>
-          </a:prstGeom>
-          <a:noFill/>
-        </p:spPr>
-        <p:txBody>
-          <a:bodyPr wrap="square" lIns="0" rIns="0" tIns="0" bIns="0">
-            <a:noAutofit/>
-          </a:bodyPr>
-          <a:lstStyle/>
-          <a:p>
-            <a:pPr algn="l">
-              <a:lnSpc>
-                <a:spcPct val="114000"/>
-              </a:lnSpc>
-              <a:spcBef>
-                <a:spcPts val="0"/>
-              </a:spcBef>
-              <a:spcAft>
-                <a:spcPts val="400"/>
-              </a:spcAft>
-              <a:buNone/>
-              <a:defRPr sz="2000" b="0">
-                <a:solidFill>
-                  <a:srgbClr val="303437"/>
-                </a:solidFill>
-                <a:latin typeface="Noto Sans"/>
-              </a:defRPr>
-            </a:pPr>
-            <a:r>
-              <a:rPr sz="2000" b="1" lang="ja-JP" altLang="en-US">
-                <a:solidFill>
-                  <a:srgbClr val="303437"/>
-                </a:solidFill>
-                <a:latin typeface="Noto Sans"/>
-                <a:ea typeface="Noto Sans CJK JP"/>
-                <a:cs typeface="Noto Sans"/>
-              </a:rPr>
-              <a:t>Markup Manual for Written Texts</a:t>
-            </a:r>
-          </a:p>
-          <a:p>
-            <a:pPr algn="l">
-              <a:lnSpc>
-                <a:spcPct val="114000"/>
-              </a:lnSpc>
-              <a:spcBef>
-                <a:spcPts val="0"/>
-              </a:spcBef>
-              <a:spcAft>
-                <a:spcPts val="500"/>
-              </a:spcAft>
-              <a:buNone/>
-              <a:defRPr sz="1350" b="0">
-                <a:solidFill>
-                  <a:srgbClr val="303437"/>
-                </a:solidFill>
-                <a:latin typeface="Noto Sans"/>
-              </a:defRPr>
-            </a:pPr>
-            <a:r>
-              <a:rPr sz="1350" b="0" lang="ja-JP" altLang="en-US">
-                <a:solidFill>
-                  <a:srgbClr val="626669"/>
-                </a:solidFill>
-                <a:latin typeface="Noto Sans"/>
-                <a:ea typeface="Noto Sans CJK JP"/>
-                <a:cs typeface="Noto Sans"/>
-              </a:rPr>
-              <a:t>Gerald Nelson (2002). International Corpus of English.</a:t>
-            </a:r>
-          </a:p>
-          <a:p>
-            <a:pPr algn="l">
-              <a:lnSpc>
-                <a:spcPct val="114000"/>
-              </a:lnSpc>
-              <a:spcBef>
-                <a:spcPts val="0"/>
-              </a:spcBef>
-              <a:spcAft>
-                <a:spcPts val="400"/>
-              </a:spcAft>
-              <a:buNone/>
-              <a:defRPr sz="1850" b="0">
-                <a:solidFill>
-                  <a:srgbClr val="303437"/>
-                </a:solidFill>
-                <a:latin typeface="Noto Sans"/>
-              </a:defRPr>
-            </a:pPr>
-            <a:r>
-              <a:rPr sz="1850" b="0" lang="ja-JP" altLang="en-US">
-                <a:solidFill>
-                  <a:srgbClr val="303437"/>
-                </a:solidFill>
-                <a:latin typeface="Noto Sans"/>
-                <a:ea typeface="Noto Sans CJK JP"/>
-                <a:cs typeface="Noto Sans"/>
-              </a:rPr>
-              <a:t>見出し、段落、組版、引用、非コーパス部分などの記号化を規定する。</a:t>
-            </a:r>
-          </a:p>
-          <a:p>
-            <a:pPr algn="l">
-              <a:lnSpc>
-                <a:spcPct val="114000"/>
-              </a:lnSpc>
-              <a:spcBef>
-                <a:spcPts val="0"/>
-              </a:spcBef>
-              <a:spcAft>
-                <a:spcPts val="0"/>
-              </a:spcAft>
-              <a:buNone/>
-              <a:defRPr sz="1150" b="0">
-                <a:solidFill>
-                  <a:srgbClr val="303437"/>
-                </a:solidFill>
-                <a:latin typeface="Noto Sans"/>
-              </a:defRPr>
-            </a:pPr>
-            <a:r>
-              <a:rPr sz="1150" b="0" lang="ja-JP" altLang="en-US">
-                <a:solidFill>
-                  <a:srgbClr val="626669"/>
-                </a:solidFill>
-                <a:latin typeface="Noto Sans"/>
-                <a:ea typeface="Noto Sans CJK JP"/>
-                <a:cs typeface="Noto Sans"/>
-                <a:hlinkClick r:id="rId2"/>
-              </a:rPr>
-              <a:t>https://www.ice-corpora.uzh.ch/en/manuals.html</a:t>
-            </a:r>
-          </a:p>
-        </p:txBody>
-      </p:sp>
-      <p:sp>
-        <p:nvSpPr>
-          <p:cNvPr id="5" name="文献 2: Holistic Evaluation of Language Models"/>
-          <p:cNvSpPr txBox="1"/>
-          <p:nvPr/>
-        </p:nvSpPr>
-        <p:spPr>
-          <a:xfrm>
-            <a:off x="548640" y="3131693"/>
-            <a:ext cx="8046720" cy="1643637"/>
-          </a:xfrm>
-          <a:prstGeom prst="rect">
-            <a:avLst/>
-          </a:prstGeom>
-          <a:noFill/>
-        </p:spPr>
-        <p:txBody>
-          <a:bodyPr wrap="square" lIns="0" rIns="0" tIns="0" bIns="0">
-            <a:noAutofit/>
-          </a:bodyPr>
-          <a:lstStyle/>
-          <a:p>
-            <a:pPr algn="l">
-              <a:lnSpc>
-                <a:spcPct val="114000"/>
-              </a:lnSpc>
-              <a:spcBef>
-                <a:spcPts val="0"/>
-              </a:spcBef>
-              <a:spcAft>
-                <a:spcPts val="400"/>
-              </a:spcAft>
-              <a:buNone/>
-              <a:defRPr sz="2000" b="0">
-                <a:solidFill>
-                  <a:srgbClr val="303437"/>
-                </a:solidFill>
-                <a:latin typeface="Noto Sans"/>
-              </a:defRPr>
-            </a:pPr>
-            <a:r>
-              <a:rPr sz="2000" b="1" lang="ja-JP" altLang="en-US">
-                <a:solidFill>
-                  <a:srgbClr val="303437"/>
-                </a:solidFill>
-                <a:latin typeface="Noto Sans"/>
-                <a:ea typeface="Noto Sans CJK JP"/>
-                <a:cs typeface="Noto Sans"/>
-              </a:rPr>
-              <a:t>Holistic Evaluation of Language Models</a:t>
-            </a:r>
-          </a:p>
-          <a:p>
-            <a:pPr algn="l">
-              <a:lnSpc>
-                <a:spcPct val="114000"/>
-              </a:lnSpc>
-              <a:spcBef>
-                <a:spcPts val="0"/>
-              </a:spcBef>
-              <a:spcAft>
-                <a:spcPts val="500"/>
-              </a:spcAft>
-              <a:buNone/>
-              <a:defRPr sz="1350" b="0">
-                <a:solidFill>
-                  <a:srgbClr val="303437"/>
-                </a:solidFill>
-                <a:latin typeface="Noto Sans"/>
-              </a:defRPr>
-            </a:pPr>
-            <a:r>
-              <a:rPr sz="1350" b="0" lang="ja-JP" altLang="en-US">
-                <a:solidFill>
-                  <a:srgbClr val="626669"/>
-                </a:solidFill>
-                <a:latin typeface="Noto Sans"/>
-                <a:ea typeface="Noto Sans CJK JP"/>
-                <a:cs typeface="Noto Sans"/>
-              </a:rPr>
-              <a:t>Percy Liang et al. (2023). Transactions on Machine Learning Research.</a:t>
-            </a:r>
-          </a:p>
-          <a:p>
-            <a:pPr algn="l">
-              <a:lnSpc>
-                <a:spcPct val="114000"/>
-              </a:lnSpc>
-              <a:spcBef>
-                <a:spcPts val="0"/>
-              </a:spcBef>
-              <a:spcAft>
-                <a:spcPts val="400"/>
-              </a:spcAft>
-              <a:buNone/>
-              <a:defRPr sz="1850" b="0">
-                <a:solidFill>
-                  <a:srgbClr val="303437"/>
-                </a:solidFill>
-                <a:latin typeface="Noto Sans"/>
-              </a:defRPr>
-            </a:pPr>
-            <a:r>
-              <a:rPr sz="1850" b="0" lang="ja-JP" altLang="en-US">
-                <a:solidFill>
-                  <a:srgbClr val="303437"/>
-                </a:solidFill>
-                <a:latin typeface="Noto Sans"/>
-                <a:ea typeface="Noto Sans CJK JP"/>
-                <a:cs typeface="Noto Sans"/>
-              </a:rPr>
-              <a:t>精度、頑健性、公平性などを共通の枠組みで評価するHELMを提案し、ICEを言語モデル評価に用いる。</a:t>
-            </a:r>
-          </a:p>
-          <a:p>
-            <a:pPr algn="l">
-              <a:lnSpc>
-                <a:spcPct val="114000"/>
-              </a:lnSpc>
-              <a:spcBef>
-                <a:spcPts val="0"/>
-              </a:spcBef>
-              <a:spcAft>
-                <a:spcPts val="0"/>
-              </a:spcAft>
-              <a:buNone/>
-              <a:defRPr sz="1150" b="0">
-                <a:solidFill>
-                  <a:srgbClr val="303437"/>
-                </a:solidFill>
-                <a:latin typeface="Noto Sans"/>
-              </a:defRPr>
-            </a:pPr>
-            <a:r>
-              <a:rPr sz="1150" b="0" lang="ja-JP" altLang="en-US">
-                <a:solidFill>
-                  <a:srgbClr val="626669"/>
-                </a:solidFill>
-                <a:latin typeface="Noto Sans"/>
-                <a:ea typeface="Noto Sans CJK JP"/>
-                <a:cs typeface="Noto Sans"/>
-                <a:hlinkClick r:id="rId3"/>
-              </a:rPr>
-              <a:t>https://arxiv.org/abs/2211.09110</a:t>
-            </a:r>
-          </a:p>
-        </p:txBody>
-      </p:sp>
-    </p:spTree>
-  </p:cSld>
-  <p:clrMapOvr>
-    <a:masterClrMapping/>
-  </p:clrMapOvr>
-</p:sld>
-</file>
-
-<file path=ppt/slides/slide49.xml><?xml version="1.0" encoding="utf-8"?>
-<p:sld xmlns:a="http://schemas.openxmlformats.org/drawingml/2006/main" xmlns:p="http://schemas.openxmlformats.org/presentationml/2006/main" xmlns:r="http://schemas.openxmlformats.org/officeDocument/2006/relationships">
-  <p:cSld>
-    <p:spTree>
-      <p:nvGrpSpPr>
-        <p:cNvPr id="1" name=""/>
-        <p:cNvGrpSpPr/>
-        <p:nvPr/>
-      </p:nvGrpSpPr>
-      <p:grpSpPr/>
-      <p:sp>
-        <p:nvSpPr>
-          <p:cNvPr id="2" name="Title 1"/>
-          <p:cNvSpPr>
-            <a:spLocks noGrp="1"/>
-          </p:cNvSpPr>
-          <p:nvPr>
-            <p:ph type="title"/>
-          </p:nvPr>
-        </p:nvSpPr>
-        <p:spPr>
-          <a:xfrm>
-            <a:off x="468172" y="650138"/>
-            <a:ext cx="8206740" cy="616305"/>
-          </a:xfrm>
-        </p:spPr>
-        <p:txBody>
-          <a:bodyPr wrap="square" lIns="0" rIns="0" tIns="0" bIns="0">
-            <a:noAutofit/>
-          </a:bodyPr>
-          <a:lstStyle/>
-          <a:p>
-            <a:pPr algn="l">
-              <a:lnSpc>
-                <a:spcPct val="110000"/>
-              </a:lnSpc>
-              <a:buNone/>
-              <a:defRPr sz="2800" b="0">
-                <a:solidFill>
-                  <a:srgbClr val="303437"/>
-                </a:solidFill>
-                <a:latin typeface="Noto Sans"/>
-              </a:defRPr>
-            </a:pPr>
-            <a:r>
-              <a:rPr sz="2800" b="1" lang="ja-JP" altLang="en-US">
-                <a:solidFill>
-                  <a:srgbClr val="303437"/>
-                </a:solidFill>
-                <a:latin typeface="Noto Sans"/>
-                <a:ea typeface="Noto Sans CJK JP"/>
-                <a:cs typeface="Noto Sans"/>
-              </a:rPr>
-              <a:t>参考文献</a:t>
-            </a:r>
-          </a:p>
-        </p:txBody>
-      </p:sp>
-      <p:sp>
-        <p:nvSpPr>
-          <p:cNvPr id="3" name="Title 2"/>
-          <p:cNvSpPr>
-            <a:spLocks noGrp="1"/>
-          </p:cNvSpPr>
-          <p:nvPr>
-            <p:ph type="title" idx="2"/>
-          </p:nvPr>
-        </p:nvSpPr>
-        <p:spPr>
-          <a:xfrm>
-            <a:off x="75895" y="0"/>
-            <a:ext cx="8115300" cy="480060"/>
-          </a:xfrm>
-        </p:spPr>
-        <p:txBody>
-          <a:bodyPr wrap="square" lIns="0" rIns="0" tIns="0" bIns="0" anchor="ctr">
-            <a:noAutofit/>
-          </a:bodyPr>
-          <a:lstStyle/>
-          <a:p>
-            <a:pPr algn="l">
-              <a:lnSpc>
-                <a:spcPct val="110000"/>
-              </a:lnSpc>
-              <a:buNone/>
-              <a:defRPr sz="1400" b="0">
-                <a:solidFill>
-                  <a:srgbClr val="303437"/>
-                </a:solidFill>
-                <a:latin typeface="Noto Sans"/>
-              </a:defRPr>
-            </a:pPr>
-            <a:r>
-              <a:rPr sz="1400" b="1" lang="ja-JP" altLang="en-US">
-                <a:solidFill>
-                  <a:srgbClr val="FFFEF8"/>
-                </a:solidFill>
-                <a:latin typeface="Noto Sans"/>
-                <a:ea typeface="Noto Sans CJK JP"/>
-                <a:cs typeface="Noto Sans"/>
-              </a:rPr>
-              <a:t>Appendix: 3. 研究と参考文献</a:t>
-            </a:r>
-          </a:p>
-        </p:txBody>
-      </p:sp>
-      <p:sp>
-        <p:nvSpPr>
           <p:cNvPr id="4" name="文献 1: ICEScenario"/>
           <p:cNvSpPr txBox="1"/>
           <p:nvPr/>
@@ -24217,7 +21309,7 @@
                 <a:ea typeface="Noto Sans CJK JP"/>
                 <a:cs typeface="Noto Sans"/>
               </a:rPr>
-              <a:t>地域別ファイルの読み込み、タグ前処理、カテゴリとメタデータの選別を実装する。</a:t>
+              <a:t>本資料で引用した、米国の硬貨収集案内文の公開掲載元。</a:t>
             </a:r>
           </a:p>
           <a:p>
@@ -24334,7 +21426,7 @@
                 <a:ea typeface="Noto Sans CJK JP"/>
                 <a:cs typeface="Noto Sans"/>
               </a:rPr>
-              <a:t>Stanford CRFM (2023). Classic v0.4.0, released 2023-11-17.</a:t>
+              <a:t>Stanford CRFM (2023). Classic v0.4.0.</a:t>
             </a:r>
           </a:p>
           <a:p>
@@ -24365,7 +21457,7 @@
                 <a:ea typeface="Noto Sans CJK JP"/>
                 <a:cs typeface="Noto Sans"/>
               </a:rPr>
-              <a:t>公開runの地域・性別条件と、言語モデルが本文に与えた確率に基づく評価値を掲載する。</a:t>
+              <a:t>本資料で引用した、インドの話し言葉・書き言葉の公開掲載元。</a:t>
             </a:r>
           </a:p>
           <a:p>
@@ -24397,7 +21489,7 @@
                 <a:cs typeface="Noto Sans"/>
                 <a:hlinkClick r:id="rId3"/>
               </a:rPr>
-              <a:t>https://crfm.stanford.edu/helm/classic/v0.4.0/#/groups/ice</a:t>
+              <a:t>https://crfm.stanford.edu/helm/classic/v0.4.0/#/runs/ice:subset=ind,model=together_opt-175b</a:t>
             </a:r>
           </a:p>
         </p:txBody>
@@ -24576,7 +21668,7 @@
                 <a:ea typeface="Noto Sans CJK JP"/>
                 <a:cs typeface="Noto Sans"/>
               </a:rPr>
-              <a:t>質問と正解の組ではなく、実際に使われた話し言葉・書き言葉のテキストが基本単位になる。</a:t>
+              <a:t>実際に使われた話し言葉・書き言葉のテキストを読み、語句の用例や発話のやり取り、文章の構成を調べられる。</a:t>
             </a:r>
           </a:p>
         </p:txBody>
@@ -24756,7 +21848,7 @@
                 <a:ea typeface="Noto Sans CJK JP"/>
                 <a:cs typeface="Noto Sans"/>
               </a:rPr>
-              <a:t>HELMでは、本文に付けた確率を採点する</a:t>
+              <a:t>公開された短い引用から、英語の違いを読む</a:t>
             </a:r>
           </a:p>
         </p:txBody>
@@ -24809,7 +21901,7 @@
                 <a:ea typeface="Noto Sans CJK JP"/>
                 <a:cs typeface="Noto Sans"/>
               </a:rPr>
-              <a:t>言語モデルにテキストを与え、各語や記号にどれだけ高い確率を付けるかを測る。本文を予測しやすいモデルほど、よい得点になる。</a:t>
+              <a:t>本資料では、公開されているインドの英語12件と米国の書き言葉1件を短く引用し、話し言葉と書き言葉の特徴を読む。</a:t>
             </a:r>
           </a:p>
           <a:p>
@@ -24839,7 +21931,37 @@
                 <a:ea typeface="Noto Sans CJK JP"/>
                 <a:cs typeface="Noto Sans"/>
               </a:rPr>
-              <a:t>以下の13例は、HELMの公開評価に含まれるインドの英語12件と、公式実装に掲載された米国の英語1件からの短い抜粋。実際の評価には、抜粋元のテキスト全体を使う。</a:t>
+              <a:t>インドの引用には会話、講演、ニュース、論考などが含まれる。米国の引用は、硬貨収集の案内文である。</a:t>
+            </a:r>
+          </a:p>
+          <a:p>
+            <a:pPr marL="457200" indent="-355600">
+              <a:lnSpc>
+                <a:spcPts val="2618"/>
+              </a:lnSpc>
+              <a:spcAft>
+                <a:spcPts val="700"/>
+              </a:spcAft>
+              <a:buSzPct val="60455"/>
+              <a:buFont typeface="Noto Sans CJK JP"/>
+              <a:buChar char="●"/>
+              <a:defRPr sz="2200" b="0">
+                <a:solidFill>
+                  <a:srgbClr val="303437"/>
+                </a:solidFill>
+                <a:latin typeface="Noto Sans"/>
+              </a:defRPr>
+            </a:pPr>
+            <a:r>
+              <a:rPr sz="2200" b="0" lang="ja-JP" altLang="en-US">
+                <a:solidFill>
+                  <a:srgbClr val="303437"/>
+                </a:solidFill>
+                <a:latin typeface="Noto Sans"/>
+                <a:ea typeface="Noto Sans CJK JP"/>
+                <a:cs typeface="Noto Sans"/>
+              </a:rPr>
+              <a:t>世界の英語を比べるための全体の構成は、地域ごとの収集計画と、共通のジャンル設計から確かめられる。</a:t>
             </a:r>
           </a:p>
         </p:txBody>

</xml_diff>